<commit_message>
Add documented data-cleaning phase and reusable cleaning toolkit
</commit_message>
<xml_diff>
--- a/Nepal_Climate_Risk_Deck.pptx
+++ b/Nepal_Climate_Risk_Deck.pptx
@@ -124,7 +124,7 @@
   <p:extLst>
     <p:ext uri="{521415D9-36F7-43E2-AB2F-B90AF26B5E84}">
       <p14:sectionLst xmlns:p14="http://schemas.microsoft.com/office/powerpoint/2010/main">
-        <p14:section name="Introduction" id="{80d2bff5-f984-f08f-034b-2f1445f88dcd}">
+        <p14:section name="Introduction" id="{ce37ca29-1dfe-9d75-f6a6-788dc7a284a0}">
           <p14:sldIdLst>
             <p14:sldId id="256"/>
             <p14:sldId id="257"/>
@@ -132,25 +132,25 @@
             <p14:sldId id="259"/>
           </p14:sldIdLst>
         </p14:section>
-        <p14:section name="Climate" id="{c5b17810-0e9c-ee01-2be3-c518ba53b42c}">
+        <p14:section name="Climate" id="{3a428108-9431-001f-5c42-7211049cb7f3}">
           <p14:sldIdLst>
             <p14:sldId id="260"/>
             <p14:sldId id="261"/>
           </p14:sldIdLst>
         </p14:section>
-        <p14:section name="Terrain and exposure" id="{eca03eff-9d7b-ae4d-ce9e-d5d664e2b7b8}">
+        <p14:section name="Terrain and exposure" id="{44371865-cd23-aa1e-8736-f2d9ff9f1d8e}">
           <p14:sldIdLst>
             <p14:sldId id="262"/>
             <p14:sldId id="263"/>
           </p14:sldIdLst>
         </p14:section>
-        <p14:section name="Risk index" id="{c8cdc2ea-dc03-2edd-84eb-6cb94696d6bb}">
+        <p14:section name="Risk index" id="{4feb929a-589c-039e-e18e-807e463b7918}">
           <p14:sldIdLst>
             <p14:sldId id="264"/>
             <p14:sldId id="265"/>
           </p14:sldIdLst>
         </p14:section>
-        <p14:section name="Validation" id="{c8b0f6fd-6c12-2c4f-bfdb-7f7de16d6f2f}">
+        <p14:section name="Validation" id="{1cece516-9b03-f2ea-5696-554ace6e64ad}">
           <p14:sldIdLst>
             <p14:sldId id="266"/>
             <p14:sldId id="267"/>
@@ -158,14 +158,14 @@
             <p14:sldId id="269"/>
           </p14:sldIdLst>
         </p14:section>
-        <p14:section name="Recommendation" id="{bf734b59-ae24-19cc-5f21-0798c1d46048}">
+        <p14:section name="Recommendation" id="{78042e2f-3b0b-f70c-5838-d2863aace24e}">
           <p14:sldIdLst>
             <p14:sldId id="270"/>
             <p14:sldId id="271"/>
             <p14:sldId id="272"/>
           </p14:sldIdLst>
         </p14:section>
-        <p14:section name="Appendix" id="{f6b358b1-520e-2f78-558b-17e1ac49bdb0}">
+        <p14:section name="Appendix" id="{468f5f02-91c0-bd81-c669-a69424e4de50}">
           <p14:sldIdLst>
             <p14:sldId id="273"/>
           </p14:sldIdLst>
@@ -3748,10 +3748,10 @@
                 <c:formatCode>General</c:formatCode>
                 <c:ptCount val="4"/>
                 <c:pt idx="0">
-                  <c:v>-0.09</c:v>
+                  <c:v>-0.08</c:v>
                 </c:pt>
                 <c:pt idx="1">
-                  <c:v>-0.27</c:v>
+                  <c:v>-0.26</c:v>
                 </c:pt>
                 <c:pt idx="2">
                   <c:v>0.32</c:v>
@@ -4059,43 +4059,43 @@
                 <c:formatCode>General</c:formatCode>
                 <c:ptCount val="16"/>
                 <c:pt idx="0">
-                  <c:v>481</c:v>
+                  <c:v>464</c:v>
                 </c:pt>
                 <c:pt idx="1">
-                  <c:v>284</c:v>
+                  <c:v>268</c:v>
                 </c:pt>
                 <c:pt idx="2">
-                  <c:v>426</c:v>
+                  <c:v>420</c:v>
                 </c:pt>
                 <c:pt idx="3">
-                  <c:v>163</c:v>
+                  <c:v>162</c:v>
                 </c:pt>
                 <c:pt idx="4">
-                  <c:v>95</c:v>
+                  <c:v>80</c:v>
                 </c:pt>
                 <c:pt idx="5">
-                  <c:v>576</c:v>
+                  <c:v>561</c:v>
                 </c:pt>
                 <c:pt idx="6">
-                  <c:v>603</c:v>
+                  <c:v>569</c:v>
                 </c:pt>
                 <c:pt idx="7">
-                  <c:v>647</c:v>
+                  <c:v>645</c:v>
                 </c:pt>
                 <c:pt idx="8">
-                  <c:v>764</c:v>
+                  <c:v>762</c:v>
                 </c:pt>
                 <c:pt idx="9">
                   <c:v>943</c:v>
                 </c:pt>
                 <c:pt idx="10">
-                  <c:v>852</c:v>
+                  <c:v>851</c:v>
                 </c:pt>
                 <c:pt idx="11">
                   <c:v>554</c:v>
                 </c:pt>
                 <c:pt idx="12">
-                  <c:v>832</c:v>
+                  <c:v>825</c:v>
                 </c:pt>
                 <c:pt idx="13">
                   <c:v>0</c:v>
@@ -4259,13 +4259,13 @@
                   <c:v>0</c:v>
                 </c:pt>
                 <c:pt idx="13">
-                  <c:v>1976</c:v>
+                  <c:v>1964</c:v>
                 </c:pt>
                 <c:pt idx="14">
-                  <c:v>1370</c:v>
+                  <c:v>1362</c:v>
                 </c:pt>
                 <c:pt idx="15">
-                  <c:v>1952</c:v>
+                  <c:v>1911</c:v>
                 </c:pt>
               </c:numCache>
             </c:numRef>
@@ -5260,7 +5260,7 @@
           <a:p>
             <a:r>
               <a:rPr lang="en-US" dirty="0"/>
-              <a:t>This is the most important part. Until now, our index is just a hypothesis. We tested it against 12,518 disasters recorded by Nepal's BIPAD system since 2011. The landslide index works: a correlation of 0.53 with recorded landslides, and terrain ruggedness alone explains about half the difference between districts. The combined index is moderate, around 0.4, but that comes almost entirely from its landslide part. The flood index fails, at only 0.23. We did not re-tune the model to make this number look better; that would be cheating. Instead we found the reason.</a:t>
+              <a:t>This is the most important part. Until now, our index is just a hypothesis. We tested it against 12,341 disasters recorded by Nepal's BIPAD system since 2011, after removing duplicate records. The landslide index works: a correlation of 0.52 with recorded landslides, and terrain ruggedness alone explains about half the difference between districts. The combined index is moderate, around 0.4, but that comes almost entirely from its landslide part. The flood index fails, at only 0.24. We did not re-tune the model to make this number look better; that would be cheating. Instead we found the reason.</a:t>
             </a:r>
             <a:endParaRPr lang="en-US" dirty="0"/>
           </a:p>
@@ -5348,7 +5348,7 @@
           <a:p>
             <a:r>
               <a:rPr lang="en-US" dirty="0"/>
-              <a:t>Why do floods fail? Look at where floods are actually recorded: Jhapa, Morang, Sunsari, Kailali. Flat southern lowlands, plus Kathmandu. Flood counts go down with rugged terrain and up with population and roads. Our flood hazard score has essentially no link at all. The explanation is a missing variable: we measure mountain rivers and rainfall, but lowland floods happen where rivers spread across flat, crowded plains, and the dataset has nothing on floodplains. Part of it is also reporting: floods get recorded where people and roads are. The brief tells us to explain weak results, not hide them, and that's what we've done.</a:t>
+              <a:t>Why do floods fail? Look at where floods are actually recorded: Jhapa, Morang, Sunsari, Kailali, and Kathmandu. Flat southern lowlands, plus Kathmandu. Flood counts go down with rugged terrain and up with population and roads. Our flood hazard score has essentially no link at all. The explanation is a missing variable: we measure mountain rivers and rainfall, but lowland floods happen where rivers spread across flat, crowded plains, and the dataset has nothing on floodplains. Part of it is also reporting: floods get recorded where people and roads are. The brief tells us to explain weak results, not hide them, and that's what we've done.</a:t>
             </a:r>
             <a:endParaRPr lang="en-US" dirty="0"/>
           </a:p>
@@ -8065,7 +8065,7 @@
                   <a:schemeClr val="tx2"/>
                 </a:solidFill>
               </a:rPr>
-              <a:t>Tested against 12,518 real disasters</a:t>
+              <a:t>Tested against 12,341 real disasters</a:t>
             </a:r>
             <a:endParaRPr lang="en-US" sz="3400" dirty="0"/>
           </a:p>
@@ -8380,7 +8380,7 @@
                 <a:ea typeface="Cambria" pitchFamily="34" charset="-122"/>
                 <a:cs typeface="Cambria" pitchFamily="34" charset="-120"/>
               </a:rPr>
-              <a:t>ρ = 0.53</a:t>
+              <a:t>ρ = 0.52</a:t>
             </a:r>
             <a:endParaRPr lang="en-US" sz="4000" dirty="0"/>
           </a:p>
@@ -8488,7 +8488,7 @@
                   <a:schemeClr val="tx1"/>
                 </a:solidFill>
               </a:rPr>
-              <a:t>Terrain ruggedness is the strongest driver; explains about half the variation (R² = 0.50)</a:t>
+              <a:t>Terrain ruggedness is the strongest driver; explains about half the variation (R² = 0.49)</a:t>
             </a:r>
             <a:endParaRPr lang="en-US" sz="1300" dirty="0"/>
           </a:p>
@@ -8665,7 +8665,7 @@
                   <a:srgbClr val="5B6B75"/>
                 </a:solidFill>
               </a:rPr>
-              <a:t>vs all events (0.42 vs deaths)</a:t>
+              <a:t>vs all events (0.43 vs deaths)</a:t>
             </a:r>
             <a:endParaRPr lang="en-US" sz="1300" dirty="0"/>
           </a:p>
@@ -8878,7 +8878,7 @@
                 <a:ea typeface="Cambria" pitchFamily="34" charset="-122"/>
                 <a:cs typeface="Cambria" pitchFamily="34" charset="-120"/>
               </a:rPr>
-              <a:t>ρ = 0.23</a:t>
+              <a:t>ρ = 0.24</a:t>
             </a:r>
             <a:endParaRPr lang="en-US" sz="4000" dirty="0"/>
           </a:p>
@@ -9325,7 +9325,7 @@
                   <a:schemeClr val="accent1"/>
                 </a:solidFill>
               </a:rPr>
-              <a:t>Jhapa, Morang, Sunsari, Kathmandu, Kailali</a:t>
+              <a:t>Jhapa, Morang, Kathmandu, Sunsari, Kailali</a:t>
             </a:r>
             <a:endParaRPr lang="en-US" sz="1600" dirty="0"/>
           </a:p>
@@ -10143,7 +10143,7 @@
                           <a:ea typeface="Calibri" pitchFamily="34" charset="-122"/>
                           <a:cs typeface="Calibri" pitchFamily="34" charset="-120"/>
                         </a:rPr>
-                        <a:t>0.23</a:t>
+                        <a:t>0.24</a:t>
                       </a:r>
                       <a:endParaRPr lang="en-US" sz="1500" dirty="0">
                         <a:latin typeface="Calibri" charset="0"/>
@@ -10417,7 +10417,7 @@
                           <a:ea typeface="Calibri" pitchFamily="34" charset="-122"/>
                           <a:cs typeface="Calibri" pitchFamily="34" charset="-120"/>
                         </a:rPr>
-                        <a:t>0.53</a:t>
+                        <a:t>0.52</a:t>
                       </a:r>
                       <a:endParaRPr lang="en-US" sz="1500" dirty="0">
                         <a:latin typeface="Calibri" charset="0"/>
@@ -10614,7 +10614,7 @@
                   <a:schemeClr val="tx1"/>
                 </a:solidFill>
               </a:rPr>
-              <a:t>Their district counts are unrelated (ρ = −0.14). One number can't rank both.</a:t>
+              <a:t>Their district counts are unrelated (ρ = −0.13). One number can't rank both.</a:t>
             </a:r>
             <a:endParaRPr lang="en-US" sz="1300" dirty="0"/>
           </a:p>
@@ -10725,7 +10725,7 @@
                   <a:schemeClr val="tx1"/>
                 </a:solidFill>
               </a:rPr>
-              <a:t>Landslide 0.53 vs combined 0.47; flood 0.23 vs combined 0.12.</a:t>
+              <a:t>Landslide 0.52 vs combined 0.47; flood 0.24 vs combined 0.12.</a:t>
             </a:r>
             <a:endParaRPr lang="en-US" sz="1300" dirty="0"/>
           </a:p>
@@ -11230,7 +11230,7 @@
                   <a:schemeClr val="tx1"/>
                 </a:solidFill>
               </a:rPr>
-              <a:t>Events quadrupled after 2023 while deaths per event fell from 0.51 to 0.04: many more minor incidents logged</a:t>
+              <a:t>Events quadrupled after 2023 while deaths per event fell from 0.52 to 0.04: many more minor incidents logged</a:t>
             </a:r>
             <a:endParaRPr lang="en-US" sz="1300" dirty="0"/>
           </a:p>
@@ -12682,7 +12682,7 @@
                           <a:ea typeface="Calibri" pitchFamily="34" charset="-122"/>
                           <a:cs typeface="Calibri" pitchFamily="34" charset="-120"/>
                         </a:rPr>
-                        <a:t>Jhapa, Morang, Sunsari, Kathmandu, Kailali</a:t>
+                        <a:t>Jhapa, Morang, Kathmandu, Sunsari, Kailali</a:t>
                       </a:r>
                       <a:endParaRPr lang="en-US" sz="1200" dirty="0">
                         <a:latin typeface="Calibri" charset="0"/>
@@ -13730,7 +13730,7 @@
                           <a:ea typeface="Calibri" pitchFamily="34" charset="-122"/>
                           <a:cs typeface="Calibri" pitchFamily="34" charset="-120"/>
                         </a:rPr>
-                        <a:t>National, piloted in: Surkhet, Parasi, Parbat, Nawalpur, Bardiya, Mugu, Salyan, Rukum East, Ramechhap, Gorkha</a:t>
+                        <a:t>National, piloted in: Surkhet, Parasi, Parbat, Bardiya, Nawalpur, Mugu, Salyan, Ramechhap, Rukum East, Doti</a:t>
                       </a:r>
                       <a:endParaRPr lang="en-US" sz="1200" dirty="0">
                         <a:latin typeface="Calibri" charset="0"/>
@@ -16561,7 +16561,7 @@
                   <a:schemeClr val="tx1"/>
                 </a:solidFill>
               </a:rPr>
-              <a:t>Compare scores with 12,518 recorded disasters, 2011-2026</a:t>
+              <a:t>Compare scores with 12,341 recorded disasters (after cleaning), 2011-2026</a:t>
             </a:r>
             <a:endParaRPr lang="en-US" sz="1400" dirty="0"/>
           </a:p>
@@ -17301,7 +17301,7 @@
                   <a:srgbClr val="5B6B75"/>
                 </a:solidFill>
               </a:rPr>
-              <a:t>12,518 floods, landslides and rain events, 2011-2026</a:t>
+              <a:t>12,341 floods, landslides and rain events after removing duplicates</a:t>
             </a:r>
             <a:endParaRPr lang="en-US" sz="1300" dirty="0"/>
           </a:p>

</xml_diff>

<commit_message>
Restyle slide deck to match the app's design system
</commit_message>
<xml_diff>
--- a/Nepal_Climate_Risk_Deck.pptx
+++ b/Nepal_Climate_Risk_Deck.pptx
@@ -124,7 +124,7 @@
   <p:extLst>
     <p:ext uri="{521415D9-36F7-43E2-AB2F-B90AF26B5E84}">
       <p14:sectionLst xmlns:p14="http://schemas.microsoft.com/office/powerpoint/2010/main">
-        <p14:section name="Introduction" id="{ce37ca29-1dfe-9d75-f6a6-788dc7a284a0}">
+        <p14:section name="Introduction" id="{a912e774-3daa-c07a-d4bf-d7893a3b5be2}">
           <p14:sldIdLst>
             <p14:sldId id="256"/>
             <p14:sldId id="257"/>
@@ -132,25 +132,25 @@
             <p14:sldId id="259"/>
           </p14:sldIdLst>
         </p14:section>
-        <p14:section name="Climate" id="{3a428108-9431-001f-5c42-7211049cb7f3}">
+        <p14:section name="Climate" id="{73d39a26-debd-5a6f-292b-e08e36241484}">
           <p14:sldIdLst>
             <p14:sldId id="260"/>
             <p14:sldId id="261"/>
           </p14:sldIdLst>
         </p14:section>
-        <p14:section name="Terrain and exposure" id="{44371865-cd23-aa1e-8736-f2d9ff9f1d8e}">
+        <p14:section name="Terrain and exposure" id="{9b06eff9-6ce6-8ecf-475f-fb986c58ffb5}">
           <p14:sldIdLst>
             <p14:sldId id="262"/>
             <p14:sldId id="263"/>
           </p14:sldIdLst>
         </p14:section>
-        <p14:section name="Risk index" id="{4feb929a-589c-039e-e18e-807e463b7918}">
+        <p14:section name="Risk index" id="{06cf5988-3bd4-b1d4-c754-07885571d984}">
           <p14:sldIdLst>
             <p14:sldId id="264"/>
             <p14:sldId id="265"/>
           </p14:sldIdLst>
         </p14:section>
-        <p14:section name="Validation" id="{1cece516-9b03-f2ea-5696-554ace6e64ad}">
+        <p14:section name="Validation" id="{ff8f6ea5-b859-cd66-fcc4-1cfa37dd464f}">
           <p14:sldIdLst>
             <p14:sldId id="266"/>
             <p14:sldId id="267"/>
@@ -158,14 +158,14 @@
             <p14:sldId id="269"/>
           </p14:sldIdLst>
         </p14:section>
-        <p14:section name="Recommendation" id="{78042e2f-3b0b-f70c-5838-d2863aace24e}">
+        <p14:section name="Recommendation" id="{ad6fdf84-a44d-74b6-39cb-1d5bdd7d62f1}">
           <p14:sldIdLst>
             <p14:sldId id="270"/>
             <p14:sldId id="271"/>
             <p14:sldId id="272"/>
           </p14:sldIdLst>
         </p14:section>
-        <p14:section name="Appendix" id="{468f5f02-91c0-bd81-c669-a69424e4de50}">
+        <p14:section name="Appendix" id="{026d652f-81fc-b2a3-f5fc-8cf79e9c0851}">
           <p14:sldIdLst>
             <p14:sldId id="273"/>
           </p14:sldIdLst>
@@ -234,11 +234,11 @@
           </c:tx>
           <c:spPr>
             <a:solidFill>
-              <a:srgbClr val="6B8496"/>
+              <a:srgbClr val="3B5BA9"/>
             </a:solidFill>
-            <a:ln w="31750" cap="flat">
+            <a:ln w="25400" cap="flat">
               <a:solidFill>
-                <a:srgbClr val="6B8496"/>
+                <a:srgbClr val="3B5BA9"/>
               </a:solidFill>
               <a:prstDash val="solid"/>
               <a:round/>
@@ -275,11 +275,11 @@
             <c:size val="7"/>
             <c:spPr>
               <a:solidFill>
-                <a:srgbClr val="6B8496"/>
+                <a:srgbClr val="3B5BA9"/>
               </a:solidFill>
               <a:ln w="9525" cap="flat">
                 <a:solidFill>
-                  <a:srgbClr val="6B8496"/>
+                  <a:srgbClr val="3B5BA9"/>
                 </a:solidFill>
                 <a:prstDash val="solid"/>
                 <a:round/>
@@ -487,13 +487,13 @@
           </c:tx>
           <c:spPr>
             <a:solidFill>
-              <a:srgbClr val="C8553D"/>
+              <a:srgbClr val="B8243B"/>
             </a:solidFill>
-            <a:ln w="31750" cap="flat">
+            <a:ln w="25400" cap="flat">
               <a:solidFill>
-                <a:srgbClr val="C8553D"/>
+                <a:srgbClr val="B8243B"/>
               </a:solidFill>
-              <a:prstDash val="solid"/>
+              <a:prstDash val="dash"/>
               <a:round/>
             </a:ln>
             <a:effectLst/>
@@ -528,11 +528,11 @@
             <c:size val="6"/>
             <c:spPr>
               <a:solidFill>
-                <a:srgbClr val="C8553D"/>
+                <a:srgbClr val="B8243B"/>
               </a:solidFill>
               <a:ln w="9525" cap="flat">
                 <a:solidFill>
-                  <a:srgbClr val="C8553D"/>
+                  <a:srgbClr val="B8243B"/>
                 </a:solidFill>
                 <a:prstDash val="solid"/>
                 <a:round/>
@@ -736,7 +736,7 @@
         <c:spPr>
           <a:ln w="12700" cap="flat">
             <a:solidFill>
-              <a:srgbClr val="DCE3E7"/>
+              <a:srgbClr val="E3E7EB"/>
             </a:solidFill>
             <a:prstDash val="solid"/>
             <a:round/>
@@ -749,7 +749,7 @@
             <a:pPr>
               <a:defRPr sz="1100" b="0" i="0" u="none" strike="noStrike">
                 <a:solidFill>
-                  <a:srgbClr val="5B6B75"/>
+                  <a:srgbClr val="76838F"/>
                 </a:solidFill>
                 <a:latin typeface="+mn-lt"/>
               </a:defRPr>
@@ -775,7 +775,7 @@
           <c:spPr>
             <a:ln w="9525" cap="flat">
               <a:solidFill>
-                <a:srgbClr val="DCE3E7"/>
+                <a:srgbClr val="E3E7EB"/>
               </a:solidFill>
               <a:prstDash val="solid"/>
               <a:round/>
@@ -800,7 +800,7 @@
             <a:pPr>
               <a:defRPr sz="1100" b="0" i="0" u="none" strike="noStrike">
                 <a:solidFill>
-                  <a:srgbClr val="5B6B75"/>
+                  <a:srgbClr val="76838F"/>
                 </a:solidFill>
                 <a:latin typeface="+mn-lt"/>
               </a:defRPr>
@@ -830,7 +830,7 @@
           <a:pPr>
             <a:defRPr sz="1100">
               <a:solidFill>
-                <a:srgbClr val="5B6B75"/>
+                <a:srgbClr val="76838F"/>
               </a:solidFill>
               <a:latin typeface="+mn-lt"/>
               <a:cs typeface="+mn-lt"/>
@@ -913,7 +913,7 @@
           </c:tx>
           <c:spPr>
             <a:solidFill>
-              <a:srgbClr val="B7C4CC"/>
+              <a:srgbClr val="C9D1D9"/>
             </a:solidFill>
             <a:effectLst/>
           </c:spPr>
@@ -1110,7 +1110,7 @@
           </c:tx>
           <c:spPr>
             <a:solidFill>
-              <a:srgbClr val="C8553D"/>
+              <a:srgbClr val="3B5BA9"/>
             </a:solidFill>
             <a:effectLst/>
           </c:spPr>
@@ -1335,7 +1335,7 @@
         <c:spPr>
           <a:ln w="12700" cap="flat">
             <a:solidFill>
-              <a:srgbClr val="DCE3E7"/>
+              <a:srgbClr val="E3E7EB"/>
             </a:solidFill>
             <a:prstDash val="solid"/>
             <a:round/>
@@ -1348,7 +1348,7 @@
             <a:pPr>
               <a:defRPr sz="1100" b="0" i="0" u="none" strike="noStrike">
                 <a:solidFill>
-                  <a:srgbClr val="5B6B75"/>
+                  <a:srgbClr val="76838F"/>
                 </a:solidFill>
                 <a:latin typeface="+mn-lt"/>
               </a:defRPr>
@@ -1373,7 +1373,7 @@
           <c:spPr>
             <a:ln w="9525" cap="flat">
               <a:solidFill>
-                <a:srgbClr val="DCE3E7"/>
+                <a:srgbClr val="E3E7EB"/>
               </a:solidFill>
               <a:prstDash val="solid"/>
               <a:round/>
@@ -1398,7 +1398,7 @@
             <a:pPr>
               <a:defRPr sz="1100" b="0" i="0" u="none" strike="noStrike">
                 <a:solidFill>
-                  <a:srgbClr val="5B6B75"/>
+                  <a:srgbClr val="76838F"/>
                 </a:solidFill>
                 <a:latin typeface="+mn-lt"/>
               </a:defRPr>
@@ -1428,7 +1428,7 @@
           <a:pPr>
             <a:defRPr sz="1100">
               <a:solidFill>
-                <a:srgbClr val="5B6B75"/>
+                <a:srgbClr val="76838F"/>
               </a:solidFill>
               <a:latin typeface="+mn-lt"/>
               <a:cs typeface="+mn-lt"/>
@@ -1510,7 +1510,7 @@
           </c:tx>
           <c:spPr>
             <a:solidFill>
-              <a:srgbClr val="B7C4CC"/>
+              <a:srgbClr val="C9D1D9"/>
             </a:solidFill>
             <a:ln>
               <a:noFill/>
@@ -1522,11 +1522,11 @@
             <c:size val="9"/>
             <c:spPr>
               <a:solidFill>
-                <a:srgbClr val="B7C4CC"/>
+                <a:srgbClr val="C9D1D9"/>
               </a:solidFill>
               <a:ln w="9525" cap="flat">
                 <a:solidFill>
-                  <a:srgbClr val="B7C4CC"/>
+                  <a:srgbClr val="C9D1D9"/>
                 </a:solidFill>
                 <a:prstDash val="solid"/>
                 <a:round/>
@@ -2032,7 +2032,7 @@
           </c:tx>
           <c:spPr>
             <a:solidFill>
-              <a:srgbClr val="C8553D"/>
+              <a:srgbClr val="B8243B"/>
             </a:solidFill>
             <a:ln>
               <a:noFill/>
@@ -2044,11 +2044,11 @@
             <c:size val="9"/>
             <c:spPr>
               <a:solidFill>
-                <a:srgbClr val="C8553D"/>
+                <a:srgbClr val="B8243B"/>
               </a:solidFill>
               <a:ln w="9525" cap="flat">
                 <a:solidFill>
-                  <a:srgbClr val="C8553D"/>
+                  <a:srgbClr val="B8243B"/>
                 </a:solidFill>
                 <a:prstDash val="solid"/>
                 <a:round/>
@@ -2582,7 +2582,7 @@
                 <a:pPr>
                   <a:defRPr sz="1200" b="0" i="0" u="none" strike="noStrike">
                     <a:solidFill>
-                      <a:srgbClr val="5B6B75"/>
+                      <a:srgbClr val="76838F"/>
                     </a:solidFill>
                     <a:latin typeface="+mn-lt"/>
                   </a:defRPr>
@@ -2590,7 +2590,7 @@
                 <a:r>
                   <a:rPr sz="1200" b="0" i="0" u="none" strike="noStrike">
                     <a:solidFill>
-                      <a:srgbClr val="5B6B75"/>
+                      <a:srgbClr val="76838F"/>
                     </a:solidFill>
                     <a:latin typeface="+mn-lt"/>
                   </a:rPr>
@@ -2609,7 +2609,7 @@
         <c:spPr>
           <a:ln w="12700" cap="flat">
             <a:solidFill>
-              <a:srgbClr val="DCE3E7"/>
+              <a:srgbClr val="E3E7EB"/>
             </a:solidFill>
             <a:prstDash val="solid"/>
             <a:round/>
@@ -2622,7 +2622,7 @@
             <a:pPr>
               <a:defRPr sz="1100" b="0" i="0" u="none" strike="noStrike">
                 <a:solidFill>
-                  <a:srgbClr val="5B6B75"/>
+                  <a:srgbClr val="76838F"/>
                 </a:solidFill>
                 <a:latin typeface="+mn-lt"/>
               </a:defRPr>
@@ -2649,7 +2649,7 @@
           <c:spPr>
             <a:ln w="9525" cap="flat">
               <a:solidFill>
-                <a:srgbClr val="DCE3E7"/>
+                <a:srgbClr val="E3E7EB"/>
               </a:solidFill>
               <a:prstDash val="solid"/>
               <a:round/>
@@ -2665,7 +2665,7 @@
                 <a:pPr>
                   <a:defRPr sz="1200" b="0" i="0" u="none" strike="noStrike">
                     <a:solidFill>
-                      <a:srgbClr val="5B6B75"/>
+                      <a:srgbClr val="76838F"/>
                     </a:solidFill>
                     <a:latin typeface="+mn-lt"/>
                   </a:defRPr>
@@ -2673,7 +2673,7 @@
                 <a:r>
                   <a:rPr sz="1200" b="0" i="0" u="none" strike="noStrike">
                     <a:solidFill>
-                      <a:srgbClr val="5B6B75"/>
+                      <a:srgbClr val="76838F"/>
                     </a:solidFill>
                     <a:latin typeface="+mn-lt"/>
                   </a:rPr>
@@ -2703,7 +2703,7 @@
             <a:pPr>
               <a:defRPr sz="1100" b="0" i="0" u="none" strike="noStrike">
                 <a:solidFill>
-                  <a:srgbClr val="5B6B75"/>
+                  <a:srgbClr val="76838F"/>
                 </a:solidFill>
                 <a:latin typeface="+mn-lt"/>
               </a:defRPr>
@@ -2733,7 +2733,7 @@
           <a:pPr>
             <a:defRPr sz="1100">
               <a:solidFill>
-                <a:srgbClr val="5B6B75"/>
+                <a:srgbClr val="76838F"/>
               </a:solidFill>
               <a:latin typeface="+mn-lt"/>
               <a:cs typeface="+mn-lt"/>
@@ -2817,7 +2817,7 @@
           </c:tx>
           <c:spPr>
             <a:solidFill>
-              <a:srgbClr val="2A7F8E"/>
+              <a:srgbClr val="3B5BA9"/>
             </a:solidFill>
             <a:effectLst/>
           </c:spPr>
@@ -2958,7 +2958,7 @@
         <c:spPr>
           <a:ln w="12700" cap="flat">
             <a:solidFill>
-              <a:srgbClr val="DCE3E7"/>
+              <a:srgbClr val="E3E7EB"/>
             </a:solidFill>
             <a:prstDash val="solid"/>
             <a:round/>
@@ -2971,7 +2971,7 @@
             <a:pPr>
               <a:defRPr sz="1200" b="0" i="0" u="none" strike="noStrike">
                 <a:solidFill>
-                  <a:srgbClr val="5B6B75"/>
+                  <a:srgbClr val="76838F"/>
                 </a:solidFill>
                 <a:latin typeface="+mn-lt"/>
               </a:defRPr>
@@ -3011,7 +3011,7 @@
             <a:pPr>
               <a:defRPr sz="1100" b="0" i="0" u="none" strike="noStrike">
                 <a:solidFill>
-                  <a:srgbClr val="5B6B75"/>
+                  <a:srgbClr val="76838F"/>
                 </a:solidFill>
                 <a:latin typeface="+mn-lt"/>
               </a:defRPr>
@@ -3104,7 +3104,7 @@
           </c:tx>
           <c:spPr>
             <a:solidFill>
-              <a:srgbClr val="C8553D"/>
+              <a:srgbClr val="3B5BA9"/>
             </a:solidFill>
             <a:effectLst/>
           </c:spPr>
@@ -3245,7 +3245,7 @@
         <c:spPr>
           <a:ln w="12700" cap="flat">
             <a:solidFill>
-              <a:srgbClr val="DCE3E7"/>
+              <a:srgbClr val="E3E7EB"/>
             </a:solidFill>
             <a:prstDash val="solid"/>
             <a:round/>
@@ -3258,7 +3258,7 @@
             <a:pPr>
               <a:defRPr sz="1200" b="0" i="0" u="none" strike="noStrike">
                 <a:solidFill>
-                  <a:srgbClr val="5B6B75"/>
+                  <a:srgbClr val="76838F"/>
                 </a:solidFill>
                 <a:latin typeface="+mn-lt"/>
               </a:defRPr>
@@ -3298,7 +3298,7 @@
             <a:pPr>
               <a:defRPr sz="1100" b="0" i="0" u="none" strike="noStrike">
                 <a:solidFill>
-                  <a:srgbClr val="5B6B75"/>
+                  <a:srgbClr val="76838F"/>
                 </a:solidFill>
                 <a:latin typeface="+mn-lt"/>
               </a:defRPr>
@@ -3391,7 +3391,7 @@
           </c:tx>
           <c:spPr>
             <a:solidFill>
-              <a:srgbClr val="C8553D"/>
+              <a:srgbClr val="B8243B"/>
             </a:solidFill>
             <a:effectLst/>
           </c:spPr>
@@ -3544,7 +3544,7 @@
         <c:spPr>
           <a:ln w="12700" cap="flat">
             <a:solidFill>
-              <a:srgbClr val="DCE3E7"/>
+              <a:srgbClr val="E3E7EB"/>
             </a:solidFill>
             <a:prstDash val="solid"/>
             <a:round/>
@@ -3557,7 +3557,7 @@
             <a:pPr>
               <a:defRPr sz="1200" b="0" i="0" u="none" strike="noStrike">
                 <a:solidFill>
-                  <a:srgbClr val="5B6B75"/>
+                  <a:srgbClr val="76838F"/>
                 </a:solidFill>
                 <a:latin typeface="+mn-lt"/>
               </a:defRPr>
@@ -3597,7 +3597,7 @@
             <a:pPr>
               <a:defRPr sz="1100" b="0" i="0" u="none" strike="noStrike">
                 <a:solidFill>
-                  <a:srgbClr val="5B6B75"/>
+                  <a:srgbClr val="76838F"/>
                 </a:solidFill>
                 <a:latin typeface="+mn-lt"/>
               </a:defRPr>
@@ -3690,7 +3690,7 @@
           </c:tx>
           <c:spPr>
             <a:solidFill>
-              <a:srgbClr val="6B8496"/>
+              <a:srgbClr val="3B5BA9"/>
             </a:solidFill>
             <a:effectLst/>
           </c:spPr>
@@ -3807,7 +3807,7 @@
         <c:spPr>
           <a:ln w="12700" cap="flat">
             <a:solidFill>
-              <a:srgbClr val="DCE3E7"/>
+              <a:srgbClr val="E3E7EB"/>
             </a:solidFill>
             <a:prstDash val="solid"/>
             <a:round/>
@@ -3820,7 +3820,7 @@
             <a:pPr>
               <a:defRPr sz="1200" b="0" i="0" u="none" strike="noStrike">
                 <a:solidFill>
-                  <a:srgbClr val="5B6B75"/>
+                  <a:srgbClr val="76838F"/>
                 </a:solidFill>
                 <a:latin typeface="+mn-lt"/>
               </a:defRPr>
@@ -3847,7 +3847,7 @@
           <c:spPr>
             <a:ln w="9525" cap="flat">
               <a:solidFill>
-                <a:srgbClr val="DCE3E7"/>
+                <a:srgbClr val="E3E7EB"/>
               </a:solidFill>
               <a:prstDash val="solid"/>
               <a:round/>
@@ -3872,7 +3872,7 @@
             <a:pPr>
               <a:defRPr sz="1100" b="0" i="0" u="none" strike="noStrike">
                 <a:solidFill>
-                  <a:srgbClr val="5B6B75"/>
+                  <a:srgbClr val="76838F"/>
                 </a:solidFill>
                 <a:latin typeface="+mn-lt"/>
               </a:defRPr>
@@ -3965,7 +3965,7 @@
           </c:tx>
           <c:spPr>
             <a:solidFill>
-              <a:srgbClr val="B7C4CC"/>
+              <a:srgbClr val="C9D1D9"/>
             </a:solidFill>
             <a:effectLst/>
           </c:spPr>
@@ -4126,7 +4126,7 @@
           </c:tx>
           <c:spPr>
             <a:solidFill>
-              <a:srgbClr val="C8553D"/>
+              <a:srgbClr val="3B5BA9"/>
             </a:solidFill>
             <a:effectLst/>
           </c:spPr>
@@ -4315,7 +4315,7 @@
         <c:spPr>
           <a:ln w="12700" cap="flat">
             <a:solidFill>
-              <a:srgbClr val="DCE3E7"/>
+              <a:srgbClr val="E3E7EB"/>
             </a:solidFill>
             <a:prstDash val="solid"/>
             <a:round/>
@@ -4328,7 +4328,7 @@
             <a:pPr>
               <a:defRPr sz="1100" b="0" i="0" u="none" strike="noStrike">
                 <a:solidFill>
-                  <a:srgbClr val="5B6B75"/>
+                  <a:srgbClr val="76838F"/>
                 </a:solidFill>
                 <a:latin typeface="+mn-lt"/>
               </a:defRPr>
@@ -4353,7 +4353,7 @@
           <c:spPr>
             <a:ln w="9525" cap="flat">
               <a:solidFill>
-                <a:srgbClr val="DCE3E7"/>
+                <a:srgbClr val="E3E7EB"/>
               </a:solidFill>
               <a:prstDash val="solid"/>
               <a:round/>
@@ -4378,7 +4378,7 @@
             <a:pPr>
               <a:defRPr sz="1100" b="0" i="0" u="none" strike="noStrike">
                 <a:solidFill>
-                  <a:srgbClr val="5B6B75"/>
+                  <a:srgbClr val="76838F"/>
                 </a:solidFill>
                 <a:latin typeface="+mn-lt"/>
               </a:defRPr>
@@ -4471,7 +4471,7 @@
           </c:tx>
           <c:spPr>
             <a:solidFill>
-              <a:srgbClr val="2A7F8E"/>
+              <a:srgbClr val="3B5BA9"/>
             </a:solidFill>
             <a:effectLst/>
           </c:spPr>
@@ -4600,7 +4600,7 @@
         <c:spPr>
           <a:ln w="12700" cap="flat">
             <a:solidFill>
-              <a:srgbClr val="DCE3E7"/>
+              <a:srgbClr val="E3E7EB"/>
             </a:solidFill>
             <a:prstDash val="solid"/>
             <a:round/>
@@ -4613,7 +4613,7 @@
             <a:pPr>
               <a:defRPr sz="1200" b="0" i="0" u="none" strike="noStrike">
                 <a:solidFill>
-                  <a:srgbClr val="5B6B75"/>
+                  <a:srgbClr val="76838F"/>
                 </a:solidFill>
                 <a:latin typeface="+mn-lt"/>
               </a:defRPr>
@@ -4653,7 +4653,7 @@
             <a:pPr>
               <a:defRPr sz="1100" b="0" i="0" u="none" strike="noStrike">
                 <a:solidFill>
-                  <a:srgbClr val="5B6B75"/>
+                  <a:srgbClr val="76838F"/>
                 </a:solidFill>
                 <a:latin typeface="+mn-lt"/>
               </a:defRPr>
@@ -6702,7 +6702,7 @@
               <a:buNone/>
               <a:defRPr lang="en-US" sz="1400" b="1" spc="200" kern="0" dirty="0">
                 <a:solidFill>
-                  <a:schemeClr val="accent3"/>
+                  <a:schemeClr val="accent6"/>
                 </a:solidFill>
               </a:defRPr>
             </a:lvl1pPr>
@@ -6851,7 +6851,7 @@
               <a:buNone/>
               <a:defRPr lang="en-US" sz="1200" b="1" spc="200" kern="0" dirty="0">
                 <a:solidFill>
-                  <a:schemeClr val="accent1"/>
+                  <a:schemeClr val="accent4"/>
                 </a:solidFill>
               </a:defRPr>
             </a:lvl1pPr>
@@ -7042,7 +7042,7 @@
               <a:buNone/>
               <a:defRPr lang="en-US" sz="1200" b="1" spc="200" kern="0" dirty="0">
                 <a:solidFill>
-                  <a:schemeClr val="accent3"/>
+                  <a:schemeClr val="accent6"/>
                 </a:solidFill>
               </a:defRPr>
             </a:lvl1pPr>
@@ -7473,7 +7473,7 @@
             <a:r>
               <a:rPr lang="en-US" sz="1400" b="1" spc="200" kern="0" dirty="0">
                 <a:solidFill>
-                  <a:schemeClr val="accent3"/>
+                  <a:schemeClr val="accent6"/>
                 </a:solidFill>
               </a:rPr>
               <a:t>CAPSTONE PROJECT  |  OCTOBER 2026</a:t>
@@ -7656,7 +7656,7 @@
             <a:r>
               <a:rPr lang="en-US" sz="1200" b="1" spc="200" kern="0" dirty="0">
                 <a:solidFill>
-                  <a:schemeClr val="accent1"/>
+                  <a:schemeClr val="accent4"/>
                 </a:solidFill>
               </a:rPr>
               <a:t>THE RISK INDEX</a:t>
@@ -7844,13 +7844,18 @@
           </a:xfrm>
           <a:prstGeom prst="roundRect">
             <a:avLst>
-              <a:gd name="adj" fmla="val 3200"/>
+              <a:gd name="adj" fmla="val 2000"/>
             </a:avLst>
           </a:prstGeom>
           <a:solidFill>
             <a:schemeClr val="bg2"/>
           </a:solidFill>
-          <a:ln/>
+          <a:ln w="9525">
+            <a:solidFill>
+              <a:srgbClr val="DDE2E7"/>
+            </a:solidFill>
+            <a:prstDash val="solid"/>
+          </a:ln>
         </p:spPr>
       </p:sp>
       <p:sp>
@@ -8024,7 +8029,7 @@
             <a:r>
               <a:rPr lang="en-US" sz="1200" b="1" spc="200" kern="0" dirty="0">
                 <a:solidFill>
-                  <a:schemeClr val="accent1"/>
+                  <a:schemeClr val="accent4"/>
                 </a:solidFill>
               </a:rPr>
               <a:t>VALIDATION</a:t>
@@ -8084,13 +8089,18 @@
           </a:xfrm>
           <a:prstGeom prst="roundRect">
             <a:avLst>
-              <a:gd name="adj" fmla="val 50000"/>
+              <a:gd name="adj" fmla="val 12500"/>
             </a:avLst>
           </a:prstGeom>
           <a:solidFill>
-            <a:schemeClr val="accent2"/>
+            <a:schemeClr val="bg1"/>
           </a:solidFill>
-          <a:ln/>
+          <a:ln w="9525">
+            <a:solidFill>
+              <a:srgbClr val="C7D1DE"/>
+            </a:solidFill>
+            <a:prstDash val="solid"/>
+          </a:ln>
         </p:spPr>
       </p:sp>
       <p:sp>
@@ -8118,14 +8128,17 @@
               <a:buNone/>
             </a:pPr>
             <a:r>
-              <a:rPr lang="en-US" sz="1200" b="1" dirty="0">
-                <a:solidFill>
-                  <a:schemeClr val="bg1"/>
-                </a:solidFill>
+              <a:rPr lang="en-US" sz="1100" b="1" dirty="0">
+                <a:solidFill>
+                  <a:schemeClr val="accent1"/>
+                </a:solidFill>
+                <a:latin typeface="Consolas" pitchFamily="34" charset="0"/>
+                <a:ea typeface="Consolas" pitchFamily="34" charset="-122"/>
+                <a:cs typeface="Consolas" pitchFamily="34" charset="-120"/>
               </a:rPr>
               <a:t>F7</a:t>
             </a:r>
-            <a:endParaRPr lang="en-US" sz="1200" dirty="0"/>
+            <a:endParaRPr lang="en-US" sz="1100" dirty="0"/>
           </a:p>
         </p:txBody>
       </p:sp>
@@ -8142,13 +8155,18 @@
           </a:xfrm>
           <a:prstGeom prst="roundRect">
             <a:avLst>
-              <a:gd name="adj" fmla="val 50000"/>
+              <a:gd name="adj" fmla="val 12500"/>
             </a:avLst>
           </a:prstGeom>
           <a:solidFill>
-            <a:schemeClr val="accent2"/>
+            <a:schemeClr val="bg1"/>
           </a:solidFill>
-          <a:ln/>
+          <a:ln w="9525">
+            <a:solidFill>
+              <a:srgbClr val="C7D1DE"/>
+            </a:solidFill>
+            <a:prstDash val="solid"/>
+          </a:ln>
         </p:spPr>
       </p:sp>
       <p:sp>
@@ -8176,14 +8194,17 @@
               <a:buNone/>
             </a:pPr>
             <a:r>
-              <a:rPr lang="en-US" sz="1200" b="1" dirty="0">
-                <a:solidFill>
-                  <a:schemeClr val="bg1"/>
-                </a:solidFill>
+              <a:rPr lang="en-US" sz="1100" b="1" dirty="0">
+                <a:solidFill>
+                  <a:schemeClr val="accent1"/>
+                </a:solidFill>
+                <a:latin typeface="Consolas" pitchFamily="34" charset="0"/>
+                <a:ea typeface="Consolas" pitchFamily="34" charset="-122"/>
+                <a:cs typeface="Consolas" pitchFamily="34" charset="-120"/>
               </a:rPr>
               <a:t>F8</a:t>
             </a:r>
-            <a:endParaRPr lang="en-US" sz="1200" dirty="0"/>
+            <a:endParaRPr lang="en-US" sz="1100" dirty="0"/>
           </a:p>
         </p:txBody>
       </p:sp>
@@ -8200,13 +8221,18 @@
           </a:xfrm>
           <a:prstGeom prst="roundRect">
             <a:avLst>
-              <a:gd name="adj" fmla="val 50000"/>
+              <a:gd name="adj" fmla="val 12500"/>
             </a:avLst>
           </a:prstGeom>
           <a:solidFill>
-            <a:schemeClr val="accent2"/>
+            <a:schemeClr val="bg1"/>
           </a:solidFill>
-          <a:ln/>
+          <a:ln w="9525">
+            <a:solidFill>
+              <a:srgbClr val="C7D1DE"/>
+            </a:solidFill>
+            <a:prstDash val="solid"/>
+          </a:ln>
         </p:spPr>
       </p:sp>
       <p:sp>
@@ -8234,14 +8260,17 @@
               <a:buNone/>
             </a:pPr>
             <a:r>
-              <a:rPr lang="en-US" sz="1200" b="1" dirty="0">
-                <a:solidFill>
-                  <a:schemeClr val="bg1"/>
-                </a:solidFill>
+              <a:rPr lang="en-US" sz="1100" b="1" dirty="0">
+                <a:solidFill>
+                  <a:schemeClr val="accent1"/>
+                </a:solidFill>
+                <a:latin typeface="Consolas" pitchFamily="34" charset="0"/>
+                <a:ea typeface="Consolas" pitchFamily="34" charset="-122"/>
+                <a:cs typeface="Consolas" pitchFamily="34" charset="-120"/>
               </a:rPr>
               <a:t>F9</a:t>
             </a:r>
-            <a:endParaRPr lang="en-US" sz="1200" dirty="0"/>
+            <a:endParaRPr lang="en-US" sz="1100" dirty="0"/>
           </a:p>
         </p:txBody>
       </p:sp>
@@ -8258,13 +8287,18 @@
           </a:xfrm>
           <a:prstGeom prst="roundRect">
             <a:avLst>
-              <a:gd name="adj" fmla="val 2105"/>
+              <a:gd name="adj" fmla="val 1316"/>
             </a:avLst>
           </a:prstGeom>
           <a:solidFill>
             <a:schemeClr val="bg2"/>
           </a:solidFill>
-          <a:ln/>
+          <a:ln w="9525">
+            <a:solidFill>
+              <a:srgbClr val="DDE2E7"/>
+            </a:solidFill>
+            <a:prstDash val="solid"/>
+          </a:ln>
         </p:spPr>
       </p:sp>
       <p:sp>
@@ -8282,7 +8316,7 @@
             <a:avLst/>
           </a:prstGeom>
           <a:solidFill>
-            <a:schemeClr val="accent2"/>
+            <a:srgbClr val="1F7A4D"/>
           </a:solidFill>
           <a:ln/>
         </p:spPr>
@@ -8374,11 +8408,8 @@
             <a:r>
               <a:rPr lang="en-US" sz="4000" b="1" dirty="0">
                 <a:solidFill>
-                  <a:schemeClr val="accent2"/>
-                </a:solidFill>
-                <a:latin typeface="Cambria" pitchFamily="34" charset="0"/>
-                <a:ea typeface="Cambria" pitchFamily="34" charset="-122"/>
-                <a:cs typeface="Cambria" pitchFamily="34" charset="-120"/>
+                  <a:schemeClr val="tx1"/>
+                </a:solidFill>
               </a:rPr>
               <a:t>ρ = 0.52</a:t>
             </a:r>
@@ -8413,7 +8444,7 @@
             <a:r>
               <a:rPr lang="en-US" sz="1300" dirty="0">
                 <a:solidFill>
-                  <a:srgbClr val="5B6B75"/>
+                  <a:srgbClr val="76838F"/>
                 </a:solidFill>
               </a:rPr>
               <a:t>vs recorded landslides</a:t>
@@ -8449,10 +8480,10 @@
             <a:r>
               <a:rPr lang="en-US" sz="1400" b="1" spc="200" kern="0" dirty="0">
                 <a:solidFill>
-                  <a:schemeClr val="accent2"/>
-                </a:solidFill>
-              </a:rPr>
-              <a:t>WORKS</a:t>
+                  <a:srgbClr val="1F7A4D"/>
+                </a:solidFill>
+              </a:rPr>
+              <a:t>VALIDATED</a:t>
             </a:r>
             <a:endParaRPr lang="en-US" sz="1400" dirty="0"/>
           </a:p>
@@ -8507,13 +8538,18 @@
           </a:xfrm>
           <a:prstGeom prst="roundRect">
             <a:avLst>
-              <a:gd name="adj" fmla="val 2105"/>
+              <a:gd name="adj" fmla="val 1316"/>
             </a:avLst>
           </a:prstGeom>
           <a:solidFill>
             <a:schemeClr val="bg2"/>
           </a:solidFill>
-          <a:ln/>
+          <a:ln w="9525">
+            <a:solidFill>
+              <a:srgbClr val="DDE2E7"/>
+            </a:solidFill>
+            <a:prstDash val="solid"/>
+          </a:ln>
         </p:spPr>
       </p:sp>
       <p:sp>
@@ -8531,7 +8567,7 @@
             <a:avLst/>
           </a:prstGeom>
           <a:solidFill>
-            <a:schemeClr val="accent3"/>
+            <a:srgbClr val="8A5A00"/>
           </a:solidFill>
           <a:ln/>
         </p:spPr>
@@ -8623,11 +8659,8 @@
             <a:r>
               <a:rPr lang="en-US" sz="4000" b="1" dirty="0">
                 <a:solidFill>
-                  <a:schemeClr val="accent3"/>
-                </a:solidFill>
-                <a:latin typeface="Cambria" pitchFamily="34" charset="0"/>
-                <a:ea typeface="Cambria" pitchFamily="34" charset="-122"/>
-                <a:cs typeface="Cambria" pitchFamily="34" charset="-120"/>
+                  <a:schemeClr val="tx1"/>
+                </a:solidFill>
               </a:rPr>
               <a:t>ρ = 0.39</a:t>
             </a:r>
@@ -8662,7 +8695,7 @@
             <a:r>
               <a:rPr lang="en-US" sz="1300" dirty="0">
                 <a:solidFill>
-                  <a:srgbClr val="5B6B75"/>
+                  <a:srgbClr val="76838F"/>
                 </a:solidFill>
               </a:rPr>
               <a:t>vs all events (0.43 vs deaths)</a:t>
@@ -8698,7 +8731,7 @@
             <a:r>
               <a:rPr lang="en-US" sz="1400" b="1" spc="200" kern="0" dirty="0">
                 <a:solidFill>
-                  <a:schemeClr val="accent3"/>
+                  <a:srgbClr val="8A5A00"/>
                 </a:solidFill>
               </a:rPr>
               <a:t>MODERATE</a:t>
@@ -8756,13 +8789,18 @@
           </a:xfrm>
           <a:prstGeom prst="roundRect">
             <a:avLst>
-              <a:gd name="adj" fmla="val 2105"/>
+              <a:gd name="adj" fmla="val 1316"/>
             </a:avLst>
           </a:prstGeom>
           <a:solidFill>
             <a:schemeClr val="bg2"/>
           </a:solidFill>
-          <a:ln/>
+          <a:ln w="9525">
+            <a:solidFill>
+              <a:srgbClr val="DDE2E7"/>
+            </a:solidFill>
+            <a:prstDash val="solid"/>
+          </a:ln>
         </p:spPr>
       </p:sp>
       <p:sp>
@@ -8780,7 +8818,7 @@
             <a:avLst/>
           </a:prstGeom>
           <a:solidFill>
-            <a:schemeClr val="accent1"/>
+            <a:srgbClr val="B8243B"/>
           </a:solidFill>
           <a:ln/>
         </p:spPr>
@@ -8872,11 +8910,8 @@
             <a:r>
               <a:rPr lang="en-US" sz="4000" b="1" dirty="0">
                 <a:solidFill>
-                  <a:schemeClr val="accent1"/>
-                </a:solidFill>
-                <a:latin typeface="Cambria" pitchFamily="34" charset="0"/>
-                <a:ea typeface="Cambria" pitchFamily="34" charset="-122"/>
-                <a:cs typeface="Cambria" pitchFamily="34" charset="-120"/>
+                  <a:schemeClr val="tx1"/>
+                </a:solidFill>
               </a:rPr>
               <a:t>ρ = 0.24</a:t>
             </a:r>
@@ -8911,7 +8946,7 @@
             <a:r>
               <a:rPr lang="en-US" sz="1300" dirty="0">
                 <a:solidFill>
-                  <a:srgbClr val="5B6B75"/>
+                  <a:srgbClr val="76838F"/>
                 </a:solidFill>
               </a:rPr>
               <a:t>vs recorded floods</a:t>
@@ -8947,10 +8982,10 @@
             <a:r>
               <a:rPr lang="en-US" sz="1400" b="1" spc="200" kern="0" dirty="0">
                 <a:solidFill>
-                  <a:schemeClr val="accent1"/>
-                </a:solidFill>
-              </a:rPr>
-              <a:t>FAILS</a:t>
+                  <a:srgbClr val="B8243B"/>
+                </a:solidFill>
+              </a:rPr>
+              <a:t>NOT VALIDATED</a:t>
             </a:r>
             <a:endParaRPr lang="en-US" sz="1400" dirty="0"/>
           </a:p>
@@ -9138,7 +9173,7 @@
             <a:r>
               <a:rPr lang="en-US" sz="1200" b="1" spc="200" kern="0" dirty="0">
                 <a:solidFill>
-                  <a:schemeClr val="accent1"/>
+                  <a:schemeClr val="accent4"/>
                 </a:solidFill>
               </a:rPr>
               <a:t>VALIDATION  |  FLOODS</a:t>
@@ -9198,13 +9233,18 @@
           </a:xfrm>
           <a:prstGeom prst="roundRect">
             <a:avLst>
-              <a:gd name="adj" fmla="val 50000"/>
+              <a:gd name="adj" fmla="val 12500"/>
             </a:avLst>
           </a:prstGeom>
           <a:solidFill>
-            <a:schemeClr val="accent2"/>
+            <a:schemeClr val="bg1"/>
           </a:solidFill>
-          <a:ln/>
+          <a:ln w="9525">
+            <a:solidFill>
+              <a:srgbClr val="C7D1DE"/>
+            </a:solidFill>
+            <a:prstDash val="solid"/>
+          </a:ln>
         </p:spPr>
       </p:sp>
       <p:sp>
@@ -9232,14 +9272,17 @@
               <a:buNone/>
             </a:pPr>
             <a:r>
-              <a:rPr lang="en-US" sz="1200" b="1" dirty="0">
-                <a:solidFill>
-                  <a:schemeClr val="bg1"/>
-                </a:solidFill>
+              <a:rPr lang="en-US" sz="1100" b="1" dirty="0">
+                <a:solidFill>
+                  <a:schemeClr val="accent1"/>
+                </a:solidFill>
+                <a:latin typeface="Consolas" pitchFamily="34" charset="0"/>
+                <a:ea typeface="Consolas" pitchFamily="34" charset="-122"/>
+                <a:cs typeface="Consolas" pitchFamily="34" charset="-120"/>
               </a:rPr>
               <a:t>F9</a:t>
             </a:r>
-            <a:endParaRPr lang="en-US" sz="1200" dirty="0"/>
+            <a:endParaRPr lang="en-US" sz="1100" dirty="0"/>
           </a:p>
         </p:txBody>
       </p:sp>
@@ -9427,13 +9470,18 @@
           </a:xfrm>
           <a:prstGeom prst="roundRect">
             <a:avLst>
-              <a:gd name="adj" fmla="val 8000"/>
+              <a:gd name="adj" fmla="val 5000"/>
             </a:avLst>
           </a:prstGeom>
           <a:solidFill>
             <a:schemeClr val="bg2"/>
           </a:solidFill>
-          <a:ln/>
+          <a:ln w="9525">
+            <a:solidFill>
+              <a:srgbClr val="DDE2E7"/>
+            </a:solidFill>
+            <a:prstDash val="solid"/>
+          </a:ln>
         </p:spPr>
       </p:sp>
       <p:sp>
@@ -9571,7 +9619,7 @@
             <a:r>
               <a:rPr lang="en-US" sz="1200" b="1" spc="200" kern="0" dirty="0">
                 <a:solidFill>
-                  <a:schemeClr val="accent1"/>
+                  <a:schemeClr val="accent4"/>
                 </a:solidFill>
               </a:rPr>
               <a:t>METHODOLOGICAL DECISION</a:t>
@@ -10500,7 +10548,7 @@
             <a:r>
               <a:rPr lang="en-US" sz="1200" i="1" dirty="0">
                 <a:solidFill>
-                  <a:srgbClr val="5B6B75"/>
+                  <a:srgbClr val="76838F"/>
                 </a:solidFill>
               </a:rPr>
               <a:t>Highlighted: the best index for each hazard. Spearman ρ across 77 districts.</a:t>
@@ -10538,9 +10586,9 @@
                 <a:solidFill>
                   <a:schemeClr val="accent1"/>
                 </a:solidFill>
-                <a:latin typeface="Cambria" pitchFamily="34" charset="0"/>
-                <a:ea typeface="Cambria" pitchFamily="34" charset="-122"/>
-                <a:cs typeface="Cambria" pitchFamily="34" charset="-120"/>
+                <a:latin typeface="Calibri" pitchFamily="34" charset="0"/>
+                <a:ea typeface="Calibri" pitchFamily="34" charset="-122"/>
+                <a:cs typeface="Calibri" pitchFamily="34" charset="-120"/>
               </a:rPr>
               <a:t>1</a:t>
             </a:r>
@@ -10649,9 +10697,9 @@
                 <a:solidFill>
                   <a:schemeClr val="accent1"/>
                 </a:solidFill>
-                <a:latin typeface="Cambria" pitchFamily="34" charset="0"/>
-                <a:ea typeface="Cambria" pitchFamily="34" charset="-122"/>
-                <a:cs typeface="Cambria" pitchFamily="34" charset="-120"/>
+                <a:latin typeface="Calibri" pitchFamily="34" charset="0"/>
+                <a:ea typeface="Calibri" pitchFamily="34" charset="-122"/>
+                <a:cs typeface="Calibri" pitchFamily="34" charset="-120"/>
               </a:rPr>
               <a:t>2</a:t>
             </a:r>
@@ -10760,9 +10808,9 @@
                 <a:solidFill>
                   <a:schemeClr val="accent1"/>
                 </a:solidFill>
-                <a:latin typeface="Cambria" pitchFamily="34" charset="0"/>
-                <a:ea typeface="Cambria" pitchFamily="34" charset="-122"/>
-                <a:cs typeface="Cambria" pitchFamily="34" charset="-120"/>
+                <a:latin typeface="Calibri" pitchFamily="34" charset="0"/>
+                <a:ea typeface="Calibri" pitchFamily="34" charset="-122"/>
+                <a:cs typeface="Calibri" pitchFamily="34" charset="-120"/>
               </a:rPr>
               <a:t>3</a:t>
             </a:r>
@@ -10941,7 +10989,7 @@
             <a:r>
               <a:rPr lang="en-US" sz="1200" b="1" spc="200" kern="0" dirty="0">
                 <a:solidFill>
-                  <a:schemeClr val="accent1"/>
+                  <a:schemeClr val="accent4"/>
                 </a:solidFill>
               </a:rPr>
               <a:t>VALIDATION  |  DATA QUALITY</a:t>
@@ -11001,13 +11049,18 @@
           </a:xfrm>
           <a:prstGeom prst="roundRect">
             <a:avLst>
-              <a:gd name="adj" fmla="val 50000"/>
+              <a:gd name="adj" fmla="val 12500"/>
             </a:avLst>
           </a:prstGeom>
           <a:solidFill>
-            <a:schemeClr val="accent2"/>
+            <a:schemeClr val="bg1"/>
           </a:solidFill>
-          <a:ln/>
+          <a:ln w="9525">
+            <a:solidFill>
+              <a:srgbClr val="C7D1DE"/>
+            </a:solidFill>
+            <a:prstDash val="solid"/>
+          </a:ln>
         </p:spPr>
       </p:sp>
       <p:sp>
@@ -11035,14 +11088,17 @@
               <a:buNone/>
             </a:pPr>
             <a:r>
-              <a:rPr lang="en-US" sz="1200" b="1" dirty="0">
-                <a:solidFill>
-                  <a:schemeClr val="bg1"/>
-                </a:solidFill>
+              <a:rPr lang="en-US" sz="1100" b="1" dirty="0">
+                <a:solidFill>
+                  <a:schemeClr val="accent1"/>
+                </a:solidFill>
+                <a:latin typeface="Consolas" pitchFamily="34" charset="0"/>
+                <a:ea typeface="Consolas" pitchFamily="34" charset="-122"/>
+                <a:cs typeface="Consolas" pitchFamily="34" charset="-120"/>
               </a:rPr>
               <a:t>F10</a:t>
             </a:r>
-            <a:endParaRPr lang="en-US" sz="1200" dirty="0"/>
+            <a:endParaRPr lang="en-US" sz="1100" dirty="0"/>
           </a:p>
         </p:txBody>
       </p:sp>
@@ -11059,13 +11115,18 @@
           </a:xfrm>
           <a:prstGeom prst="roundRect">
             <a:avLst>
-              <a:gd name="adj" fmla="val 50000"/>
+              <a:gd name="adj" fmla="val 12500"/>
             </a:avLst>
           </a:prstGeom>
           <a:solidFill>
-            <a:schemeClr val="accent2"/>
+            <a:schemeClr val="bg1"/>
           </a:solidFill>
-          <a:ln/>
+          <a:ln w="9525">
+            <a:solidFill>
+              <a:srgbClr val="C7D1DE"/>
+            </a:solidFill>
+            <a:prstDash val="solid"/>
+          </a:ln>
         </p:spPr>
       </p:sp>
       <p:sp>
@@ -11093,14 +11154,17 @@
               <a:buNone/>
             </a:pPr>
             <a:r>
-              <a:rPr lang="en-US" sz="1200" b="1" dirty="0">
-                <a:solidFill>
-                  <a:schemeClr val="bg1"/>
-                </a:solidFill>
+              <a:rPr lang="en-US" sz="1100" b="1" dirty="0">
+                <a:solidFill>
+                  <a:schemeClr val="accent1"/>
+                </a:solidFill>
+                <a:latin typeface="Consolas" pitchFamily="34" charset="0"/>
+                <a:ea typeface="Consolas" pitchFamily="34" charset="-122"/>
+                <a:cs typeface="Consolas" pitchFamily="34" charset="-120"/>
               </a:rPr>
               <a:t>F11</a:t>
             </a:r>
-            <a:endParaRPr lang="en-US" sz="1200" dirty="0"/>
+            <a:endParaRPr lang="en-US" sz="1100" dirty="0"/>
           </a:p>
         </p:txBody>
       </p:sp>
@@ -11567,7 +11631,7 @@
             <a:r>
               <a:rPr lang="en-US" sz="1200" b="1" spc="200" kern="0" dirty="0">
                 <a:solidFill>
-                  <a:schemeClr val="accent1"/>
+                  <a:schemeClr val="accent4"/>
                 </a:solidFill>
               </a:rPr>
               <a:t>RECOMMENDATION</a:t>
@@ -11643,13 +11707,18 @@
           </a:xfrm>
           <a:prstGeom prst="roundRect">
             <a:avLst>
-              <a:gd name="adj" fmla="val 3478"/>
+              <a:gd name="adj" fmla="val 2174"/>
             </a:avLst>
           </a:prstGeom>
           <a:solidFill>
             <a:schemeClr val="bg2"/>
           </a:solidFill>
-          <a:ln/>
+          <a:ln w="9525">
+            <a:solidFill>
+              <a:srgbClr val="DDE2E7"/>
+            </a:solidFill>
+            <a:prstDash val="solid"/>
+          </a:ln>
         </p:spPr>
       </p:sp>
       <p:sp>
@@ -11681,9 +11750,9 @@
                 <a:solidFill>
                   <a:schemeClr val="accent2"/>
                 </a:solidFill>
-                <a:latin typeface="Cambria" pitchFamily="34" charset="0"/>
-                <a:ea typeface="Cambria" pitchFamily="34" charset="-122"/>
-                <a:cs typeface="Cambria" pitchFamily="34" charset="-120"/>
+                <a:latin typeface="Calibri" pitchFamily="34" charset="0"/>
+                <a:ea typeface="Calibri" pitchFamily="34" charset="-122"/>
+                <a:cs typeface="Calibri" pitchFamily="34" charset="-120"/>
               </a:rPr>
               <a:t>$63M</a:t>
             </a:r>
@@ -11740,7 +11809,7 @@
           </a:xfrm>
           <a:prstGeom prst="roundRect">
             <a:avLst>
-              <a:gd name="adj" fmla="val 3404"/>
+              <a:gd name="adj" fmla="val 2128"/>
             </a:avLst>
           </a:prstGeom>
           <a:solidFill>
@@ -11776,11 +11845,8 @@
             <a:r>
               <a:rPr lang="en-US" sz="3600" b="1" dirty="0">
                 <a:solidFill>
-                  <a:schemeClr val="accent3"/>
-                </a:solidFill>
-                <a:latin typeface="Cambria" pitchFamily="34" charset="0"/>
-                <a:ea typeface="Cambria" pitchFamily="34" charset="-122"/>
-                <a:cs typeface="Cambria" pitchFamily="34" charset="-120"/>
+                  <a:schemeClr val="bg1"/>
+                </a:solidFill>
               </a:rPr>
               <a:t>$37M</a:t>
             </a:r>
@@ -11923,7 +11989,7 @@
             <a:r>
               <a:rPr lang="en-US" sz="1200" b="1" spc="200" kern="0" dirty="0">
                 <a:solidFill>
-                  <a:schemeClr val="accent1"/>
+                  <a:schemeClr val="accent4"/>
                 </a:solidFill>
               </a:rPr>
               <a:t>RECOMMENDATION</a:t>
@@ -12477,20 +12543,20 @@
                         <a:buNone/>
                       </a:pPr>
                       <a:r>
-                        <a:rPr lang="en-US" sz="1200" b="1" dirty="0">
+                        <a:rPr lang="en-US" sz="1100" b="1" dirty="0">
                           <a:solidFill>
-                            <a:schemeClr val="accent2"/>
+                            <a:schemeClr val="accent1"/>
                           </a:solidFill>
-                          <a:latin typeface="Calibri" pitchFamily="34" charset="0"/>
-                          <a:ea typeface="Calibri" pitchFamily="34" charset="-122"/>
-                          <a:cs typeface="Calibri" pitchFamily="34" charset="-120"/>
+                          <a:latin typeface="Consolas" pitchFamily="34" charset="0"/>
+                          <a:ea typeface="Consolas" pitchFamily="34" charset="-122"/>
+                          <a:cs typeface="Consolas" pitchFamily="34" charset="-120"/>
                         </a:rPr>
                         <a:t>F1, F2, F8</a:t>
                       </a:r>
-                      <a:endParaRPr lang="en-US" sz="1200" dirty="0">
-                        <a:latin typeface="Calibri" charset="0"/>
-                        <a:ea typeface="Calibri" charset="0"/>
-                        <a:cs typeface="Calibri" charset="0"/>
+                      <a:endParaRPr lang="en-US" sz="1100" dirty="0">
+                        <a:latin typeface="Consolas" charset="0"/>
+                        <a:ea typeface="Consolas" charset="0"/>
+                        <a:cs typeface="Consolas" charset="0"/>
                       </a:endParaRPr>
                     </a:p>
                   </a:txBody>
@@ -12739,20 +12805,20 @@
                         <a:buNone/>
                       </a:pPr>
                       <a:r>
-                        <a:rPr lang="en-US" sz="1200" b="1" dirty="0">
+                        <a:rPr lang="en-US" sz="1100" b="1" dirty="0">
                           <a:solidFill>
-                            <a:schemeClr val="accent2"/>
+                            <a:schemeClr val="accent1"/>
                           </a:solidFill>
-                          <a:latin typeface="Calibri" pitchFamily="34" charset="0"/>
-                          <a:ea typeface="Calibri" pitchFamily="34" charset="-122"/>
-                          <a:cs typeface="Calibri" pitchFamily="34" charset="-120"/>
+                          <a:latin typeface="Consolas" pitchFamily="34" charset="0"/>
+                          <a:ea typeface="Consolas" pitchFamily="34" charset="-122"/>
+                          <a:cs typeface="Consolas" pitchFamily="34" charset="-120"/>
                         </a:rPr>
                         <a:t>F9</a:t>
                       </a:r>
-                      <a:endParaRPr lang="en-US" sz="1200" dirty="0">
-                        <a:latin typeface="Calibri" charset="0"/>
-                        <a:ea typeface="Calibri" charset="0"/>
-                        <a:cs typeface="Calibri" charset="0"/>
+                      <a:endParaRPr lang="en-US" sz="1100" dirty="0">
+                        <a:latin typeface="Consolas" charset="0"/>
+                        <a:ea typeface="Consolas" charset="0"/>
+                        <a:cs typeface="Consolas" charset="0"/>
                       </a:endParaRPr>
                     </a:p>
                   </a:txBody>
@@ -13001,20 +13067,20 @@
                         <a:buNone/>
                       </a:pPr>
                       <a:r>
-                        <a:rPr lang="en-US" sz="1200" b="1" dirty="0">
+                        <a:rPr lang="en-US" sz="1100" b="1" dirty="0">
                           <a:solidFill>
-                            <a:schemeClr val="accent2"/>
+                            <a:schemeClr val="accent1"/>
                           </a:solidFill>
-                          <a:latin typeface="Calibri" pitchFamily="34" charset="0"/>
-                          <a:ea typeface="Calibri" pitchFamily="34" charset="-122"/>
-                          <a:cs typeface="Calibri" pitchFamily="34" charset="-120"/>
+                          <a:latin typeface="Consolas" pitchFamily="34" charset="0"/>
+                          <a:ea typeface="Consolas" pitchFamily="34" charset="-122"/>
+                          <a:cs typeface="Consolas" pitchFamily="34" charset="-120"/>
                         </a:rPr>
                         <a:t>F3, F4, F8, F11</a:t>
                       </a:r>
-                      <a:endParaRPr lang="en-US" sz="1200" dirty="0">
-                        <a:latin typeface="Calibri" charset="0"/>
-                        <a:ea typeface="Calibri" charset="0"/>
-                        <a:cs typeface="Calibri" charset="0"/>
+                      <a:endParaRPr lang="en-US" sz="1100" dirty="0">
+                        <a:latin typeface="Consolas" charset="0"/>
+                        <a:ea typeface="Consolas" charset="0"/>
+                        <a:cs typeface="Consolas" charset="0"/>
                       </a:endParaRPr>
                     </a:p>
                   </a:txBody>
@@ -13263,20 +13329,20 @@
                         <a:buNone/>
                       </a:pPr>
                       <a:r>
-                        <a:rPr lang="en-US" sz="1200" b="1" dirty="0">
+                        <a:rPr lang="en-US" sz="1100" b="1" dirty="0">
                           <a:solidFill>
-                            <a:schemeClr val="accent2"/>
+                            <a:schemeClr val="accent1"/>
                           </a:solidFill>
-                          <a:latin typeface="Calibri" pitchFamily="34" charset="0"/>
-                          <a:ea typeface="Calibri" pitchFamily="34" charset="-122"/>
-                          <a:cs typeface="Calibri" pitchFamily="34" charset="-120"/>
+                          <a:latin typeface="Consolas" pitchFamily="34" charset="0"/>
+                          <a:ea typeface="Consolas" pitchFamily="34" charset="-122"/>
+                          <a:cs typeface="Consolas" pitchFamily="34" charset="-120"/>
                         </a:rPr>
                         <a:t>F3, F5</a:t>
                       </a:r>
-                      <a:endParaRPr lang="en-US" sz="1200" dirty="0">
-                        <a:latin typeface="Calibri" charset="0"/>
-                        <a:ea typeface="Calibri" charset="0"/>
-                        <a:cs typeface="Calibri" charset="0"/>
+                      <a:endParaRPr lang="en-US" sz="1100" dirty="0">
+                        <a:latin typeface="Consolas" charset="0"/>
+                        <a:ea typeface="Consolas" charset="0"/>
+                        <a:cs typeface="Consolas" charset="0"/>
                       </a:endParaRPr>
                     </a:p>
                   </a:txBody>
@@ -13525,20 +13591,20 @@
                         <a:buNone/>
                       </a:pPr>
                       <a:r>
-                        <a:rPr lang="en-US" sz="1200" b="1" dirty="0">
+                        <a:rPr lang="en-US" sz="1100" b="1" dirty="0">
                           <a:solidFill>
-                            <a:schemeClr val="accent2"/>
+                            <a:schemeClr val="accent1"/>
                           </a:solidFill>
-                          <a:latin typeface="Calibri" pitchFamily="34" charset="0"/>
-                          <a:ea typeface="Calibri" pitchFamily="34" charset="-122"/>
-                          <a:cs typeface="Calibri" pitchFamily="34" charset="-120"/>
+                          <a:latin typeface="Consolas" pitchFamily="34" charset="0"/>
+                          <a:ea typeface="Consolas" pitchFamily="34" charset="-122"/>
+                          <a:cs typeface="Consolas" pitchFamily="34" charset="-120"/>
                         </a:rPr>
                         <a:t>F6</a:t>
                       </a:r>
-                      <a:endParaRPr lang="en-US" sz="1200" dirty="0">
-                        <a:latin typeface="Calibri" charset="0"/>
-                        <a:ea typeface="Calibri" charset="0"/>
-                        <a:cs typeface="Calibri" charset="0"/>
+                      <a:endParaRPr lang="en-US" sz="1100" dirty="0">
+                        <a:latin typeface="Consolas" charset="0"/>
+                        <a:ea typeface="Consolas" charset="0"/>
+                        <a:cs typeface="Consolas" charset="0"/>
                       </a:endParaRPr>
                     </a:p>
                   </a:txBody>
@@ -13787,20 +13853,20 @@
                         <a:buNone/>
                       </a:pPr>
                       <a:r>
-                        <a:rPr lang="en-US" sz="1200" b="1" dirty="0">
+                        <a:rPr lang="en-US" sz="1100" b="1" dirty="0">
                           <a:solidFill>
-                            <a:schemeClr val="accent2"/>
+                            <a:schemeClr val="accent1"/>
                           </a:solidFill>
-                          <a:latin typeface="Calibri" pitchFamily="34" charset="0"/>
-                          <a:ea typeface="Calibri" pitchFamily="34" charset="-122"/>
-                          <a:cs typeface="Calibri" pitchFamily="34" charset="-120"/>
+                          <a:latin typeface="Consolas" pitchFamily="34" charset="0"/>
+                          <a:ea typeface="Consolas" pitchFamily="34" charset="-122"/>
+                          <a:cs typeface="Consolas" pitchFamily="34" charset="-120"/>
                         </a:rPr>
                         <a:t>F9, F10, F11</a:t>
                       </a:r>
-                      <a:endParaRPr lang="en-US" sz="1200" dirty="0">
-                        <a:latin typeface="Calibri" charset="0"/>
-                        <a:ea typeface="Calibri" charset="0"/>
-                        <a:cs typeface="Calibri" charset="0"/>
+                      <a:endParaRPr lang="en-US" sz="1100" dirty="0">
+                        <a:latin typeface="Consolas" charset="0"/>
+                        <a:ea typeface="Consolas" charset="0"/>
+                        <a:cs typeface="Consolas" charset="0"/>
                       </a:endParaRPr>
                     </a:p>
                   </a:txBody>
@@ -13947,7 +14013,7 @@
             <a:r>
               <a:rPr lang="en-US" sz="1200" b="1" spc="200" kern="0" dirty="0">
                 <a:solidFill>
-                  <a:schemeClr val="accent3"/>
+                  <a:schemeClr val="accent6"/>
                 </a:solidFill>
               </a:rPr>
               <a:t>IN SUMMARY</a:t>
@@ -14021,11 +14087,8 @@
             <a:r>
               <a:rPr lang="en-US" sz="5400" b="1" dirty="0">
                 <a:solidFill>
-                  <a:schemeClr val="accent3"/>
-                </a:solidFill>
-                <a:latin typeface="Cambria" pitchFamily="34" charset="0"/>
-                <a:ea typeface="Cambria" pitchFamily="34" charset="-122"/>
-                <a:cs typeface="Cambria" pitchFamily="34" charset="-120"/>
+                  <a:schemeClr val="accent6"/>
+                </a:solidFill>
               </a:rPr>
               <a:t>1</a:t>
             </a:r>
@@ -14132,8 +14195,11 @@
             <a:r>
               <a:rPr lang="en-US" sz="1200" b="1" dirty="0">
                 <a:solidFill>
-                  <a:schemeClr val="accent3"/>
-                </a:solidFill>
+                  <a:schemeClr val="accent6"/>
+                </a:solidFill>
+                <a:latin typeface="Consolas" pitchFamily="34" charset="0"/>
+                <a:ea typeface="Consolas" pitchFamily="34" charset="-122"/>
+                <a:cs typeface="Consolas" pitchFamily="34" charset="-120"/>
               </a:rPr>
               <a:t>F1, F2</a:t>
             </a:r>
@@ -14168,11 +14234,8 @@
             <a:r>
               <a:rPr lang="en-US" sz="5400" b="1" dirty="0">
                 <a:solidFill>
-                  <a:schemeClr val="accent3"/>
-                </a:solidFill>
-                <a:latin typeface="Cambria" pitchFamily="34" charset="0"/>
-                <a:ea typeface="Cambria" pitchFamily="34" charset="-122"/>
-                <a:cs typeface="Cambria" pitchFamily="34" charset="-120"/>
+                  <a:schemeClr val="accent6"/>
+                </a:solidFill>
               </a:rPr>
               <a:t>2</a:t>
             </a:r>
@@ -14279,8 +14342,11 @@
             <a:r>
               <a:rPr lang="en-US" sz="1200" b="1" dirty="0">
                 <a:solidFill>
-                  <a:schemeClr val="accent3"/>
-                </a:solidFill>
+                  <a:schemeClr val="accent6"/>
+                </a:solidFill>
+                <a:latin typeface="Consolas" pitchFamily="34" charset="0"/>
+                <a:ea typeface="Consolas" pitchFamily="34" charset="-122"/>
+                <a:cs typeface="Consolas" pitchFamily="34" charset="-120"/>
               </a:rPr>
               <a:t>F8 to F11</a:t>
             </a:r>
@@ -14315,11 +14381,8 @@
             <a:r>
               <a:rPr lang="en-US" sz="5400" b="1" dirty="0">
                 <a:solidFill>
-                  <a:schemeClr val="accent3"/>
-                </a:solidFill>
-                <a:latin typeface="Cambria" pitchFamily="34" charset="0"/>
-                <a:ea typeface="Cambria" pitchFamily="34" charset="-122"/>
-                <a:cs typeface="Cambria" pitchFamily="34" charset="-120"/>
+                  <a:schemeClr val="accent6"/>
+                </a:solidFill>
               </a:rPr>
               <a:t>3</a:t>
             </a:r>
@@ -14426,8 +14489,11 @@
             <a:r>
               <a:rPr lang="en-US" sz="1200" b="1" dirty="0">
                 <a:solidFill>
-                  <a:schemeClr val="accent3"/>
-                </a:solidFill>
+                  <a:schemeClr val="accent6"/>
+                </a:solidFill>
+                <a:latin typeface="Consolas" pitchFamily="34" charset="0"/>
+                <a:ea typeface="Consolas" pitchFamily="34" charset="-122"/>
+                <a:cs typeface="Consolas" pitchFamily="34" charset="-120"/>
               </a:rPr>
               <a:t>All findings</a:t>
             </a:r>
@@ -14525,7 +14591,7 @@
             <a:r>
               <a:rPr lang="en-US" sz="1200" b="1" spc="200" kern="0" dirty="0">
                 <a:solidFill>
-                  <a:schemeClr val="accent1"/>
+                  <a:schemeClr val="accent4"/>
                 </a:solidFill>
               </a:rPr>
               <a:t>APPENDIX</a:t>
@@ -15205,7 +15271,7 @@
             <a:r>
               <a:rPr lang="en-US" sz="1200" b="1" spc="200" kern="0" dirty="0">
                 <a:solidFill>
-                  <a:schemeClr val="accent1"/>
+                  <a:schemeClr val="accent4"/>
                 </a:solidFill>
               </a:rPr>
               <a:t>THE EVENT</a:t>
@@ -15729,7 +15795,7 @@
           </a:xfrm>
           <a:prstGeom prst="roundRect">
             <a:avLst>
-              <a:gd name="adj" fmla="val 1684"/>
+              <a:gd name="adj" fmla="val 1053"/>
             </a:avLst>
           </a:prstGeom>
           <a:solidFill>
@@ -15765,7 +15831,7 @@
             <a:r>
               <a:rPr lang="en-US" sz="1200" b="1" spc="200" kern="0" dirty="0">
                 <a:solidFill>
-                  <a:schemeClr val="accent3"/>
+                  <a:schemeClr val="accent6"/>
                 </a:solidFill>
               </a:rPr>
               <a:t>THE CENTRAL QUESTION</a:t>
@@ -15799,13 +15865,10 @@
               <a:buNone/>
             </a:pPr>
             <a:r>
-              <a:rPr lang="en-US" sz="2000" i="1" dirty="0">
+              <a:rPr lang="en-US" sz="2000" dirty="0">
                 <a:solidFill>
                   <a:schemeClr val="bg1"/>
                 </a:solidFill>
-                <a:latin typeface="Cambria" pitchFamily="34" charset="0"/>
-                <a:ea typeface="Cambria" pitchFamily="34" charset="-122"/>
-                <a:cs typeface="Cambria" pitchFamily="34" charset="-120"/>
               </a:rPr>
               <a:t>How do climate hazards, terrain, population, infrastructure and access interact to create risk across Nepal's 77 districts, and where has that risk actually materialized?</a:t>
             </a:r>
@@ -15912,7 +15975,7 @@
             <a:r>
               <a:rPr lang="en-US" sz="1200" b="1" spc="200" kern="0" dirty="0">
                 <a:solidFill>
-                  <a:schemeClr val="accent1"/>
+                  <a:schemeClr val="accent4"/>
                 </a:solidFill>
               </a:rPr>
               <a:t>OUR APPROACH</a:t>
@@ -15974,7 +16037,7 @@
             <a:avLst/>
           </a:prstGeom>
           <a:solidFill>
-            <a:schemeClr val="accent1"/>
+            <a:schemeClr val="accent3"/>
           </a:solidFill>
           <a:ln/>
         </p:spPr>
@@ -16278,7 +16341,7 @@
             <a:avLst/>
           </a:prstGeom>
           <a:solidFill>
-            <a:schemeClr val="accent3"/>
+            <a:schemeClr val="accent1"/>
           </a:solidFill>
           <a:ln/>
         </p:spPr>
@@ -16392,13 +16455,18 @@
           </a:xfrm>
           <a:prstGeom prst="roundRect">
             <a:avLst>
-              <a:gd name="adj" fmla="val 4848"/>
+              <a:gd name="adj" fmla="val 3030"/>
             </a:avLst>
           </a:prstGeom>
           <a:solidFill>
             <a:schemeClr val="bg2"/>
           </a:solidFill>
-          <a:ln/>
+          <a:ln w="9525">
+            <a:solidFill>
+              <a:srgbClr val="DDE2E7"/>
+            </a:solidFill>
+            <a:prstDash val="solid"/>
+          </a:ln>
         </p:spPr>
       </p:sp>
       <p:sp>
@@ -16486,13 +16554,18 @@
           </a:xfrm>
           <a:prstGeom prst="roundRect">
             <a:avLst>
-              <a:gd name="adj" fmla="val 4848"/>
+              <a:gd name="adj" fmla="val 3030"/>
             </a:avLst>
           </a:prstGeom>
           <a:solidFill>
             <a:schemeClr val="bg2"/>
           </a:solidFill>
-          <a:ln/>
+          <a:ln w="9525">
+            <a:solidFill>
+              <a:srgbClr val="DDE2E7"/>
+            </a:solidFill>
+            <a:prstDash val="solid"/>
+          </a:ln>
         </p:spPr>
       </p:sp>
       <p:sp>
@@ -16580,13 +16653,18 @@
           </a:xfrm>
           <a:prstGeom prst="roundRect">
             <a:avLst>
-              <a:gd name="adj" fmla="val 4848"/>
+              <a:gd name="adj" fmla="val 3030"/>
             </a:avLst>
           </a:prstGeom>
           <a:solidFill>
             <a:schemeClr val="bg2"/>
           </a:solidFill>
-          <a:ln/>
+          <a:ln w="9525">
+            <a:solidFill>
+              <a:srgbClr val="DDE2E7"/>
+            </a:solidFill>
+            <a:prstDash val="solid"/>
+          </a:ln>
         </p:spPr>
       </p:sp>
       <p:sp>
@@ -16760,7 +16838,7 @@
             <a:r>
               <a:rPr lang="en-US" sz="1200" b="1" spc="200" kern="0" dirty="0">
                 <a:solidFill>
-                  <a:schemeClr val="accent1"/>
+                  <a:schemeClr val="accent4"/>
                 </a:solidFill>
               </a:rPr>
               <a:t>THE DATA</a:t>
@@ -16858,7 +16936,7 @@
             <a:avLst/>
           </a:prstGeom>
           <a:solidFill>
-            <a:schemeClr val="accent2"/>
+            <a:schemeClr val="accent1"/>
           </a:solidFill>
           <a:ln/>
         </p:spPr>
@@ -16950,7 +17028,7 @@
             <a:r>
               <a:rPr lang="en-US" sz="1300" dirty="0">
                 <a:solidFill>
-                  <a:srgbClr val="5B6B75"/>
+                  <a:srgbClr val="76838F"/>
                 </a:solidFill>
               </a:rPr>
               <a:t>Daily rainfall and temperature, 1990-2026</a:t>
@@ -16974,7 +17052,7 @@
             <a:avLst/>
           </a:prstGeom>
           <a:solidFill>
-            <a:schemeClr val="accent2"/>
+            <a:schemeClr val="accent1"/>
           </a:solidFill>
           <a:ln/>
         </p:spPr>
@@ -17066,7 +17144,7 @@
             <a:r>
               <a:rPr lang="en-US" sz="1300" dirty="0">
                 <a:solidFill>
-                  <a:srgbClr val="5B6B75"/>
+                  <a:srgbClr val="76838F"/>
                 </a:solidFill>
               </a:rPr>
               <a:t>Elevation, river size, distance to rivers</a:t>
@@ -17090,7 +17168,7 @@
             <a:avLst/>
           </a:prstGeom>
           <a:solidFill>
-            <a:schemeClr val="accent2"/>
+            <a:schemeClr val="accent1"/>
           </a:solidFill>
           <a:ln/>
         </p:spPr>
@@ -17182,7 +17260,7 @@
             <a:r>
               <a:rPr lang="en-US" sz="1300" dirty="0">
                 <a:solidFill>
-                  <a:srgbClr val="5B6B75"/>
+                  <a:srgbClr val="76838F"/>
                 </a:solidFill>
               </a:rPr>
               <a:t>Population, hospitals, schools, roads, hydropower</a:t>
@@ -17206,7 +17284,7 @@
             <a:avLst/>
           </a:prstGeom>
           <a:solidFill>
-            <a:schemeClr val="accent2"/>
+            <a:schemeClr val="accent1"/>
           </a:solidFill>
           <a:ln/>
         </p:spPr>
@@ -17298,7 +17376,7 @@
             <a:r>
               <a:rPr lang="en-US" sz="1300" dirty="0">
                 <a:solidFill>
-                  <a:srgbClr val="5B6B75"/>
+                  <a:srgbClr val="76838F"/>
                 </a:solidFill>
               </a:rPr>
               <a:t>12,341 floods, landslides and rain events after removing duplicates</a:t>
@@ -17356,13 +17434,18 @@
           </a:xfrm>
           <a:prstGeom prst="roundRect">
             <a:avLst>
-              <a:gd name="adj" fmla="val 4000"/>
+              <a:gd name="adj" fmla="val 2500"/>
             </a:avLst>
           </a:prstGeom>
           <a:solidFill>
             <a:schemeClr val="bg2"/>
           </a:solidFill>
-          <a:ln/>
+          <a:ln w="9525">
+            <a:solidFill>
+              <a:srgbClr val="DDE2E7"/>
+            </a:solidFill>
+            <a:prstDash val="solid"/>
+          </a:ln>
         </p:spPr>
       </p:sp>
       <p:sp>
@@ -17450,13 +17533,18 @@
           </a:xfrm>
           <a:prstGeom prst="roundRect">
             <a:avLst>
-              <a:gd name="adj" fmla="val 4000"/>
+              <a:gd name="adj" fmla="val 2500"/>
             </a:avLst>
           </a:prstGeom>
           <a:solidFill>
             <a:schemeClr val="bg2"/>
           </a:solidFill>
-          <a:ln/>
+          <a:ln w="9525">
+            <a:solidFill>
+              <a:srgbClr val="DDE2E7"/>
+            </a:solidFill>
+            <a:prstDash val="solid"/>
+          </a:ln>
         </p:spPr>
       </p:sp>
       <p:sp>
@@ -17544,13 +17632,18 @@
           </a:xfrm>
           <a:prstGeom prst="roundRect">
             <a:avLst>
-              <a:gd name="adj" fmla="val 4000"/>
+              <a:gd name="adj" fmla="val 2500"/>
             </a:avLst>
           </a:prstGeom>
           <a:solidFill>
             <a:schemeClr val="bg2"/>
           </a:solidFill>
-          <a:ln/>
+          <a:ln w="9525">
+            <a:solidFill>
+              <a:srgbClr val="DDE2E7"/>
+            </a:solidFill>
+            <a:prstDash val="solid"/>
+          </a:ln>
         </p:spPr>
       </p:sp>
       <p:sp>
@@ -17638,13 +17731,18 @@
           </a:xfrm>
           <a:prstGeom prst="roundRect">
             <a:avLst>
-              <a:gd name="adj" fmla="val 4000"/>
+              <a:gd name="adj" fmla="val 2500"/>
             </a:avLst>
           </a:prstGeom>
           <a:solidFill>
             <a:schemeClr val="bg2"/>
           </a:solidFill>
-          <a:ln/>
+          <a:ln w="9525">
+            <a:solidFill>
+              <a:srgbClr val="DDE2E7"/>
+            </a:solidFill>
+            <a:prstDash val="solid"/>
+          </a:ln>
         </p:spPr>
       </p:sp>
       <p:sp>
@@ -17818,7 +17916,7 @@
             <a:r>
               <a:rPr lang="en-US" sz="1200" b="1" spc="200" kern="0" dirty="0">
                 <a:solidFill>
-                  <a:schemeClr val="accent1"/>
+                  <a:schemeClr val="accent4"/>
                 </a:solidFill>
               </a:rPr>
               <a:t>CLIMATE  |  2004-2025</a:t>
@@ -17878,13 +17976,18 @@
           </a:xfrm>
           <a:prstGeom prst="roundRect">
             <a:avLst>
-              <a:gd name="adj" fmla="val 50000"/>
+              <a:gd name="adj" fmla="val 12500"/>
             </a:avLst>
           </a:prstGeom>
           <a:solidFill>
-            <a:schemeClr val="accent2"/>
+            <a:schemeClr val="bg1"/>
           </a:solidFill>
-          <a:ln/>
+          <a:ln w="9525">
+            <a:solidFill>
+              <a:srgbClr val="C7D1DE"/>
+            </a:solidFill>
+            <a:prstDash val="solid"/>
+          </a:ln>
         </p:spPr>
       </p:sp>
       <p:sp>
@@ -17912,14 +18015,17 @@
               <a:buNone/>
             </a:pPr>
             <a:r>
-              <a:rPr lang="en-US" sz="1200" b="1" dirty="0">
-                <a:solidFill>
-                  <a:schemeClr val="bg1"/>
-                </a:solidFill>
+              <a:rPr lang="en-US" sz="1100" b="1" dirty="0">
+                <a:solidFill>
+                  <a:schemeClr val="accent1"/>
+                </a:solidFill>
+                <a:latin typeface="Consolas" pitchFamily="34" charset="0"/>
+                <a:ea typeface="Consolas" pitchFamily="34" charset="-122"/>
+                <a:cs typeface="Consolas" pitchFamily="34" charset="-120"/>
               </a:rPr>
               <a:t>F1</a:t>
             </a:r>
-            <a:endParaRPr lang="en-US" sz="1200" dirty="0"/>
+            <a:endParaRPr lang="en-US" sz="1100" dirty="0"/>
           </a:p>
         </p:txBody>
       </p:sp>
@@ -17966,11 +18072,11 @@
             <a:r>
               <a:rPr lang="en-US" sz="4000" b="1" dirty="0">
                 <a:solidFill>
-                  <a:schemeClr val="accent1"/>
-                </a:solidFill>
-                <a:latin typeface="Cambria" pitchFamily="34" charset="0"/>
-                <a:ea typeface="Cambria" pitchFamily="34" charset="-122"/>
-                <a:cs typeface="Cambria" pitchFamily="34" charset="-120"/>
+                  <a:schemeClr val="tx1"/>
+                </a:solidFill>
+                <a:latin typeface="Calibri" pitchFamily="34" charset="0"/>
+                <a:ea typeface="Calibri" pitchFamily="34" charset="-122"/>
+                <a:cs typeface="Calibri" pitchFamily="34" charset="-120"/>
               </a:rPr>
               <a:t>+22.1 mm</a:t>
             </a:r>
@@ -18041,11 +18147,11 @@
             <a:r>
               <a:rPr lang="en-US" sz="4000" b="1" dirty="0">
                 <a:solidFill>
-                  <a:schemeClr val="accent1"/>
-                </a:solidFill>
-                <a:latin typeface="Cambria" pitchFamily="34" charset="0"/>
-                <a:ea typeface="Cambria" pitchFamily="34" charset="-122"/>
-                <a:cs typeface="Cambria" pitchFamily="34" charset="-120"/>
+                  <a:schemeClr val="tx1"/>
+                </a:solidFill>
+                <a:latin typeface="Calibri" pitchFamily="34" charset="0"/>
+                <a:ea typeface="Calibri" pitchFamily="34" charset="-122"/>
+                <a:cs typeface="Calibri" pitchFamily="34" charset="-120"/>
               </a:rPr>
               <a:t>+27%</a:t>
             </a:r>
@@ -18116,11 +18222,11 @@
             <a:r>
               <a:rPr lang="en-US" sz="4000" b="1" dirty="0">
                 <a:solidFill>
-                  <a:schemeClr val="accent1"/>
-                </a:solidFill>
-                <a:latin typeface="Cambria" pitchFamily="34" charset="0"/>
-                <a:ea typeface="Cambria" pitchFamily="34" charset="-122"/>
-                <a:cs typeface="Cambria" pitchFamily="34" charset="-120"/>
+                  <a:schemeClr val="tx1"/>
+                </a:solidFill>
+                <a:latin typeface="Calibri" pitchFamily="34" charset="0"/>
+                <a:ea typeface="Calibri" pitchFamily="34" charset="-122"/>
+                <a:cs typeface="Calibri" pitchFamily="34" charset="-120"/>
               </a:rPr>
               <a:t>33 of 45</a:t>
             </a:r>
@@ -18263,7 +18369,7 @@
             <a:r>
               <a:rPr lang="en-US" sz="1200" b="1" spc="200" kern="0" dirty="0">
                 <a:solidFill>
-                  <a:schemeClr val="accent1"/>
+                  <a:schemeClr val="accent4"/>
                 </a:solidFill>
               </a:rPr>
               <a:t>CLIMATE  |  EXTREMES</a:t>
@@ -18323,13 +18429,18 @@
           </a:xfrm>
           <a:prstGeom prst="roundRect">
             <a:avLst>
-              <a:gd name="adj" fmla="val 50000"/>
+              <a:gd name="adj" fmla="val 12500"/>
             </a:avLst>
           </a:prstGeom>
           <a:solidFill>
-            <a:schemeClr val="accent2"/>
+            <a:schemeClr val="bg1"/>
           </a:solidFill>
-          <a:ln/>
+          <a:ln w="9525">
+            <a:solidFill>
+              <a:srgbClr val="C7D1DE"/>
+            </a:solidFill>
+            <a:prstDash val="solid"/>
+          </a:ln>
         </p:spPr>
       </p:sp>
       <p:sp>
@@ -18357,14 +18468,17 @@
               <a:buNone/>
             </a:pPr>
             <a:r>
-              <a:rPr lang="en-US" sz="1200" b="1" dirty="0">
-                <a:solidFill>
-                  <a:schemeClr val="bg1"/>
-                </a:solidFill>
+              <a:rPr lang="en-US" sz="1100" b="1" dirty="0">
+                <a:solidFill>
+                  <a:schemeClr val="accent1"/>
+                </a:solidFill>
+                <a:latin typeface="Consolas" pitchFamily="34" charset="0"/>
+                <a:ea typeface="Consolas" pitchFamily="34" charset="-122"/>
+                <a:cs typeface="Consolas" pitchFamily="34" charset="-120"/>
               </a:rPr>
               <a:t>F2</a:t>
             </a:r>
-            <a:endParaRPr lang="en-US" sz="1200" dirty="0"/>
+            <a:endParaRPr lang="en-US" sz="1100" dirty="0"/>
           </a:p>
         </p:txBody>
       </p:sp>
@@ -18381,13 +18495,18 @@
           </a:xfrm>
           <a:prstGeom prst="roundRect">
             <a:avLst>
-              <a:gd name="adj" fmla="val 50000"/>
+              <a:gd name="adj" fmla="val 12500"/>
             </a:avLst>
           </a:prstGeom>
           <a:solidFill>
-            <a:schemeClr val="accent2"/>
+            <a:schemeClr val="bg1"/>
           </a:solidFill>
-          <a:ln/>
+          <a:ln w="9525">
+            <a:solidFill>
+              <a:srgbClr val="C7D1DE"/>
+            </a:solidFill>
+            <a:prstDash val="solid"/>
+          </a:ln>
         </p:spPr>
       </p:sp>
       <p:sp>
@@ -18415,14 +18534,17 @@
               <a:buNone/>
             </a:pPr>
             <a:r>
-              <a:rPr lang="en-US" sz="1200" b="1" dirty="0">
-                <a:solidFill>
-                  <a:schemeClr val="bg1"/>
-                </a:solidFill>
+              <a:rPr lang="en-US" sz="1100" b="1" dirty="0">
+                <a:solidFill>
+                  <a:schemeClr val="accent1"/>
+                </a:solidFill>
+                <a:latin typeface="Consolas" pitchFamily="34" charset="0"/>
+                <a:ea typeface="Consolas" pitchFamily="34" charset="-122"/>
+                <a:cs typeface="Consolas" pitchFamily="34" charset="-120"/>
               </a:rPr>
               <a:t>F3</a:t>
             </a:r>
-            <a:endParaRPr lang="en-US" sz="1200" dirty="0"/>
+            <a:endParaRPr lang="en-US" sz="1100" dirty="0"/>
           </a:p>
         </p:txBody>
       </p:sp>
@@ -18469,11 +18591,11 @@
             <a:r>
               <a:rPr lang="en-US" sz="4000" b="1" dirty="0">
                 <a:solidFill>
-                  <a:schemeClr val="accent1"/>
-                </a:solidFill>
-                <a:latin typeface="Cambria" pitchFamily="34" charset="0"/>
-                <a:ea typeface="Cambria" pitchFamily="34" charset="-122"/>
-                <a:cs typeface="Cambria" pitchFamily="34" charset="-120"/>
+                  <a:schemeClr val="tx1"/>
+                </a:solidFill>
+                <a:latin typeface="Calibri" pitchFamily="34" charset="0"/>
+                <a:ea typeface="Calibri" pitchFamily="34" charset="-122"/>
+                <a:cs typeface="Calibri" pitchFamily="34" charset="-120"/>
               </a:rPr>
               <a:t>6.0 → 8.9</a:t>
             </a:r>
@@ -18530,7 +18652,7 @@
           </a:xfrm>
           <a:prstGeom prst="roundRect">
             <a:avLst>
-              <a:gd name="adj" fmla="val 2581"/>
+              <a:gd name="adj" fmla="val 1613"/>
             </a:avLst>
           </a:prstGeom>
           <a:solidFill>
@@ -18566,7 +18688,7 @@
             <a:r>
               <a:rPr lang="en-US" sz="1700" b="1" dirty="0">
                 <a:solidFill>
-                  <a:schemeClr val="accent3"/>
+                  <a:schemeClr val="bg1"/>
                 </a:solidFill>
               </a:rPr>
               <a:t>But 26 August was an ordinary rain day</a:t>
@@ -18710,7 +18832,7 @@
             <a:r>
               <a:rPr lang="en-US" sz="1200" b="1" spc="200" kern="0" dirty="0">
                 <a:solidFill>
-                  <a:schemeClr val="accent1"/>
+                  <a:schemeClr val="accent4"/>
                 </a:solidFill>
               </a:rPr>
               <a:t>TERRAIN AND RIVERS</a:t>
@@ -18770,13 +18892,18 @@
           </a:xfrm>
           <a:prstGeom prst="roundRect">
             <a:avLst>
-              <a:gd name="adj" fmla="val 50000"/>
+              <a:gd name="adj" fmla="val 12500"/>
             </a:avLst>
           </a:prstGeom>
           <a:solidFill>
-            <a:schemeClr val="accent2"/>
+            <a:schemeClr val="bg1"/>
           </a:solidFill>
-          <a:ln/>
+          <a:ln w="9525">
+            <a:solidFill>
+              <a:srgbClr val="C7D1DE"/>
+            </a:solidFill>
+            <a:prstDash val="solid"/>
+          </a:ln>
         </p:spPr>
       </p:sp>
       <p:sp>
@@ -18804,14 +18931,17 @@
               <a:buNone/>
             </a:pPr>
             <a:r>
-              <a:rPr lang="en-US" sz="1200" b="1" dirty="0">
-                <a:solidFill>
-                  <a:schemeClr val="bg1"/>
-                </a:solidFill>
+              <a:rPr lang="en-US" sz="1100" b="1" dirty="0">
+                <a:solidFill>
+                  <a:schemeClr val="accent1"/>
+                </a:solidFill>
+                <a:latin typeface="Consolas" pitchFamily="34" charset="0"/>
+                <a:ea typeface="Consolas" pitchFamily="34" charset="-122"/>
+                <a:cs typeface="Consolas" pitchFamily="34" charset="-120"/>
               </a:rPr>
               <a:t>F4</a:t>
             </a:r>
-            <a:endParaRPr lang="en-US" sz="1200" dirty="0"/>
+            <a:endParaRPr lang="en-US" sz="1100" dirty="0"/>
           </a:p>
         </p:txBody>
       </p:sp>
@@ -18880,13 +19010,18 @@
           </a:xfrm>
           <a:prstGeom prst="roundRect">
             <a:avLst>
-              <a:gd name="adj" fmla="val 17391"/>
+              <a:gd name="adj" fmla="val 10870"/>
             </a:avLst>
           </a:prstGeom>
           <a:solidFill>
             <a:schemeClr val="bg2"/>
           </a:solidFill>
-          <a:ln/>
+          <a:ln w="9525">
+            <a:solidFill>
+              <a:srgbClr val="DDE2E7"/>
+            </a:solidFill>
+            <a:prstDash val="solid"/>
+          </a:ln>
         </p:spPr>
       </p:sp>
       <p:sp>
@@ -18938,13 +19073,18 @@
           </a:xfrm>
           <a:prstGeom prst="roundRect">
             <a:avLst>
-              <a:gd name="adj" fmla="val 17391"/>
+              <a:gd name="adj" fmla="val 10870"/>
             </a:avLst>
           </a:prstGeom>
           <a:solidFill>
             <a:schemeClr val="bg2"/>
           </a:solidFill>
-          <a:ln/>
+          <a:ln w="9525">
+            <a:solidFill>
+              <a:srgbClr val="DDE2E7"/>
+            </a:solidFill>
+            <a:prstDash val="solid"/>
+          </a:ln>
         </p:spPr>
       </p:sp>
       <p:sp>
@@ -18996,13 +19136,18 @@
           </a:xfrm>
           <a:prstGeom prst="roundRect">
             <a:avLst>
-              <a:gd name="adj" fmla="val 17391"/>
+              <a:gd name="adj" fmla="val 10870"/>
             </a:avLst>
           </a:prstGeom>
           <a:solidFill>
             <a:schemeClr val="bg2"/>
           </a:solidFill>
-          <a:ln/>
+          <a:ln w="9525">
+            <a:solidFill>
+              <a:srgbClr val="DDE2E7"/>
+            </a:solidFill>
+            <a:prstDash val="solid"/>
+          </a:ln>
         </p:spPr>
       </p:sp>
       <p:sp>
@@ -19054,13 +19199,18 @@
           </a:xfrm>
           <a:prstGeom prst="roundRect">
             <a:avLst>
-              <a:gd name="adj" fmla="val 17391"/>
+              <a:gd name="adj" fmla="val 10870"/>
             </a:avLst>
           </a:prstGeom>
           <a:solidFill>
             <a:schemeClr val="bg2"/>
           </a:solidFill>
-          <a:ln/>
+          <a:ln w="9525">
+            <a:solidFill>
+              <a:srgbClr val="DDE2E7"/>
+            </a:solidFill>
+            <a:prstDash val="solid"/>
+          </a:ln>
         </p:spPr>
       </p:sp>
       <p:sp>
@@ -19112,13 +19262,18 @@
           </a:xfrm>
           <a:prstGeom prst="roundRect">
             <a:avLst>
-              <a:gd name="adj" fmla="val 17391"/>
+              <a:gd name="adj" fmla="val 10870"/>
             </a:avLst>
           </a:prstGeom>
           <a:solidFill>
             <a:schemeClr val="bg2"/>
           </a:solidFill>
-          <a:ln/>
+          <a:ln w="9525">
+            <a:solidFill>
+              <a:srgbClr val="DDE2E7"/>
+            </a:solidFill>
+            <a:prstDash val="solid"/>
+          </a:ln>
         </p:spPr>
       </p:sp>
       <p:sp>
@@ -19170,13 +19325,18 @@
           </a:xfrm>
           <a:prstGeom prst="roundRect">
             <a:avLst>
-              <a:gd name="adj" fmla="val 17391"/>
+              <a:gd name="adj" fmla="val 10870"/>
             </a:avLst>
           </a:prstGeom>
           <a:solidFill>
             <a:schemeClr val="bg2"/>
           </a:solidFill>
-          <a:ln/>
+          <a:ln w="9525">
+            <a:solidFill>
+              <a:srgbClr val="DDE2E7"/>
+            </a:solidFill>
+            <a:prstDash val="solid"/>
+          </a:ln>
         </p:spPr>
       </p:sp>
       <p:sp>
@@ -19228,13 +19388,18 @@
           </a:xfrm>
           <a:prstGeom prst="roundRect">
             <a:avLst>
-              <a:gd name="adj" fmla="val 17391"/>
+              <a:gd name="adj" fmla="val 10870"/>
             </a:avLst>
           </a:prstGeom>
           <a:solidFill>
             <a:schemeClr val="bg2"/>
           </a:solidFill>
-          <a:ln/>
+          <a:ln w="9525">
+            <a:solidFill>
+              <a:srgbClr val="DDE2E7"/>
+            </a:solidFill>
+            <a:prstDash val="solid"/>
+          </a:ln>
         </p:spPr>
       </p:sp>
       <p:sp>
@@ -19286,13 +19451,18 @@
           </a:xfrm>
           <a:prstGeom prst="roundRect">
             <a:avLst>
-              <a:gd name="adj" fmla="val 17391"/>
+              <a:gd name="adj" fmla="val 10870"/>
             </a:avLst>
           </a:prstGeom>
           <a:solidFill>
             <a:schemeClr val="bg2"/>
           </a:solidFill>
-          <a:ln/>
+          <a:ln w="9525">
+            <a:solidFill>
+              <a:srgbClr val="DDE2E7"/>
+            </a:solidFill>
+            <a:prstDash val="solid"/>
+          </a:ln>
         </p:spPr>
       </p:sp>
       <p:sp>
@@ -19405,7 +19575,7 @@
             <a:r>
               <a:rPr lang="en-US" sz="1100" i="1" dirty="0">
                 <a:solidFill>
-                  <a:srgbClr val="5B6B75"/>
+                  <a:srgbClr val="76838F"/>
                 </a:solidFill>
               </a:rPr>
               <a:t>Ruggedness = spread of elevation within the district (supplied slope data is corrupted).</a:t>
@@ -19513,7 +19683,7 @@
             <a:r>
               <a:rPr lang="en-US" sz="1200" b="1" spc="200" kern="0" dirty="0">
                 <a:solidFill>
-                  <a:schemeClr val="accent1"/>
+                  <a:schemeClr val="accent4"/>
                 </a:solidFill>
               </a:rPr>
               <a:t>EXPOSURE AND VULNERABILITY</a:t>
@@ -19573,13 +19743,18 @@
           </a:xfrm>
           <a:prstGeom prst="roundRect">
             <a:avLst>
-              <a:gd name="adj" fmla="val 50000"/>
+              <a:gd name="adj" fmla="val 12500"/>
             </a:avLst>
           </a:prstGeom>
           <a:solidFill>
-            <a:schemeClr val="accent2"/>
+            <a:schemeClr val="bg1"/>
           </a:solidFill>
-          <a:ln/>
+          <a:ln w="9525">
+            <a:solidFill>
+              <a:srgbClr val="C7D1DE"/>
+            </a:solidFill>
+            <a:prstDash val="solid"/>
+          </a:ln>
         </p:spPr>
       </p:sp>
       <p:sp>
@@ -19607,14 +19782,17 @@
               <a:buNone/>
             </a:pPr>
             <a:r>
-              <a:rPr lang="en-US" sz="1200" b="1" dirty="0">
-                <a:solidFill>
-                  <a:schemeClr val="bg1"/>
-                </a:solidFill>
+              <a:rPr lang="en-US" sz="1100" b="1" dirty="0">
+                <a:solidFill>
+                  <a:schemeClr val="accent1"/>
+                </a:solidFill>
+                <a:latin typeface="Consolas" pitchFamily="34" charset="0"/>
+                <a:ea typeface="Consolas" pitchFamily="34" charset="-122"/>
+                <a:cs typeface="Consolas" pitchFamily="34" charset="-120"/>
               </a:rPr>
               <a:t>F5</a:t>
             </a:r>
-            <a:endParaRPr lang="en-US" sz="1200" dirty="0"/>
+            <a:endParaRPr lang="en-US" sz="1100" dirty="0"/>
           </a:p>
         </p:txBody>
       </p:sp>
@@ -19631,13 +19809,18 @@
           </a:xfrm>
           <a:prstGeom prst="roundRect">
             <a:avLst>
-              <a:gd name="adj" fmla="val 50000"/>
+              <a:gd name="adj" fmla="val 12500"/>
             </a:avLst>
           </a:prstGeom>
           <a:solidFill>
-            <a:schemeClr val="accent2"/>
+            <a:schemeClr val="bg1"/>
           </a:solidFill>
-          <a:ln/>
+          <a:ln w="9525">
+            <a:solidFill>
+              <a:srgbClr val="C7D1DE"/>
+            </a:solidFill>
+            <a:prstDash val="solid"/>
+          </a:ln>
         </p:spPr>
       </p:sp>
       <p:sp>
@@ -19665,14 +19848,17 @@
               <a:buNone/>
             </a:pPr>
             <a:r>
-              <a:rPr lang="en-US" sz="1200" b="1" dirty="0">
-                <a:solidFill>
-                  <a:schemeClr val="bg1"/>
-                </a:solidFill>
+              <a:rPr lang="en-US" sz="1100" b="1" dirty="0">
+                <a:solidFill>
+                  <a:schemeClr val="accent1"/>
+                </a:solidFill>
+                <a:latin typeface="Consolas" pitchFamily="34" charset="0"/>
+                <a:ea typeface="Consolas" pitchFamily="34" charset="-122"/>
+                <a:cs typeface="Consolas" pitchFamily="34" charset="-120"/>
               </a:rPr>
               <a:t>F6</a:t>
             </a:r>
-            <a:endParaRPr lang="en-US" sz="1200" dirty="0"/>
+            <a:endParaRPr lang="en-US" sz="1100" dirty="0"/>
           </a:p>
         </p:txBody>
       </p:sp>
@@ -19879,7 +20065,7 @@
             <a:r>
               <a:rPr lang="en-US" sz="1200" b="1" spc="200" kern="0" dirty="0">
                 <a:solidFill>
-                  <a:schemeClr val="accent1"/>
+                  <a:schemeClr val="accent4"/>
                 </a:solidFill>
               </a:rPr>
               <a:t>THE RISK INDEX</a:t>
@@ -19939,11 +20125,11 @@
           </a:xfrm>
           <a:prstGeom prst="roundRect">
             <a:avLst>
-              <a:gd name="adj" fmla="val 3810"/>
+              <a:gd name="adj" fmla="val 2381"/>
             </a:avLst>
           </a:prstGeom>
           <a:solidFill>
-            <a:schemeClr val="accent1"/>
+            <a:schemeClr val="accent3"/>
           </a:solidFill>
           <a:ln/>
         </p:spPr>
@@ -20083,7 +20269,7 @@
           </a:xfrm>
           <a:prstGeom prst="roundRect">
             <a:avLst>
-              <a:gd name="adj" fmla="val 3810"/>
+              <a:gd name="adj" fmla="val 2381"/>
             </a:avLst>
           </a:prstGeom>
           <a:solidFill>
@@ -20213,11 +20399,11 @@
           </a:xfrm>
           <a:prstGeom prst="roundRect">
             <a:avLst>
-              <a:gd name="adj" fmla="val 3810"/>
+              <a:gd name="adj" fmla="val 2381"/>
             </a:avLst>
           </a:prstGeom>
           <a:solidFill>
-            <a:schemeClr val="accent3"/>
+            <a:schemeClr val="accent4"/>
           </a:solidFill>
           <a:ln/>
         </p:spPr>
@@ -20343,7 +20529,7 @@
           </a:xfrm>
           <a:prstGeom prst="roundRect">
             <a:avLst>
-              <a:gd name="adj" fmla="val 3810"/>
+              <a:gd name="adj" fmla="val 2381"/>
             </a:avLst>
           </a:prstGeom>
           <a:solidFill>
@@ -20379,7 +20565,7 @@
             <a:r>
               <a:rPr lang="en-US" sz="1600" b="1" spc="100" kern="0" dirty="0">
                 <a:solidFill>
-                  <a:schemeClr val="accent3"/>
+                  <a:schemeClr val="accent6"/>
                 </a:solidFill>
               </a:rPr>
               <a:t>RISK</a:t>
@@ -20437,13 +20623,18 @@
           </a:xfrm>
           <a:prstGeom prst="roundRect">
             <a:avLst>
-              <a:gd name="adj" fmla="val 3404"/>
+              <a:gd name="adj" fmla="val 2128"/>
             </a:avLst>
           </a:prstGeom>
           <a:solidFill>
             <a:schemeClr val="bg2"/>
           </a:solidFill>
-          <a:ln/>
+          <a:ln w="9525">
+            <a:solidFill>
+              <a:srgbClr val="DDE2E7"/>
+            </a:solidFill>
+            <a:prstDash val="solid"/>
+          </a:ln>
         </p:spPr>
       </p:sp>
       <p:sp>
@@ -20575,13 +20766,18 @@
           </a:xfrm>
           <a:prstGeom prst="roundRect">
             <a:avLst>
-              <a:gd name="adj" fmla="val 3404"/>
+              <a:gd name="adj" fmla="val 2128"/>
             </a:avLst>
           </a:prstGeom>
           <a:solidFill>
             <a:schemeClr val="bg2"/>
           </a:solidFill>
-          <a:ln/>
+          <a:ln w="9525">
+            <a:solidFill>
+              <a:srgbClr val="DDE2E7"/>
+            </a:solidFill>
+            <a:prstDash val="solid"/>
+          </a:ln>
         </p:spPr>
       </p:sp>
       <p:sp>
@@ -20713,13 +20909,18 @@
           </a:xfrm>
           <a:prstGeom prst="roundRect">
             <a:avLst>
-              <a:gd name="adj" fmla="val 3404"/>
+              <a:gd name="adj" fmla="val 2128"/>
             </a:avLst>
           </a:prstGeom>
           <a:solidFill>
             <a:schemeClr val="bg2"/>
           </a:solidFill>
-          <a:ln/>
+          <a:ln w="9525">
+            <a:solidFill>
+              <a:srgbClr val="DDE2E7"/>
+            </a:solidFill>
+            <a:prstDash val="solid"/>
+          </a:ln>
         </p:spPr>
       </p:sp>
       <p:sp>
@@ -20896,45 +21097,45 @@
   <a:themeElements>
     <a:clrScheme name="Himalaya Risk">
       <a:dk1>
-        <a:srgbClr val="1B2A33"/>
+        <a:srgbClr val="14202B"/>
       </a:dk1>
       <a:lt1>
         <a:srgbClr val="FFFFFF"/>
       </a:lt1>
       <a:dk2>
-        <a:srgbClr val="14324A"/>
+        <a:srgbClr val="1F3A5F"/>
       </a:dk2>
       <a:lt2>
-        <a:srgbClr val="EAF0F3"/>
+        <a:srgbClr val="F5F7F9"/>
       </a:lt2>
       <a:accent1>
-        <a:srgbClr val="C8553D"/>
+        <a:srgbClr val="1F3A5F"/>
       </a:accent1>
       <a:accent2>
-        <a:srgbClr val="2A7F8E"/>
+        <a:srgbClr val="3B5BA9"/>
       </a:accent2>
       <a:accent3>
-        <a:srgbClr val="E0A030"/>
+        <a:srgbClr val="B8243B"/>
       </a:accent3>
       <a:accent4>
-        <a:srgbClr val="6B8496"/>
+        <a:srgbClr val="76838F"/>
       </a:accent4>
       <a:accent5>
-        <a:srgbClr val="7FA38F"/>
+        <a:srgbClr val="2462A3"/>
       </a:accent5>
       <a:accent6>
-        <a:srgbClr val="B7C4CC"/>
+        <a:srgbClr val="C9D1D9"/>
       </a:accent6>
       <a:hlink>
-        <a:srgbClr val="2A7F8E"/>
+        <a:srgbClr val="2F4FA0"/>
       </a:hlink>
       <a:folHlink>
-        <a:srgbClr val="6B8496"/>
+        <a:srgbClr val="76838F"/>
       </a:folHlink>
     </a:clrScheme>
     <a:fontScheme name="Himalaya Risk">
       <a:majorFont>
-        <a:latin typeface="Cambria"/>
+        <a:latin typeface="Calibri"/>
         <a:ea typeface=""/>
         <a:cs typeface=""/>
         <a:font script="Jpan" typeface="游ゴシック Light"/>

</xml_diff>

<commit_message>
Restyle slide deck to the Intelligence Platform design
</commit_message>
<xml_diff>
--- a/Nepal_Climate_Risk_Deck.pptx
+++ b/Nepal_Climate_Risk_Deck.pptx
@@ -124,7 +124,7 @@
   <p:extLst>
     <p:ext uri="{521415D9-36F7-43E2-AB2F-B90AF26B5E84}">
       <p14:sectionLst xmlns:p14="http://schemas.microsoft.com/office/powerpoint/2010/main">
-        <p14:section name="Introduction" id="{a912e774-3daa-c07a-d4bf-d7893a3b5be2}">
+        <p14:section name="Introduction" id="{d6230e0d-702e-eafe-8eb6-9a2287367ee6}">
           <p14:sldIdLst>
             <p14:sldId id="256"/>
             <p14:sldId id="257"/>
@@ -132,25 +132,25 @@
             <p14:sldId id="259"/>
           </p14:sldIdLst>
         </p14:section>
-        <p14:section name="Climate" id="{73d39a26-debd-5a6f-292b-e08e36241484}">
+        <p14:section name="Climate" id="{04d85eee-8ca6-6c30-de3f-dc9846ffd03b}">
           <p14:sldIdLst>
             <p14:sldId id="260"/>
             <p14:sldId id="261"/>
           </p14:sldIdLst>
         </p14:section>
-        <p14:section name="Terrain and exposure" id="{9b06eff9-6ce6-8ecf-475f-fb986c58ffb5}">
+        <p14:section name="Terrain and exposure" id="{94fa56bb-631b-7615-3fd4-36469c266cac}">
           <p14:sldIdLst>
             <p14:sldId id="262"/>
             <p14:sldId id="263"/>
           </p14:sldIdLst>
         </p14:section>
-        <p14:section name="Risk index" id="{06cf5988-3bd4-b1d4-c754-07885571d984}">
+        <p14:section name="Risk index" id="{81500c9f-35aa-149b-98bc-a4db1ee677f5}">
           <p14:sldIdLst>
             <p14:sldId id="264"/>
             <p14:sldId id="265"/>
           </p14:sldIdLst>
         </p14:section>
-        <p14:section name="Validation" id="{ff8f6ea5-b859-cd66-fcc4-1cfa37dd464f}">
+        <p14:section name="Validation" id="{7d27a51a-8c20-919c-14e2-5524b33577cb}">
           <p14:sldIdLst>
             <p14:sldId id="266"/>
             <p14:sldId id="267"/>
@@ -158,14 +158,14 @@
             <p14:sldId id="269"/>
           </p14:sldIdLst>
         </p14:section>
-        <p14:section name="Recommendation" id="{ad6fdf84-a44d-74b6-39cb-1d5bdd7d62f1}">
+        <p14:section name="Recommendation" id="{1208bc22-975b-863b-f7f4-21a2d6b3fbcf}">
           <p14:sldIdLst>
             <p14:sldId id="270"/>
             <p14:sldId id="271"/>
             <p14:sldId id="272"/>
           </p14:sldIdLst>
         </p14:section>
-        <p14:section name="Appendix" id="{026d652f-81fc-b2a3-f5fc-8cf79e9c0851}">
+        <p14:section name="Appendix" id="{5709a503-7b9f-424e-0c90-39755ce716ad}">
           <p14:sldIdLst>
             <p14:sldId id="273"/>
           </p14:sldIdLst>
@@ -193,7 +193,7 @@
             <a:pPr>
               <a:defRPr sz="1300" b="0" i="0" u="none" strike="noStrike">
                 <a:solidFill>
-                  <a:srgbClr val="1B2A33"/>
+                  <a:srgbClr val="112B49"/>
                 </a:solidFill>
                 <a:latin typeface="+mn-lt"/>
               </a:defRPr>
@@ -201,7 +201,7 @@
             <a:r>
               <a:rPr sz="1300" b="0" i="0" u="none" strike="noStrike">
                 <a:solidFill>
-                  <a:srgbClr val="1B2A33"/>
+                  <a:srgbClr val="112B49"/>
                 </a:solidFill>
                 <a:latin typeface="+mn-lt"/>
               </a:rPr>
@@ -234,11 +234,11 @@
           </c:tx>
           <c:spPr>
             <a:solidFill>
-              <a:srgbClr val="3B5BA9"/>
+              <a:srgbClr val="0072B2"/>
             </a:solidFill>
             <a:ln w="25400" cap="flat">
               <a:solidFill>
-                <a:srgbClr val="3B5BA9"/>
+                <a:srgbClr val="0072B2"/>
               </a:solidFill>
               <a:prstDash val="solid"/>
               <a:round/>
@@ -255,7 +255,7 @@
                 <a:pPr>
                   <a:defRPr b="0" i="0" strike="noStrike" sz="1100" u="none">
                     <a:solidFill>
-                      <a:srgbClr val="1B2A33"/>
+                      <a:srgbClr val="334155"/>
                     </a:solidFill>
                     <a:latin typeface="+mn-lt"/>
                   </a:defRPr>
@@ -275,11 +275,11 @@
             <c:size val="7"/>
             <c:spPr>
               <a:solidFill>
-                <a:srgbClr val="3B5BA9"/>
+                <a:srgbClr val="0072B2"/>
               </a:solidFill>
               <a:ln w="9525" cap="flat">
                 <a:solidFill>
-                  <a:srgbClr val="3B5BA9"/>
+                  <a:srgbClr val="0072B2"/>
                 </a:solidFill>
                 <a:prstDash val="solid"/>
                 <a:round/>
@@ -449,7 +449,7 @@
               <a:pPr>
                 <a:defRPr b="0" i="0" strike="noStrike" sz="1100" u="none">
                   <a:solidFill>
-                    <a:srgbClr val="1B2A33"/>
+                    <a:srgbClr val="334155"/>
                   </a:solidFill>
                   <a:latin typeface="+mn-lt"/>
                 </a:defRPr>
@@ -487,11 +487,11 @@
           </c:tx>
           <c:spPr>
             <a:solidFill>
-              <a:srgbClr val="B8243B"/>
+              <a:srgbClr val="D55E00"/>
             </a:solidFill>
             <a:ln w="25400" cap="flat">
               <a:solidFill>
-                <a:srgbClr val="B8243B"/>
+                <a:srgbClr val="D55E00"/>
               </a:solidFill>
               <a:prstDash val="dash"/>
               <a:round/>
@@ -508,7 +508,7 @@
                 <a:pPr>
                   <a:defRPr b="0" i="0" strike="noStrike" sz="1100" u="none">
                     <a:solidFill>
-                      <a:srgbClr val="1B2A33"/>
+                      <a:srgbClr val="334155"/>
                     </a:solidFill>
                     <a:latin typeface="+mn-lt"/>
                   </a:defRPr>
@@ -528,11 +528,11 @@
             <c:size val="6"/>
             <c:spPr>
               <a:solidFill>
-                <a:srgbClr val="B8243B"/>
+                <a:srgbClr val="D55E00"/>
               </a:solidFill>
               <a:ln w="9525" cap="flat">
                 <a:solidFill>
-                  <a:srgbClr val="B8243B"/>
+                  <a:srgbClr val="D55E00"/>
                 </a:solidFill>
                 <a:prstDash val="solid"/>
                 <a:round/>
@@ -702,7 +702,7 @@
               <a:pPr>
                 <a:defRPr b="0" i="0" strike="noStrike" sz="1100" u="none">
                   <a:solidFill>
-                    <a:srgbClr val="1B2A33"/>
+                    <a:srgbClr val="334155"/>
                   </a:solidFill>
                   <a:latin typeface="+mn-lt"/>
                 </a:defRPr>
@@ -736,7 +736,7 @@
         <c:spPr>
           <a:ln w="12700" cap="flat">
             <a:solidFill>
-              <a:srgbClr val="E3E7EB"/>
+              <a:srgbClr val="E2E8F0"/>
             </a:solidFill>
             <a:prstDash val="solid"/>
             <a:round/>
@@ -749,7 +749,7 @@
             <a:pPr>
               <a:defRPr sz="1100" b="0" i="0" u="none" strike="noStrike">
                 <a:solidFill>
-                  <a:srgbClr val="76838F"/>
+                  <a:srgbClr val="526579"/>
                 </a:solidFill>
                 <a:latin typeface="+mn-lt"/>
               </a:defRPr>
@@ -775,7 +775,7 @@
           <c:spPr>
             <a:ln w="9525" cap="flat">
               <a:solidFill>
-                <a:srgbClr val="E3E7EB"/>
+                <a:srgbClr val="E2E8F0"/>
               </a:solidFill>
               <a:prstDash val="solid"/>
               <a:round/>
@@ -800,7 +800,7 @@
             <a:pPr>
               <a:defRPr sz="1100" b="0" i="0" u="none" strike="noStrike">
                 <a:solidFill>
-                  <a:srgbClr val="76838F"/>
+                  <a:srgbClr val="526579"/>
                 </a:solidFill>
                 <a:latin typeface="+mn-lt"/>
               </a:defRPr>
@@ -830,7 +830,7 @@
           <a:pPr>
             <a:defRPr sz="1100">
               <a:solidFill>
-                <a:srgbClr val="76838F"/>
+                <a:srgbClr val="526579"/>
               </a:solidFill>
               <a:latin typeface="+mn-lt"/>
               <a:cs typeface="+mn-lt"/>
@@ -870,7 +870,7 @@
             <a:pPr>
               <a:defRPr sz="1300" b="0" i="0" u="none" strike="noStrike">
                 <a:solidFill>
-                  <a:srgbClr val="1B2A33"/>
+                  <a:srgbClr val="112B49"/>
                 </a:solidFill>
                 <a:latin typeface="+mn-lt"/>
               </a:defRPr>
@@ -878,7 +878,7 @@
             <a:r>
               <a:rPr sz="1300" b="0" i="0" u="none" strike="noStrike">
                 <a:solidFill>
-                  <a:srgbClr val="1B2A33"/>
+                  <a:srgbClr val="112B49"/>
                 </a:solidFill>
                 <a:latin typeface="+mn-lt"/>
               </a:rPr>
@@ -913,7 +913,7 @@
           </c:tx>
           <c:spPr>
             <a:solidFill>
-              <a:srgbClr val="C9D1D9"/>
+              <a:srgbClr val="76879A"/>
             </a:solidFill>
             <a:effectLst/>
           </c:spPr>
@@ -927,7 +927,7 @@
                 <a:pPr>
                   <a:defRPr b="0" i="0" strike="noStrike" sz="1100" u="none">
                     <a:solidFill>
-                      <a:srgbClr val="1B2A33"/>
+                      <a:srgbClr val="334155"/>
                     </a:solidFill>
                     <a:latin typeface="+mn-lt"/>
                   </a:defRPr>
@@ -1110,7 +1110,7 @@
           </c:tx>
           <c:spPr>
             <a:solidFill>
-              <a:srgbClr val="3B5BA9"/>
+              <a:srgbClr val="0072B2"/>
             </a:solidFill>
             <a:effectLst/>
           </c:spPr>
@@ -1124,7 +1124,7 @@
                 <a:pPr>
                   <a:defRPr b="0" i="0" strike="noStrike" sz="1100" u="none">
                     <a:solidFill>
-                      <a:srgbClr val="1B2A33"/>
+                      <a:srgbClr val="334155"/>
                     </a:solidFill>
                     <a:latin typeface="+mn-lt"/>
                   </a:defRPr>
@@ -1300,7 +1300,7 @@
               <a:pPr>
                 <a:defRPr b="0" i="0" strike="noStrike" sz="1100" u="none">
                   <a:solidFill>
-                    <a:srgbClr val="1B2A33"/>
+                    <a:srgbClr val="334155"/>
                   </a:solidFill>
                   <a:latin typeface="+mn-lt"/>
                 </a:defRPr>
@@ -1335,7 +1335,7 @@
         <c:spPr>
           <a:ln w="12700" cap="flat">
             <a:solidFill>
-              <a:srgbClr val="E3E7EB"/>
+              <a:srgbClr val="E2E8F0"/>
             </a:solidFill>
             <a:prstDash val="solid"/>
             <a:round/>
@@ -1348,7 +1348,7 @@
             <a:pPr>
               <a:defRPr sz="1100" b="0" i="0" u="none" strike="noStrike">
                 <a:solidFill>
-                  <a:srgbClr val="76838F"/>
+                  <a:srgbClr val="526579"/>
                 </a:solidFill>
                 <a:latin typeface="+mn-lt"/>
               </a:defRPr>
@@ -1373,7 +1373,7 @@
           <c:spPr>
             <a:ln w="9525" cap="flat">
               <a:solidFill>
-                <a:srgbClr val="E3E7EB"/>
+                <a:srgbClr val="E2E8F0"/>
               </a:solidFill>
               <a:prstDash val="solid"/>
               <a:round/>
@@ -1398,7 +1398,7 @@
             <a:pPr>
               <a:defRPr sz="1100" b="0" i="0" u="none" strike="noStrike">
                 <a:solidFill>
-                  <a:srgbClr val="76838F"/>
+                  <a:srgbClr val="526579"/>
                 </a:solidFill>
                 <a:latin typeface="+mn-lt"/>
               </a:defRPr>
@@ -1428,7 +1428,7 @@
           <a:pPr>
             <a:defRPr sz="1100">
               <a:solidFill>
-                <a:srgbClr val="76838F"/>
+                <a:srgbClr val="526579"/>
               </a:solidFill>
               <a:latin typeface="+mn-lt"/>
               <a:cs typeface="+mn-lt"/>
@@ -1468,7 +1468,7 @@
             <a:pPr>
               <a:defRPr sz="1300" b="0" i="0" u="none" strike="noStrike">
                 <a:solidFill>
-                  <a:srgbClr val="1B2A33"/>
+                  <a:srgbClr val="112B49"/>
                 </a:solidFill>
                 <a:latin typeface="+mn-lt"/>
               </a:defRPr>
@@ -1476,7 +1476,7 @@
             <a:r>
               <a:rPr sz="1300" b="0" i="0" u="none" strike="noStrike">
                 <a:solidFill>
-                  <a:srgbClr val="1B2A33"/>
+                  <a:srgbClr val="112B49"/>
                 </a:solidFill>
                 <a:latin typeface="+mn-lt"/>
               </a:rPr>
@@ -1510,7 +1510,7 @@
           </c:tx>
           <c:spPr>
             <a:solidFill>
-              <a:srgbClr val="C9D1D9"/>
+              <a:srgbClr val="76879A"/>
             </a:solidFill>
             <a:ln>
               <a:noFill/>
@@ -1522,11 +1522,11 @@
             <c:size val="9"/>
             <c:spPr>
               <a:solidFill>
-                <a:srgbClr val="C9D1D9"/>
+                <a:srgbClr val="76879A"/>
               </a:solidFill>
               <a:ln w="9525" cap="flat">
                 <a:solidFill>
-                  <a:srgbClr val="C9D1D9"/>
+                  <a:srgbClr val="76879A"/>
                 </a:solidFill>
                 <a:prstDash val="solid"/>
                 <a:round/>
@@ -2032,7 +2032,7 @@
           </c:tx>
           <c:spPr>
             <a:solidFill>
-              <a:srgbClr val="B8243B"/>
+              <a:srgbClr val="D55E00"/>
             </a:solidFill>
             <a:ln>
               <a:noFill/>
@@ -2044,11 +2044,11 @@
             <c:size val="9"/>
             <c:spPr>
               <a:solidFill>
-                <a:srgbClr val="B8243B"/>
+                <a:srgbClr val="D55E00"/>
               </a:solidFill>
               <a:ln w="9525" cap="flat">
                 <a:solidFill>
-                  <a:srgbClr val="B8243B"/>
+                  <a:srgbClr val="D55E00"/>
                 </a:solidFill>
                 <a:prstDash val="solid"/>
                 <a:round/>
@@ -2547,7 +2547,7 @@
               <a:pPr>
                 <a:defRPr b="0" i="0" strike="noStrike" sz="1100" u="none">
                   <a:solidFill>
-                    <a:srgbClr val="1B2A33"/>
+                    <a:srgbClr val="334155"/>
                   </a:solidFill>
                   <a:latin typeface="+mn-lt"/>
                 </a:defRPr>
@@ -2582,7 +2582,7 @@
                 <a:pPr>
                   <a:defRPr sz="1200" b="0" i="0" u="none" strike="noStrike">
                     <a:solidFill>
-                      <a:srgbClr val="76838F"/>
+                      <a:srgbClr val="526579"/>
                     </a:solidFill>
                     <a:latin typeface="+mn-lt"/>
                   </a:defRPr>
@@ -2590,7 +2590,7 @@
                 <a:r>
                   <a:rPr sz="1200" b="0" i="0" u="none" strike="noStrike">
                     <a:solidFill>
-                      <a:srgbClr val="76838F"/>
+                      <a:srgbClr val="526579"/>
                     </a:solidFill>
                     <a:latin typeface="+mn-lt"/>
                   </a:rPr>
@@ -2609,7 +2609,7 @@
         <c:spPr>
           <a:ln w="12700" cap="flat">
             <a:solidFill>
-              <a:srgbClr val="E3E7EB"/>
+              <a:srgbClr val="E2E8F0"/>
             </a:solidFill>
             <a:prstDash val="solid"/>
             <a:round/>
@@ -2622,7 +2622,7 @@
             <a:pPr>
               <a:defRPr sz="1100" b="0" i="0" u="none" strike="noStrike">
                 <a:solidFill>
-                  <a:srgbClr val="76838F"/>
+                  <a:srgbClr val="526579"/>
                 </a:solidFill>
                 <a:latin typeface="+mn-lt"/>
               </a:defRPr>
@@ -2649,7 +2649,7 @@
           <c:spPr>
             <a:ln w="9525" cap="flat">
               <a:solidFill>
-                <a:srgbClr val="E3E7EB"/>
+                <a:srgbClr val="E2E8F0"/>
               </a:solidFill>
               <a:prstDash val="solid"/>
               <a:round/>
@@ -2665,7 +2665,7 @@
                 <a:pPr>
                   <a:defRPr sz="1200" b="0" i="0" u="none" strike="noStrike">
                     <a:solidFill>
-                      <a:srgbClr val="76838F"/>
+                      <a:srgbClr val="526579"/>
                     </a:solidFill>
                     <a:latin typeface="+mn-lt"/>
                   </a:defRPr>
@@ -2673,7 +2673,7 @@
                 <a:r>
                   <a:rPr sz="1200" b="0" i="0" u="none" strike="noStrike">
                     <a:solidFill>
-                      <a:srgbClr val="76838F"/>
+                      <a:srgbClr val="526579"/>
                     </a:solidFill>
                     <a:latin typeface="+mn-lt"/>
                   </a:rPr>
@@ -2703,7 +2703,7 @@
             <a:pPr>
               <a:defRPr sz="1100" b="0" i="0" u="none" strike="noStrike">
                 <a:solidFill>
-                  <a:srgbClr val="76838F"/>
+                  <a:srgbClr val="526579"/>
                 </a:solidFill>
                 <a:latin typeface="+mn-lt"/>
               </a:defRPr>
@@ -2733,7 +2733,7 @@
           <a:pPr>
             <a:defRPr sz="1100">
               <a:solidFill>
-                <a:srgbClr val="76838F"/>
+                <a:srgbClr val="526579"/>
               </a:solidFill>
               <a:latin typeface="+mn-lt"/>
               <a:cs typeface="+mn-lt"/>
@@ -2774,7 +2774,7 @@
             <a:pPr>
               <a:defRPr sz="1300" b="0" i="0" u="none" strike="noStrike">
                 <a:solidFill>
-                  <a:srgbClr val="1B2A33"/>
+                  <a:srgbClr val="112B49"/>
                 </a:solidFill>
                 <a:latin typeface="+mn-lt"/>
               </a:defRPr>
@@ -2782,7 +2782,7 @@
             <a:r>
               <a:rPr sz="1300" b="0" i="0" u="none" strike="noStrike">
                 <a:solidFill>
-                  <a:srgbClr val="1B2A33"/>
+                  <a:srgbClr val="112B49"/>
                 </a:solidFill>
                 <a:latin typeface="+mn-lt"/>
               </a:rPr>
@@ -2817,7 +2817,7 @@
           </c:tx>
           <c:spPr>
             <a:solidFill>
-              <a:srgbClr val="3B5BA9"/>
+              <a:srgbClr val="0072B2"/>
             </a:solidFill>
             <a:effectLst/>
           </c:spPr>
@@ -2831,7 +2831,7 @@
                 <a:pPr>
                   <a:defRPr b="0" i="0" strike="noStrike" sz="1100" u="none">
                     <a:solidFill>
-                      <a:srgbClr val="1B2A33"/>
+                      <a:srgbClr val="334155"/>
                     </a:solidFill>
                     <a:latin typeface="+mn-lt"/>
                   </a:defRPr>
@@ -2923,7 +2923,7 @@
               <a:pPr>
                 <a:defRPr b="0" i="0" strike="noStrike" sz="1100" u="none">
                   <a:solidFill>
-                    <a:srgbClr val="1B2A33"/>
+                    <a:srgbClr val="334155"/>
                   </a:solidFill>
                   <a:latin typeface="+mn-lt"/>
                 </a:defRPr>
@@ -2958,7 +2958,7 @@
         <c:spPr>
           <a:ln w="12700" cap="flat">
             <a:solidFill>
-              <a:srgbClr val="E3E7EB"/>
+              <a:srgbClr val="E2E8F0"/>
             </a:solidFill>
             <a:prstDash val="solid"/>
             <a:round/>
@@ -2971,7 +2971,7 @@
             <a:pPr>
               <a:defRPr sz="1200" b="0" i="0" u="none" strike="noStrike">
                 <a:solidFill>
-                  <a:srgbClr val="76838F"/>
+                  <a:srgbClr val="526579"/>
                 </a:solidFill>
                 <a:latin typeface="+mn-lt"/>
               </a:defRPr>
@@ -3011,7 +3011,7 @@
             <a:pPr>
               <a:defRPr sz="1100" b="0" i="0" u="none" strike="noStrike">
                 <a:solidFill>
-                  <a:srgbClr val="76838F"/>
+                  <a:srgbClr val="526579"/>
                 </a:solidFill>
                 <a:latin typeface="+mn-lt"/>
               </a:defRPr>
@@ -3061,7 +3061,7 @@
             <a:pPr>
               <a:defRPr sz="1300" b="0" i="0" u="none" strike="noStrike">
                 <a:solidFill>
-                  <a:srgbClr val="1B2A33"/>
+                  <a:srgbClr val="112B49"/>
                 </a:solidFill>
                 <a:latin typeface="+mn-lt"/>
               </a:defRPr>
@@ -3069,7 +3069,7 @@
             <a:r>
               <a:rPr sz="1300" b="0" i="0" u="none" strike="noStrike">
                 <a:solidFill>
-                  <a:srgbClr val="1B2A33"/>
+                  <a:srgbClr val="112B49"/>
                 </a:solidFill>
                 <a:latin typeface="+mn-lt"/>
               </a:rPr>
@@ -3104,7 +3104,7 @@
           </c:tx>
           <c:spPr>
             <a:solidFill>
-              <a:srgbClr val="3B5BA9"/>
+              <a:srgbClr val="0072B2"/>
             </a:solidFill>
             <a:effectLst/>
           </c:spPr>
@@ -3118,7 +3118,7 @@
                 <a:pPr>
                   <a:defRPr b="0" i="0" strike="noStrike" sz="1100" u="none">
                     <a:solidFill>
-                      <a:srgbClr val="1B2A33"/>
+                      <a:srgbClr val="334155"/>
                     </a:solidFill>
                     <a:latin typeface="+mn-lt"/>
                   </a:defRPr>
@@ -3210,7 +3210,7 @@
               <a:pPr>
                 <a:defRPr b="0" i="0" strike="noStrike" sz="1100" u="none">
                   <a:solidFill>
-                    <a:srgbClr val="1B2A33"/>
+                    <a:srgbClr val="334155"/>
                   </a:solidFill>
                   <a:latin typeface="+mn-lt"/>
                 </a:defRPr>
@@ -3245,7 +3245,7 @@
         <c:spPr>
           <a:ln w="12700" cap="flat">
             <a:solidFill>
-              <a:srgbClr val="E3E7EB"/>
+              <a:srgbClr val="E2E8F0"/>
             </a:solidFill>
             <a:prstDash val="solid"/>
             <a:round/>
@@ -3258,7 +3258,7 @@
             <a:pPr>
               <a:defRPr sz="1200" b="0" i="0" u="none" strike="noStrike">
                 <a:solidFill>
-                  <a:srgbClr val="76838F"/>
+                  <a:srgbClr val="526579"/>
                 </a:solidFill>
                 <a:latin typeface="+mn-lt"/>
               </a:defRPr>
@@ -3298,7 +3298,7 @@
             <a:pPr>
               <a:defRPr sz="1100" b="0" i="0" u="none" strike="noStrike">
                 <a:solidFill>
-                  <a:srgbClr val="76838F"/>
+                  <a:srgbClr val="526579"/>
                 </a:solidFill>
                 <a:latin typeface="+mn-lt"/>
               </a:defRPr>
@@ -3348,7 +3348,7 @@
             <a:pPr>
               <a:defRPr sz="1300" b="0" i="0" u="none" strike="noStrike">
                 <a:solidFill>
-                  <a:srgbClr val="1B2A33"/>
+                  <a:srgbClr val="112B49"/>
                 </a:solidFill>
                 <a:latin typeface="+mn-lt"/>
               </a:defRPr>
@@ -3356,7 +3356,7 @@
             <a:r>
               <a:rPr sz="1300" b="0" i="0" u="none" strike="noStrike">
                 <a:solidFill>
-                  <a:srgbClr val="1B2A33"/>
+                  <a:srgbClr val="112B49"/>
                 </a:solidFill>
                 <a:latin typeface="+mn-lt"/>
               </a:rPr>
@@ -3391,7 +3391,7 @@
           </c:tx>
           <c:spPr>
             <a:solidFill>
-              <a:srgbClr val="B8243B"/>
+              <a:srgbClr val="0072B2"/>
             </a:solidFill>
             <a:effectLst/>
           </c:spPr>
@@ -3405,7 +3405,7 @@
                 <a:pPr>
                   <a:defRPr b="0" i="0" strike="noStrike" sz="1100" u="none">
                     <a:solidFill>
-                      <a:srgbClr val="1B2A33"/>
+                      <a:srgbClr val="334155"/>
                     </a:solidFill>
                     <a:latin typeface="+mn-lt"/>
                   </a:defRPr>
@@ -3509,7 +3509,7 @@
               <a:pPr>
                 <a:defRPr b="0" i="0" strike="noStrike" sz="1100" u="none">
                   <a:solidFill>
-                    <a:srgbClr val="1B2A33"/>
+                    <a:srgbClr val="334155"/>
                   </a:solidFill>
                   <a:latin typeface="+mn-lt"/>
                 </a:defRPr>
@@ -3544,7 +3544,7 @@
         <c:spPr>
           <a:ln w="12700" cap="flat">
             <a:solidFill>
-              <a:srgbClr val="E3E7EB"/>
+              <a:srgbClr val="E2E8F0"/>
             </a:solidFill>
             <a:prstDash val="solid"/>
             <a:round/>
@@ -3557,7 +3557,7 @@
             <a:pPr>
               <a:defRPr sz="1200" b="0" i="0" u="none" strike="noStrike">
                 <a:solidFill>
-                  <a:srgbClr val="76838F"/>
+                  <a:srgbClr val="526579"/>
                 </a:solidFill>
                 <a:latin typeface="+mn-lt"/>
               </a:defRPr>
@@ -3597,7 +3597,7 @@
             <a:pPr>
               <a:defRPr sz="1100" b="0" i="0" u="none" strike="noStrike">
                 <a:solidFill>
-                  <a:srgbClr val="76838F"/>
+                  <a:srgbClr val="526579"/>
                 </a:solidFill>
                 <a:latin typeface="+mn-lt"/>
               </a:defRPr>
@@ -3647,7 +3647,7 @@
             <a:pPr>
               <a:defRPr sz="1300" b="0" i="0" u="none" strike="noStrike">
                 <a:solidFill>
-                  <a:srgbClr val="1B2A33"/>
+                  <a:srgbClr val="112B49"/>
                 </a:solidFill>
                 <a:latin typeface="+mn-lt"/>
               </a:defRPr>
@@ -3655,7 +3655,7 @@
             <a:r>
               <a:rPr sz="1300" b="0" i="0" u="none" strike="noStrike">
                 <a:solidFill>
-                  <a:srgbClr val="1B2A33"/>
+                  <a:srgbClr val="112B49"/>
                 </a:solidFill>
                 <a:latin typeface="+mn-lt"/>
               </a:rPr>
@@ -3690,7 +3690,7 @@
           </c:tx>
           <c:spPr>
             <a:solidFill>
-              <a:srgbClr val="3B5BA9"/>
+              <a:srgbClr val="0072B2"/>
             </a:solidFill>
             <a:effectLst/>
           </c:spPr>
@@ -3704,7 +3704,7 @@
                 <a:pPr>
                   <a:defRPr b="0" i="0" strike="noStrike" sz="1100" u="none">
                     <a:solidFill>
-                      <a:srgbClr val="1B2A33"/>
+                      <a:srgbClr val="334155"/>
                     </a:solidFill>
                     <a:latin typeface="+mn-lt"/>
                   </a:defRPr>
@@ -3772,7 +3772,7 @@
               <a:pPr>
                 <a:defRPr b="0" i="0" strike="noStrike" sz="1100" u="none">
                   <a:solidFill>
-                    <a:srgbClr val="1B2A33"/>
+                    <a:srgbClr val="334155"/>
                   </a:solidFill>
                   <a:latin typeface="+mn-lt"/>
                 </a:defRPr>
@@ -3807,7 +3807,7 @@
         <c:spPr>
           <a:ln w="12700" cap="flat">
             <a:solidFill>
-              <a:srgbClr val="E3E7EB"/>
+              <a:srgbClr val="E2E8F0"/>
             </a:solidFill>
             <a:prstDash val="solid"/>
             <a:round/>
@@ -3820,7 +3820,7 @@
             <a:pPr>
               <a:defRPr sz="1200" b="0" i="0" u="none" strike="noStrike">
                 <a:solidFill>
-                  <a:srgbClr val="76838F"/>
+                  <a:srgbClr val="526579"/>
                 </a:solidFill>
                 <a:latin typeface="+mn-lt"/>
               </a:defRPr>
@@ -3847,7 +3847,7 @@
           <c:spPr>
             <a:ln w="9525" cap="flat">
               <a:solidFill>
-                <a:srgbClr val="E3E7EB"/>
+                <a:srgbClr val="E2E8F0"/>
               </a:solidFill>
               <a:prstDash val="solid"/>
               <a:round/>
@@ -3872,7 +3872,7 @@
             <a:pPr>
               <a:defRPr sz="1100" b="0" i="0" u="none" strike="noStrike">
                 <a:solidFill>
-                  <a:srgbClr val="76838F"/>
+                  <a:srgbClr val="526579"/>
                 </a:solidFill>
                 <a:latin typeface="+mn-lt"/>
               </a:defRPr>
@@ -3922,7 +3922,7 @@
             <a:pPr>
               <a:defRPr sz="1300" b="0" i="0" u="none" strike="noStrike">
                 <a:solidFill>
-                  <a:srgbClr val="1B2A33"/>
+                  <a:srgbClr val="112B49"/>
                 </a:solidFill>
                 <a:latin typeface="+mn-lt"/>
               </a:defRPr>
@@ -3930,7 +3930,7 @@
             <a:r>
               <a:rPr sz="1300" b="0" i="0" u="none" strike="noStrike">
                 <a:solidFill>
-                  <a:srgbClr val="1B2A33"/>
+                  <a:srgbClr val="112B49"/>
                 </a:solidFill>
                 <a:latin typeface="+mn-lt"/>
               </a:rPr>
@@ -3965,7 +3965,7 @@
           </c:tx>
           <c:spPr>
             <a:solidFill>
-              <a:srgbClr val="C9D1D9"/>
+              <a:srgbClr val="76879A"/>
             </a:solidFill>
             <a:effectLst/>
           </c:spPr>
@@ -3979,7 +3979,7 @@
                 <a:pPr>
                   <a:defRPr b="0" i="0" strike="noStrike" sz="1100" u="none">
                     <a:solidFill>
-                      <a:srgbClr val="1B2A33"/>
+                      <a:srgbClr val="334155"/>
                     </a:solidFill>
                     <a:latin typeface="+mn-lt"/>
                   </a:defRPr>
@@ -4126,7 +4126,7 @@
           </c:tx>
           <c:spPr>
             <a:solidFill>
-              <a:srgbClr val="3B5BA9"/>
+              <a:srgbClr val="0072B2"/>
             </a:solidFill>
             <a:effectLst/>
           </c:spPr>
@@ -4140,7 +4140,7 @@
                 <a:pPr>
                   <a:defRPr b="0" i="0" strike="noStrike" sz="1100" u="none">
                     <a:solidFill>
-                      <a:srgbClr val="1B2A33"/>
+                      <a:srgbClr val="334155"/>
                     </a:solidFill>
                     <a:latin typeface="+mn-lt"/>
                   </a:defRPr>
@@ -4280,7 +4280,7 @@
               <a:pPr>
                 <a:defRPr b="0" i="0" strike="noStrike" sz="1100" u="none">
                   <a:solidFill>
-                    <a:srgbClr val="1B2A33"/>
+                    <a:srgbClr val="334155"/>
                   </a:solidFill>
                   <a:latin typeface="+mn-lt"/>
                 </a:defRPr>
@@ -4315,7 +4315,7 @@
         <c:spPr>
           <a:ln w="12700" cap="flat">
             <a:solidFill>
-              <a:srgbClr val="E3E7EB"/>
+              <a:srgbClr val="E2E8F0"/>
             </a:solidFill>
             <a:prstDash val="solid"/>
             <a:round/>
@@ -4328,7 +4328,7 @@
             <a:pPr>
               <a:defRPr sz="1100" b="0" i="0" u="none" strike="noStrike">
                 <a:solidFill>
-                  <a:srgbClr val="76838F"/>
+                  <a:srgbClr val="526579"/>
                 </a:solidFill>
                 <a:latin typeface="+mn-lt"/>
               </a:defRPr>
@@ -4353,7 +4353,7 @@
           <c:spPr>
             <a:ln w="9525" cap="flat">
               <a:solidFill>
-                <a:srgbClr val="E3E7EB"/>
+                <a:srgbClr val="E2E8F0"/>
               </a:solidFill>
               <a:prstDash val="solid"/>
               <a:round/>
@@ -4378,7 +4378,7 @@
             <a:pPr>
               <a:defRPr sz="1100" b="0" i="0" u="none" strike="noStrike">
                 <a:solidFill>
-                  <a:srgbClr val="76838F"/>
+                  <a:srgbClr val="526579"/>
                 </a:solidFill>
                 <a:latin typeface="+mn-lt"/>
               </a:defRPr>
@@ -4428,7 +4428,7 @@
             <a:pPr>
               <a:defRPr sz="1300" b="0" i="0" u="none" strike="noStrike">
                 <a:solidFill>
-                  <a:srgbClr val="1B2A33"/>
+                  <a:srgbClr val="112B49"/>
                 </a:solidFill>
                 <a:latin typeface="+mn-lt"/>
               </a:defRPr>
@@ -4436,7 +4436,7 @@
             <a:r>
               <a:rPr sz="1300" b="0" i="0" u="none" strike="noStrike">
                 <a:solidFill>
-                  <a:srgbClr val="1B2A33"/>
+                  <a:srgbClr val="112B49"/>
                 </a:solidFill>
                 <a:latin typeface="+mn-lt"/>
               </a:rPr>
@@ -4471,7 +4471,7 @@
           </c:tx>
           <c:spPr>
             <a:solidFill>
-              <a:srgbClr val="3B5BA9"/>
+              <a:srgbClr val="0072B2"/>
             </a:solidFill>
             <a:effectLst/>
           </c:spPr>
@@ -4485,7 +4485,7 @@
                 <a:pPr>
                   <a:defRPr b="0" i="0" strike="noStrike" sz="1100" u="none">
                     <a:solidFill>
-                      <a:srgbClr val="1B2A33"/>
+                      <a:srgbClr val="334155"/>
                     </a:solidFill>
                     <a:latin typeface="+mn-lt"/>
                   </a:defRPr>
@@ -4565,7 +4565,7 @@
               <a:pPr>
                 <a:defRPr b="0" i="0" strike="noStrike" sz="1100" u="none">
                   <a:solidFill>
-                    <a:srgbClr val="1B2A33"/>
+                    <a:srgbClr val="334155"/>
                   </a:solidFill>
                   <a:latin typeface="+mn-lt"/>
                 </a:defRPr>
@@ -4600,7 +4600,7 @@
         <c:spPr>
           <a:ln w="12700" cap="flat">
             <a:solidFill>
-              <a:srgbClr val="E3E7EB"/>
+              <a:srgbClr val="E2E8F0"/>
             </a:solidFill>
             <a:prstDash val="solid"/>
             <a:round/>
@@ -4613,7 +4613,7 @@
             <a:pPr>
               <a:defRPr sz="1200" b="0" i="0" u="none" strike="noStrike">
                 <a:solidFill>
-                  <a:srgbClr val="76838F"/>
+                  <a:srgbClr val="526579"/>
                 </a:solidFill>
                 <a:latin typeface="+mn-lt"/>
               </a:defRPr>
@@ -4653,7 +4653,7 @@
             <a:pPr>
               <a:defRPr sz="1100" b="0" i="0" u="none" strike="noStrike">
                 <a:solidFill>
-                  <a:srgbClr val="76838F"/>
+                  <a:srgbClr val="526579"/>
                 </a:solidFill>
                 <a:latin typeface="+mn-lt"/>
               </a:defRPr>
@@ -6702,7 +6702,7 @@
               <a:buNone/>
               <a:defRPr lang="en-US" sz="1400" b="1" spc="200" kern="0" dirty="0">
                 <a:solidFill>
-                  <a:schemeClr val="accent6"/>
+                  <a:srgbClr val="A9BCD0"/>
                 </a:solidFill>
               </a:defRPr>
             </a:lvl1pPr>
@@ -6726,7 +6726,7 @@
         <p:spPr>
           <a:xfrm>
             <a:off x="548640" y="1828800"/>
-            <a:ext cx="7680960" cy="1920240"/>
+            <a:ext cx="7680960" cy="1143000"/>
           </a:xfrm>
           <a:prstGeom prst="rect">
             <a:avLst/>
@@ -6764,7 +6764,7 @@
         </p:nvSpPr>
         <p:spPr>
           <a:xfrm>
-            <a:off x="548640" y="3931920"/>
+            <a:off x="548640" y="3063240"/>
             <a:ext cx="7315200" cy="1280160"/>
           </a:xfrm>
           <a:prstGeom prst="rect">
@@ -6807,7 +6807,7 @@
     <p:bg>
       <p:bgPr>
         <a:solidFill>
-          <a:schemeClr val="bg1"/>
+          <a:schemeClr val="bg2"/>
         </a:solidFill>
       </p:bgPr>
     </p:bg>
@@ -6851,7 +6851,7 @@
               <a:buNone/>
               <a:defRPr lang="en-US" sz="1200" b="1" spc="200" kern="0" dirty="0">
                 <a:solidFill>
-                  <a:schemeClr val="accent4"/>
+                  <a:schemeClr val="accent2"/>
                 </a:solidFill>
               </a:defRPr>
             </a:lvl1pPr>
@@ -7042,7 +7042,7 @@
               <a:buNone/>
               <a:defRPr lang="en-US" sz="1200" b="1" spc="200" kern="0" dirty="0">
                 <a:solidFill>
-                  <a:schemeClr val="accent6"/>
+                  <a:srgbClr val="A9BCD0"/>
                 </a:solidFill>
               </a:defRPr>
             </a:lvl1pPr>
@@ -7473,7 +7473,7 @@
             <a:r>
               <a:rPr lang="en-US" sz="1400" b="1" spc="200" kern="0" dirty="0">
                 <a:solidFill>
-                  <a:schemeClr val="accent6"/>
+                  <a:srgbClr val="A9BCD0"/>
                 </a:solidFill>
               </a:rPr>
               <a:t>CAPSTONE PROJECT  |  OCTOBER 2026</a:t>
@@ -7493,7 +7493,7 @@
         <p:spPr>
           <a:xfrm>
             <a:off x="548640" y="1828800"/>
-            <a:ext cx="7680960" cy="1920240"/>
+            <a:ext cx="7680960" cy="1143000"/>
           </a:xfrm>
           <a:prstGeom prst="rect">
             <a:avLst/>
@@ -7530,7 +7530,7 @@
         </p:nvSpPr>
         <p:spPr>
           <a:xfrm>
-            <a:off x="548640" y="3931920"/>
+            <a:off x="548640" y="3063240"/>
             <a:ext cx="7315200" cy="1280160"/>
           </a:xfrm>
           <a:prstGeom prst="rect">
@@ -7558,29 +7558,9 @@
           </a:p>
         </p:txBody>
       </p:sp>
-      <p:sp>
-        <p:nvSpPr>
-          <p:cNvPr id="5" name="hero circle"/>
-          <p:cNvSpPr/>
-          <p:nvPr/>
-        </p:nvSpPr>
-        <p:spPr>
-          <a:xfrm>
-            <a:off x="8732520" y="1600200"/>
-            <a:ext cx="2926080" cy="2926080"/>
-          </a:xfrm>
-          <a:prstGeom prst="ellipse">
-            <a:avLst/>
-          </a:prstGeom>
-          <a:solidFill>
-            <a:schemeClr val="accent2"/>
-          </a:solidFill>
-          <a:ln/>
-        </p:spPr>
-      </p:sp>
       <p:pic>
         <p:nvPicPr>
-          <p:cNvPr id="6" name="hero icon" descr="Mountain">    </p:cNvPr>
+          <p:cNvPr id="5" name="mountain ridges" descr="Himalayan ridge line art">    </p:cNvPr>
           <p:cNvPicPr>
             <a:picLocks noChangeAspect="1"/>
           </p:cNvPicPr>
@@ -7594,14 +7574,96 @@
         </p:blipFill>
         <p:spPr>
           <a:xfrm>
-            <a:off x="9464040" y="2331720"/>
-            <a:ext cx="1463040" cy="1463040"/>
+            <a:off x="5788152" y="3566160"/>
+            <a:ext cx="6400800" cy="3291840"/>
           </a:xfrm>
           <a:prstGeom prst="rect">
             <a:avLst/>
           </a:prstGeom>
         </p:spPr>
       </p:pic>
+      <p:sp>
+        <p:nvSpPr>
+          <p:cNvPr id="6" name="Logo tile"/>
+          <p:cNvSpPr/>
+          <p:nvPr/>
+        </p:nvSpPr>
+        <p:spPr>
+          <a:xfrm>
+            <a:off x="548640" y="548640"/>
+            <a:ext cx="457200" cy="457200"/>
+          </a:xfrm>
+          <a:prstGeom prst="roundRect">
+            <a:avLst>
+              <a:gd name="adj" fmla="val 22000"/>
+            </a:avLst>
+          </a:prstGeom>
+          <a:solidFill>
+            <a:srgbClr val="195B96"/>
+          </a:solidFill>
+          <a:ln/>
+        </p:spPr>
+      </p:sp>
+      <p:pic>
+        <p:nvPicPr>
+          <p:cNvPr id="7" name="Logo icon" descr="Logo">    </p:cNvPr>
+          <p:cNvPicPr>
+            <a:picLocks noChangeAspect="1"/>
+          </p:cNvPicPr>
+          <p:nvPr/>
+        </p:nvPicPr>
+        <p:blipFill>
+          <a:blip r:embed="rId2"/>
+          <a:stretch>
+            <a:fillRect/>
+          </a:stretch>
+        </p:blipFill>
+        <p:spPr>
+          <a:xfrm>
+            <a:off x="662940" y="662940"/>
+            <a:ext cx="228600" cy="228600"/>
+          </a:xfrm>
+          <a:prstGeom prst="rect">
+            <a:avLst/>
+          </a:prstGeom>
+        </p:spPr>
+      </p:pic>
+      <p:sp>
+        <p:nvSpPr>
+          <p:cNvPr id="8" name="Text 4"/>
+          <p:cNvSpPr txBox="1"/>
+          <p:nvPr/>
+        </p:nvSpPr>
+        <p:spPr>
+          <a:xfrm>
+            <a:off x="1170432" y="548640"/>
+            <a:ext cx="6400800" cy="457200"/>
+          </a:xfrm>
+          <a:prstGeom prst="rect">
+            <a:avLst/>
+          </a:prstGeom>
+          <a:noFill/>
+          <a:ln/>
+        </p:spPr>
+        <p:txBody>
+          <a:bodyPr wrap="square" lIns="0" tIns="0" rIns="0" bIns="0" rtlCol="0" anchor="ctr"/>
+          <a:lstStyle/>
+          <a:p>
+            <a:pPr indent="0" marL="0">
+              <a:buNone/>
+            </a:pPr>
+            <a:r>
+              <a:rPr lang="en-US" sz="1200" b="1" spc="200" kern="0" dirty="0">
+                <a:solidFill>
+                  <a:srgbClr val="A9BCD0"/>
+                </a:solidFill>
+              </a:rPr>
+              <a:t>NEPAL CLIMATE RISK  ·  INTELLIGENCE PLATFORM</a:t>
+            </a:r>
+            <a:endParaRPr lang="en-US" sz="1200" dirty="0"/>
+          </a:p>
+        </p:txBody>
+      </p:sp>
     </p:spTree>
   </p:cSld>
   <p:clrMapOvr>
@@ -7656,7 +7718,7 @@
             <a:r>
               <a:rPr lang="en-US" sz="1200" b="1" spc="200" kern="0" dirty="0">
                 <a:solidFill>
-                  <a:schemeClr val="accent4"/>
+                  <a:schemeClr val="accent2"/>
                 </a:solidFill>
               </a:rPr>
               <a:t>THE RISK INDEX</a:t>
@@ -7703,9 +7765,36 @@
           </a:p>
         </p:txBody>
       </p:sp>
+      <p:sp>
+        <p:nvSpPr>
+          <p:cNvPr id="4" name="chart panel"/>
+          <p:cNvSpPr/>
+          <p:nvPr/>
+        </p:nvSpPr>
+        <p:spPr>
+          <a:xfrm>
+            <a:off x="438912" y="1536192"/>
+            <a:ext cx="6986016" cy="4745736"/>
+          </a:xfrm>
+          <a:prstGeom prst="roundRect">
+            <a:avLst>
+              <a:gd name="adj" fmla="val 2312"/>
+            </a:avLst>
+          </a:prstGeom>
+          <a:solidFill>
+            <a:schemeClr val="bg1"/>
+          </a:solidFill>
+          <a:ln w="9525">
+            <a:solidFill>
+              <a:srgbClr val="E2E8F0"/>
+            </a:solidFill>
+            <a:prstDash val="solid"/>
+          </a:ln>
+        </p:spPr>
+      </p:sp>
       <p:graphicFrame>
         <p:nvGraphicFramePr>
-          <p:cNvPr id="4" name="Chart 0" descr=""/>
+          <p:cNvPr id="5" name="Chart 0" descr=""/>
           <p:cNvGraphicFramePr/>
           <p:nvPr/>
         </p:nvGraphicFramePr>
@@ -7721,7 +7810,7 @@
       </p:graphicFrame>
       <p:sp>
         <p:nvSpPr>
-          <p:cNvPr id="5" name="Text 2"/>
+          <p:cNvPr id="6" name="Text 3"/>
           <p:cNvSpPr txBox="1"/>
           <p:nvPr/>
         </p:nvSpPr>
@@ -7757,7 +7846,7 @@
       </p:sp>
       <p:sp>
         <p:nvSpPr>
-          <p:cNvPr id="6" name="Text 3"/>
+          <p:cNvPr id="7" name="Text 4"/>
           <p:cNvSpPr txBox="1"/>
           <p:nvPr/>
         </p:nvSpPr>
@@ -7833,7 +7922,7 @@
       </p:sp>
       <p:sp>
         <p:nvSpPr>
-          <p:cNvPr id="7" name="corridor card"/>
+          <p:cNvPr id="8" name="corridor card"/>
           <p:cNvSpPr/>
           <p:nvPr/>
         </p:nvSpPr>
@@ -7844,15 +7933,15 @@
           </a:xfrm>
           <a:prstGeom prst="roundRect">
             <a:avLst>
-              <a:gd name="adj" fmla="val 2000"/>
+              <a:gd name="adj" fmla="val 4800"/>
             </a:avLst>
           </a:prstGeom>
           <a:solidFill>
-            <a:schemeClr val="bg2"/>
+            <a:schemeClr val="bg1"/>
           </a:solidFill>
           <a:ln w="9525">
             <a:solidFill>
-              <a:srgbClr val="DDE2E7"/>
+              <a:srgbClr val="E2E8F0"/>
             </a:solidFill>
             <a:prstDash val="solid"/>
           </a:ln>
@@ -7860,7 +7949,7 @@
       </p:sp>
       <p:sp>
         <p:nvSpPr>
-          <p:cNvPr id="8" name="Text 5"/>
+          <p:cNvPr id="9" name="Text 6"/>
           <p:cNvSpPr txBox="1"/>
           <p:nvPr/>
         </p:nvSpPr>
@@ -7896,7 +7985,7 @@
       </p:sp>
       <p:sp>
         <p:nvSpPr>
-          <p:cNvPr id="9" name="Text 6"/>
+          <p:cNvPr id="10" name="Text 7"/>
           <p:cNvSpPr txBox="1"/>
           <p:nvPr/>
         </p:nvSpPr>
@@ -8029,7 +8118,7 @@
             <a:r>
               <a:rPr lang="en-US" sz="1200" b="1" spc="200" kern="0" dirty="0">
                 <a:solidFill>
-                  <a:schemeClr val="accent4"/>
+                  <a:schemeClr val="accent2"/>
                 </a:solidFill>
               </a:rPr>
               <a:t>VALIDATION</a:t>
@@ -8097,7 +8186,7 @@
           </a:solidFill>
           <a:ln w="9525">
             <a:solidFill>
-              <a:srgbClr val="C7D1DE"/>
+              <a:srgbClr val="9DBAD6"/>
             </a:solidFill>
             <a:prstDash val="solid"/>
           </a:ln>
@@ -8163,7 +8252,7 @@
           </a:solidFill>
           <a:ln w="9525">
             <a:solidFill>
-              <a:srgbClr val="C7D1DE"/>
+              <a:srgbClr val="9DBAD6"/>
             </a:solidFill>
             <a:prstDash val="solid"/>
           </a:ln>
@@ -8229,7 +8318,7 @@
           </a:solidFill>
           <a:ln w="9525">
             <a:solidFill>
-              <a:srgbClr val="C7D1DE"/>
+              <a:srgbClr val="9DBAD6"/>
             </a:solidFill>
             <a:prstDash val="solid"/>
           </a:ln>
@@ -8287,15 +8376,15 @@
           </a:xfrm>
           <a:prstGeom prst="roundRect">
             <a:avLst>
-              <a:gd name="adj" fmla="val 1316"/>
+              <a:gd name="adj" fmla="val 3158"/>
             </a:avLst>
           </a:prstGeom>
           <a:solidFill>
-            <a:schemeClr val="bg2"/>
+            <a:schemeClr val="bg1"/>
           </a:solidFill>
           <a:ln w="9525">
             <a:solidFill>
-              <a:srgbClr val="DDE2E7"/>
+              <a:srgbClr val="E2E8F0"/>
             </a:solidFill>
             <a:prstDash val="solid"/>
           </a:ln>
@@ -8303,7 +8392,7 @@
       </p:sp>
       <p:sp>
         <p:nvSpPr>
-          <p:cNvPr id="11" name="Landslide index circle"/>
+          <p:cNvPr id="11" name="Landslide index tile"/>
           <p:cNvSpPr/>
           <p:nvPr/>
         </p:nvSpPr>
@@ -8312,11 +8401,13 @@
             <a:off x="822960" y="1920240"/>
             <a:ext cx="640080" cy="640080"/>
           </a:xfrm>
-          <a:prstGeom prst="ellipse">
-            <a:avLst/>
+          <a:prstGeom prst="roundRect">
+            <a:avLst>
+              <a:gd name="adj" fmla="val 22000"/>
+            </a:avLst>
           </a:prstGeom>
           <a:solidFill>
-            <a:srgbClr val="1F7A4D"/>
+            <a:srgbClr val="E6F1F8"/>
           </a:solidFill>
           <a:ln/>
         </p:spPr>
@@ -8337,8 +8428,8 @@
         </p:blipFill>
         <p:spPr>
           <a:xfrm>
-            <a:off x="995782" y="2093062"/>
-            <a:ext cx="294437" cy="294437"/>
+            <a:off x="982980" y="2080260"/>
+            <a:ext cx="320040" cy="320040"/>
           </a:xfrm>
           <a:prstGeom prst="rect">
             <a:avLst/>
@@ -8444,7 +8535,7 @@
             <a:r>
               <a:rPr lang="en-US" sz="1300" dirty="0">
                 <a:solidFill>
-                  <a:srgbClr val="76838F"/>
+                  <a:srgbClr val="526579"/>
                 </a:solidFill>
               </a:rPr>
               <a:t>vs recorded landslides</a:t>
@@ -8480,7 +8571,7 @@
             <a:r>
               <a:rPr lang="en-US" sz="1400" b="1" spc="200" kern="0" dirty="0">
                 <a:solidFill>
-                  <a:srgbClr val="1F7A4D"/>
+                  <a:srgbClr val="0072B2"/>
                 </a:solidFill>
               </a:rPr>
               <a:t>VALIDATED</a:t>
@@ -8538,15 +8629,15 @@
           </a:xfrm>
           <a:prstGeom prst="roundRect">
             <a:avLst>
-              <a:gd name="adj" fmla="val 1316"/>
+              <a:gd name="adj" fmla="val 3158"/>
             </a:avLst>
           </a:prstGeom>
           <a:solidFill>
-            <a:schemeClr val="bg2"/>
+            <a:schemeClr val="bg1"/>
           </a:solidFill>
           <a:ln w="9525">
             <a:solidFill>
-              <a:srgbClr val="DDE2E7"/>
+              <a:srgbClr val="E2E8F0"/>
             </a:solidFill>
             <a:prstDash val="solid"/>
           </a:ln>
@@ -8554,7 +8645,7 @@
       </p:sp>
       <p:sp>
         <p:nvSpPr>
-          <p:cNvPr id="19" name="Combined index circle"/>
+          <p:cNvPr id="19" name="Combined index tile"/>
           <p:cNvSpPr/>
           <p:nvPr/>
         </p:nvSpPr>
@@ -8563,11 +8654,13 @@
             <a:off x="4636008" y="1920240"/>
             <a:ext cx="640080" cy="640080"/>
           </a:xfrm>
-          <a:prstGeom prst="ellipse">
-            <a:avLst/>
+          <a:prstGeom prst="roundRect">
+            <a:avLst>
+              <a:gd name="adj" fmla="val 22000"/>
+            </a:avLst>
           </a:prstGeom>
           <a:solidFill>
-            <a:srgbClr val="8A5A00"/>
+            <a:srgbClr val="E6F1F8"/>
           </a:solidFill>
           <a:ln/>
         </p:spPr>
@@ -8588,8 +8681,8 @@
         </p:blipFill>
         <p:spPr>
           <a:xfrm>
-            <a:off x="4808830" y="2093062"/>
-            <a:ext cx="294437" cy="294437"/>
+            <a:off x="4796028" y="2080260"/>
+            <a:ext cx="320040" cy="320040"/>
           </a:xfrm>
           <a:prstGeom prst="rect">
             <a:avLst/>
@@ -8695,7 +8788,7 @@
             <a:r>
               <a:rPr lang="en-US" sz="1300" dirty="0">
                 <a:solidFill>
-                  <a:srgbClr val="76838F"/>
+                  <a:srgbClr val="526579"/>
                 </a:solidFill>
               </a:rPr>
               <a:t>vs all events (0.43 vs deaths)</a:t>
@@ -8731,7 +8824,7 @@
             <a:r>
               <a:rPr lang="en-US" sz="1400" b="1" spc="200" kern="0" dirty="0">
                 <a:solidFill>
-                  <a:srgbClr val="8A5A00"/>
+                  <a:srgbClr val="B84A00"/>
                 </a:solidFill>
               </a:rPr>
               <a:t>MODERATE</a:t>
@@ -8789,15 +8882,15 @@
           </a:xfrm>
           <a:prstGeom prst="roundRect">
             <a:avLst>
-              <a:gd name="adj" fmla="val 1316"/>
+              <a:gd name="adj" fmla="val 3158"/>
             </a:avLst>
           </a:prstGeom>
           <a:solidFill>
-            <a:schemeClr val="bg2"/>
+            <a:schemeClr val="bg1"/>
           </a:solidFill>
           <a:ln w="9525">
             <a:solidFill>
-              <a:srgbClr val="DDE2E7"/>
+              <a:srgbClr val="E2E8F0"/>
             </a:solidFill>
             <a:prstDash val="solid"/>
           </a:ln>
@@ -8805,7 +8898,7 @@
       </p:sp>
       <p:sp>
         <p:nvSpPr>
-          <p:cNvPr id="27" name="Flood index circle"/>
+          <p:cNvPr id="27" name="Flood index tile"/>
           <p:cNvSpPr/>
           <p:nvPr/>
         </p:nvSpPr>
@@ -8814,11 +8907,13 @@
             <a:off x="8449056" y="1920240"/>
             <a:ext cx="640080" cy="640080"/>
           </a:xfrm>
-          <a:prstGeom prst="ellipse">
-            <a:avLst/>
+          <a:prstGeom prst="roundRect">
+            <a:avLst>
+              <a:gd name="adj" fmla="val 22000"/>
+            </a:avLst>
           </a:prstGeom>
           <a:solidFill>
-            <a:srgbClr val="B8243B"/>
+            <a:srgbClr val="E6F1F8"/>
           </a:solidFill>
           <a:ln/>
         </p:spPr>
@@ -8839,8 +8934,8 @@
         </p:blipFill>
         <p:spPr>
           <a:xfrm>
-            <a:off x="8621878" y="2093062"/>
-            <a:ext cx="294437" cy="294437"/>
+            <a:off x="8609076" y="2080260"/>
+            <a:ext cx="320040" cy="320040"/>
           </a:xfrm>
           <a:prstGeom prst="rect">
             <a:avLst/>
@@ -8946,7 +9041,7 @@
             <a:r>
               <a:rPr lang="en-US" sz="1300" dirty="0">
                 <a:solidFill>
-                  <a:srgbClr val="76838F"/>
+                  <a:srgbClr val="526579"/>
                 </a:solidFill>
               </a:rPr>
               <a:t>vs recorded floods</a:t>
@@ -8982,7 +9077,7 @@
             <a:r>
               <a:rPr lang="en-US" sz="1400" b="1" spc="200" kern="0" dirty="0">
                 <a:solidFill>
-                  <a:srgbClr val="B8243B"/>
+                  <a:srgbClr val="D55E00"/>
                 </a:solidFill>
               </a:rPr>
               <a:t>NOT VALIDATED</a:t>
@@ -9173,7 +9268,7 @@
             <a:r>
               <a:rPr lang="en-US" sz="1200" b="1" spc="200" kern="0" dirty="0">
                 <a:solidFill>
-                  <a:schemeClr val="accent4"/>
+                  <a:schemeClr val="accent2"/>
                 </a:solidFill>
               </a:rPr>
               <a:t>VALIDATION  |  FLOODS</a:t>
@@ -9241,7 +9336,7 @@
           </a:solidFill>
           <a:ln w="9525">
             <a:solidFill>
-              <a:srgbClr val="C7D1DE"/>
+              <a:srgbClr val="9DBAD6"/>
             </a:solidFill>
             <a:prstDash val="solid"/>
           </a:ln>
@@ -9286,9 +9381,36 @@
           </a:p>
         </p:txBody>
       </p:sp>
+      <p:sp>
+        <p:nvSpPr>
+          <p:cNvPr id="6" name="chart panel"/>
+          <p:cNvSpPr/>
+          <p:nvPr/>
+        </p:nvSpPr>
+        <p:spPr>
+          <a:xfrm>
+            <a:off x="438912" y="1536192"/>
+            <a:ext cx="6254496" cy="4425696"/>
+          </a:xfrm>
+          <a:prstGeom prst="roundRect">
+            <a:avLst>
+              <a:gd name="adj" fmla="val 2479"/>
+            </a:avLst>
+          </a:prstGeom>
+          <a:solidFill>
+            <a:schemeClr val="bg1"/>
+          </a:solidFill>
+          <a:ln w="9525">
+            <a:solidFill>
+              <a:srgbClr val="E2E8F0"/>
+            </a:solidFill>
+            <a:prstDash val="solid"/>
+          </a:ln>
+        </p:spPr>
+      </p:sp>
       <p:graphicFrame>
         <p:nvGraphicFramePr>
-          <p:cNvPr id="6" name="Chart 0" descr=""/>
+          <p:cNvPr id="7" name="Chart 0" descr=""/>
           <p:cNvGraphicFramePr/>
           <p:nvPr/>
         </p:nvGraphicFramePr>
@@ -9304,7 +9426,7 @@
       </p:graphicFrame>
       <p:sp>
         <p:nvSpPr>
-          <p:cNvPr id="7" name="Text 4"/>
+          <p:cNvPr id="8" name="Text 5"/>
           <p:cNvSpPr txBox="1"/>
           <p:nvPr/>
         </p:nvSpPr>
@@ -9340,7 +9462,7 @@
       </p:sp>
       <p:sp>
         <p:nvSpPr>
-          <p:cNvPr id="8" name="Text 5"/>
+          <p:cNvPr id="9" name="Text 6"/>
           <p:cNvSpPr txBox="1"/>
           <p:nvPr/>
         </p:nvSpPr>
@@ -9376,7 +9498,7 @@
       </p:sp>
       <p:sp>
         <p:nvSpPr>
-          <p:cNvPr id="9" name="Text 6"/>
+          <p:cNvPr id="10" name="Text 7"/>
           <p:cNvSpPr txBox="1"/>
           <p:nvPr/>
         </p:nvSpPr>
@@ -9412,7 +9534,7 @@
       </p:sp>
       <p:sp>
         <p:nvSpPr>
-          <p:cNvPr id="10" name="Text 7"/>
+          <p:cNvPr id="11" name="Text 8"/>
           <p:cNvSpPr txBox="1"/>
           <p:nvPr/>
         </p:nvSpPr>
@@ -9459,7 +9581,7 @@
       </p:sp>
       <p:sp>
         <p:nvSpPr>
-          <p:cNvPr id="11" name="honesty card"/>
+          <p:cNvPr id="12" name="honesty card"/>
           <p:cNvSpPr/>
           <p:nvPr/>
         </p:nvSpPr>
@@ -9470,15 +9592,15 @@
           </a:xfrm>
           <a:prstGeom prst="roundRect">
             <a:avLst>
-              <a:gd name="adj" fmla="val 5000"/>
+              <a:gd name="adj" fmla="val 12000"/>
             </a:avLst>
           </a:prstGeom>
           <a:solidFill>
-            <a:schemeClr val="bg2"/>
+            <a:schemeClr val="bg1"/>
           </a:solidFill>
           <a:ln w="9525">
             <a:solidFill>
-              <a:srgbClr val="DDE2E7"/>
+              <a:srgbClr val="E2E8F0"/>
             </a:solidFill>
             <a:prstDash val="solid"/>
           </a:ln>
@@ -9486,7 +9608,7 @@
       </p:sp>
       <p:sp>
         <p:nvSpPr>
-          <p:cNvPr id="12" name="Text 9"/>
+          <p:cNvPr id="13" name="Text 10"/>
           <p:cNvSpPr txBox="1"/>
           <p:nvPr/>
         </p:nvSpPr>
@@ -9619,7 +9741,7 @@
             <a:r>
               <a:rPr lang="en-US" sz="1200" b="1" spc="200" kern="0" dirty="0">
                 <a:solidFill>
-                  <a:schemeClr val="accent4"/>
+                  <a:schemeClr val="accent2"/>
                 </a:solidFill>
               </a:rPr>
               <a:t>METHODOLOGICAL DECISION</a:t>
@@ -10548,7 +10670,7 @@
             <a:r>
               <a:rPr lang="en-US" sz="1200" i="1" dirty="0">
                 <a:solidFill>
-                  <a:srgbClr val="76838F"/>
+                  <a:srgbClr val="526579"/>
                 </a:solidFill>
               </a:rPr>
               <a:t>Highlighted: the best index for each hazard. Spearman ρ across 77 districts.</a:t>
@@ -10989,7 +11111,7 @@
             <a:r>
               <a:rPr lang="en-US" sz="1200" b="1" spc="200" kern="0" dirty="0">
                 <a:solidFill>
-                  <a:schemeClr val="accent4"/>
+                  <a:schemeClr val="accent2"/>
                 </a:solidFill>
               </a:rPr>
               <a:t>VALIDATION  |  DATA QUALITY</a:t>
@@ -11057,7 +11179,7 @@
           </a:solidFill>
           <a:ln w="9525">
             <a:solidFill>
-              <a:srgbClr val="C7D1DE"/>
+              <a:srgbClr val="9DBAD6"/>
             </a:solidFill>
             <a:prstDash val="solid"/>
           </a:ln>
@@ -11123,7 +11245,7 @@
           </a:solidFill>
           <a:ln w="9525">
             <a:solidFill>
-              <a:srgbClr val="C7D1DE"/>
+              <a:srgbClr val="9DBAD6"/>
             </a:solidFill>
             <a:prstDash val="solid"/>
           </a:ln>
@@ -11168,9 +11290,36 @@
           </a:p>
         </p:txBody>
       </p:sp>
+      <p:sp>
+        <p:nvSpPr>
+          <p:cNvPr id="8" name="chart panel"/>
+          <p:cNvSpPr/>
+          <p:nvPr/>
+        </p:nvSpPr>
+        <p:spPr>
+          <a:xfrm>
+            <a:off x="438912" y="1536192"/>
+            <a:ext cx="6803136" cy="4745736"/>
+          </a:xfrm>
+          <a:prstGeom prst="roundRect">
+            <a:avLst>
+              <a:gd name="adj" fmla="val 2312"/>
+            </a:avLst>
+          </a:prstGeom>
+          <a:solidFill>
+            <a:schemeClr val="bg1"/>
+          </a:solidFill>
+          <a:ln w="9525">
+            <a:solidFill>
+              <a:srgbClr val="E2E8F0"/>
+            </a:solidFill>
+            <a:prstDash val="solid"/>
+          </a:ln>
+        </p:spPr>
+      </p:sp>
       <p:graphicFrame>
         <p:nvGraphicFramePr>
-          <p:cNvPr id="8" name="Chart 0" descr=""/>
+          <p:cNvPr id="9" name="Chart 0" descr=""/>
           <p:cNvGraphicFramePr/>
           <p:nvPr/>
         </p:nvGraphicFramePr>
@@ -11186,7 +11335,7 @@
       </p:graphicFrame>
       <p:sp>
         <p:nvSpPr>
-          <p:cNvPr id="9" name="Reporting changed, not disasters circle"/>
+          <p:cNvPr id="10" name="Reporting changed, not disasters tile"/>
           <p:cNvSpPr/>
           <p:nvPr/>
         </p:nvSpPr>
@@ -11195,18 +11344,20 @@
             <a:off x="7498080" y="1645920"/>
             <a:ext cx="594360" cy="594360"/>
           </a:xfrm>
-          <a:prstGeom prst="ellipse">
-            <a:avLst/>
+          <a:prstGeom prst="roundRect">
+            <a:avLst>
+              <a:gd name="adj" fmla="val 22000"/>
+            </a:avLst>
           </a:prstGeom>
           <a:solidFill>
-            <a:schemeClr val="accent1"/>
+            <a:srgbClr val="E6F1F8"/>
           </a:solidFill>
           <a:ln/>
         </p:spPr>
       </p:sp>
       <p:pic>
         <p:nvPicPr>
-          <p:cNvPr id="10" name="Reporting changed, not disasters icon" descr="Reporting changed, not disasters">    </p:cNvPr>
+          <p:cNvPr id="11" name="Reporting changed, not disasters icon" descr="Reporting changed, not disasters">    </p:cNvPr>
           <p:cNvPicPr>
             <a:picLocks noChangeAspect="1"/>
           </p:cNvPicPr>
@@ -11220,8 +11371,8 @@
         </p:blipFill>
         <p:spPr>
           <a:xfrm>
-            <a:off x="7658557" y="1806397"/>
-            <a:ext cx="273406" cy="273406"/>
+            <a:off x="7646670" y="1794510"/>
+            <a:ext cx="297180" cy="297180"/>
           </a:xfrm>
           <a:prstGeom prst="rect">
             <a:avLst/>
@@ -11230,7 +11381,7 @@
       </p:pic>
       <p:sp>
         <p:nvSpPr>
-          <p:cNvPr id="11" name="Text 7"/>
+          <p:cNvPr id="12" name="Text 8"/>
           <p:cNvSpPr txBox="1"/>
           <p:nvPr/>
         </p:nvSpPr>
@@ -11266,7 +11417,7 @@
       </p:sp>
       <p:sp>
         <p:nvSpPr>
-          <p:cNvPr id="12" name="Text 8"/>
+          <p:cNvPr id="13" name="Text 9"/>
           <p:cNvSpPr txBox="1"/>
           <p:nvPr/>
         </p:nvSpPr>
@@ -11302,7 +11453,7 @@
       </p:sp>
       <p:sp>
         <p:nvSpPr>
-          <p:cNvPr id="13" name="The 26 Aug collapse is missing circle"/>
+          <p:cNvPr id="14" name="The 26 Aug collapse is missing tile"/>
           <p:cNvSpPr/>
           <p:nvPr/>
         </p:nvSpPr>
@@ -11311,18 +11462,20 @@
             <a:off x="7498080" y="3182112"/>
             <a:ext cx="594360" cy="594360"/>
           </a:xfrm>
-          <a:prstGeom prst="ellipse">
-            <a:avLst/>
+          <a:prstGeom prst="roundRect">
+            <a:avLst>
+              <a:gd name="adj" fmla="val 22000"/>
+            </a:avLst>
           </a:prstGeom>
           <a:solidFill>
-            <a:schemeClr val="accent1"/>
+            <a:srgbClr val="E6F1F8"/>
           </a:solidFill>
           <a:ln/>
         </p:spPr>
       </p:sp>
       <p:pic>
         <p:nvPicPr>
-          <p:cNvPr id="14" name="The 26 Aug collapse is missing icon" descr="The 26 Aug collapse is missing">    </p:cNvPr>
+          <p:cNvPr id="15" name="The 26 Aug collapse is missing icon" descr="The 26 Aug collapse is missing">    </p:cNvPr>
           <p:cNvPicPr>
             <a:picLocks noChangeAspect="1"/>
           </p:cNvPicPr>
@@ -11336,8 +11489,8 @@
         </p:blipFill>
         <p:spPr>
           <a:xfrm>
-            <a:off x="7658557" y="3342589"/>
-            <a:ext cx="273406" cy="273406"/>
+            <a:off x="7646670" y="3330702"/>
+            <a:ext cx="297180" cy="297180"/>
           </a:xfrm>
           <a:prstGeom prst="rect">
             <a:avLst/>
@@ -11346,7 +11499,7 @@
       </p:pic>
       <p:sp>
         <p:nvSpPr>
-          <p:cNvPr id="15" name="Text 10"/>
+          <p:cNvPr id="16" name="Text 11"/>
           <p:cNvSpPr txBox="1"/>
           <p:nvPr/>
         </p:nvSpPr>
@@ -11382,7 +11535,7 @@
       </p:sp>
       <p:sp>
         <p:nvSpPr>
-          <p:cNvPr id="16" name="Text 11"/>
+          <p:cNvPr id="17" name="Text 12"/>
           <p:cNvSpPr txBox="1"/>
           <p:nvPr/>
         </p:nvSpPr>
@@ -11418,7 +11571,7 @@
       </p:sp>
       <p:sp>
         <p:nvSpPr>
-          <p:cNvPr id="17" name="Glacial risk is invisible to our data circle"/>
+          <p:cNvPr id="18" name="Glacial risk is invisible to our data tile"/>
           <p:cNvSpPr/>
           <p:nvPr/>
         </p:nvSpPr>
@@ -11427,18 +11580,20 @@
             <a:off x="7498080" y="4718304"/>
             <a:ext cx="594360" cy="594360"/>
           </a:xfrm>
-          <a:prstGeom prst="ellipse">
-            <a:avLst/>
+          <a:prstGeom prst="roundRect">
+            <a:avLst>
+              <a:gd name="adj" fmla="val 22000"/>
+            </a:avLst>
           </a:prstGeom>
           <a:solidFill>
-            <a:schemeClr val="accent1"/>
+            <a:srgbClr val="E6F1F8"/>
           </a:solidFill>
           <a:ln/>
         </p:spPr>
       </p:sp>
       <p:pic>
         <p:nvPicPr>
-          <p:cNvPr id="18" name="Glacial risk is invisible to our data icon" descr="Glacial risk is invisible to our data">    </p:cNvPr>
+          <p:cNvPr id="19" name="Glacial risk is invisible to our data icon" descr="Glacial risk is invisible to our data">    </p:cNvPr>
           <p:cNvPicPr>
             <a:picLocks noChangeAspect="1"/>
           </p:cNvPicPr>
@@ -11452,8 +11607,8 @@
         </p:blipFill>
         <p:spPr>
           <a:xfrm>
-            <a:off x="7658557" y="4878781"/>
-            <a:ext cx="273406" cy="273406"/>
+            <a:off x="7646670" y="4866894"/>
+            <a:ext cx="297180" cy="297180"/>
           </a:xfrm>
           <a:prstGeom prst="rect">
             <a:avLst/>
@@ -11462,7 +11617,7 @@
       </p:pic>
       <p:sp>
         <p:nvSpPr>
-          <p:cNvPr id="19" name="Text 13"/>
+          <p:cNvPr id="20" name="Text 14"/>
           <p:cNvSpPr txBox="1"/>
           <p:nvPr/>
         </p:nvSpPr>
@@ -11498,7 +11653,7 @@
       </p:sp>
       <p:sp>
         <p:nvSpPr>
-          <p:cNvPr id="20" name="Text 14"/>
+          <p:cNvPr id="21" name="Text 15"/>
           <p:cNvSpPr txBox="1"/>
           <p:nvPr/>
         </p:nvSpPr>
@@ -11631,7 +11786,7 @@
             <a:r>
               <a:rPr lang="en-US" sz="1200" b="1" spc="200" kern="0" dirty="0">
                 <a:solidFill>
-                  <a:schemeClr val="accent4"/>
+                  <a:schemeClr val="accent2"/>
                 </a:solidFill>
               </a:rPr>
               <a:t>RECOMMENDATION</a:t>
@@ -11678,9 +11833,36 @@
           </a:p>
         </p:txBody>
       </p:sp>
+      <p:sp>
+        <p:nvSpPr>
+          <p:cNvPr id="4" name="chart panel"/>
+          <p:cNvSpPr/>
+          <p:nvPr/>
+        </p:nvSpPr>
+        <p:spPr>
+          <a:xfrm>
+            <a:off x="438912" y="1536192"/>
+            <a:ext cx="6986016" cy="4745736"/>
+          </a:xfrm>
+          <a:prstGeom prst="roundRect">
+            <a:avLst>
+              <a:gd name="adj" fmla="val 2312"/>
+            </a:avLst>
+          </a:prstGeom>
+          <a:solidFill>
+            <a:schemeClr val="bg1"/>
+          </a:solidFill>
+          <a:ln w="9525">
+            <a:solidFill>
+              <a:srgbClr val="E2E8F0"/>
+            </a:solidFill>
+            <a:prstDash val="solid"/>
+          </a:ln>
+        </p:spPr>
+      </p:sp>
       <p:graphicFrame>
         <p:nvGraphicFramePr>
-          <p:cNvPr id="4" name="Chart 0" descr=""/>
+          <p:cNvPr id="5" name="Chart 0" descr=""/>
           <p:cNvGraphicFramePr/>
           <p:nvPr/>
         </p:nvGraphicFramePr>
@@ -11696,7 +11878,7 @@
       </p:graphicFrame>
       <p:sp>
         <p:nvSpPr>
-          <p:cNvPr id="5" name="act card"/>
+          <p:cNvPr id="6" name="act card"/>
           <p:cNvSpPr/>
           <p:nvPr/>
         </p:nvSpPr>
@@ -11707,15 +11889,15 @@
           </a:xfrm>
           <a:prstGeom prst="roundRect">
             <a:avLst>
-              <a:gd name="adj" fmla="val 2174"/>
+              <a:gd name="adj" fmla="val 5217"/>
             </a:avLst>
           </a:prstGeom>
           <a:solidFill>
-            <a:schemeClr val="bg2"/>
+            <a:schemeClr val="bg1"/>
           </a:solidFill>
           <a:ln w="9525">
             <a:solidFill>
-              <a:srgbClr val="DDE2E7"/>
+              <a:srgbClr val="E2E8F0"/>
             </a:solidFill>
             <a:prstDash val="solid"/>
           </a:ln>
@@ -11723,7 +11905,7 @@
       </p:sp>
       <p:sp>
         <p:nvSpPr>
-          <p:cNvPr id="6" name="Text 3"/>
+          <p:cNvPr id="7" name="Text 4"/>
           <p:cNvSpPr txBox="1"/>
           <p:nvPr/>
         </p:nvSpPr>
@@ -11762,7 +11944,7 @@
       </p:sp>
       <p:sp>
         <p:nvSpPr>
-          <p:cNvPr id="7" name="Text 4"/>
+          <p:cNvPr id="8" name="Text 5"/>
           <p:cNvSpPr txBox="1"/>
           <p:nvPr/>
         </p:nvSpPr>
@@ -11798,7 +11980,7 @@
       </p:sp>
       <p:sp>
         <p:nvSpPr>
-          <p:cNvPr id="8" name="blind card"/>
+          <p:cNvPr id="9" name="blind card"/>
           <p:cNvSpPr/>
           <p:nvPr/>
         </p:nvSpPr>
@@ -11809,7 +11991,7 @@
           </a:xfrm>
           <a:prstGeom prst="roundRect">
             <a:avLst>
-              <a:gd name="adj" fmla="val 2128"/>
+              <a:gd name="adj" fmla="val 5106"/>
             </a:avLst>
           </a:prstGeom>
           <a:solidFill>
@@ -11820,7 +12002,7 @@
       </p:sp>
       <p:sp>
         <p:nvSpPr>
-          <p:cNvPr id="9" name="Text 6"/>
+          <p:cNvPr id="10" name="Text 7"/>
           <p:cNvSpPr txBox="1"/>
           <p:nvPr/>
         </p:nvSpPr>
@@ -11856,7 +12038,7 @@
       </p:sp>
       <p:sp>
         <p:nvSpPr>
-          <p:cNvPr id="10" name="Text 7"/>
+          <p:cNvPr id="11" name="Text 8"/>
           <p:cNvSpPr txBox="1"/>
           <p:nvPr/>
         </p:nvSpPr>
@@ -11989,7 +12171,7 @@
             <a:r>
               <a:rPr lang="en-US" sz="1200" b="1" spc="200" kern="0" dirty="0">
                 <a:solidFill>
-                  <a:schemeClr val="accent4"/>
+                  <a:schemeClr val="accent2"/>
                 </a:solidFill>
               </a:rPr>
               <a:t>RECOMMENDATION</a:t>
@@ -14013,7 +14195,7 @@
             <a:r>
               <a:rPr lang="en-US" sz="1200" b="1" spc="200" kern="0" dirty="0">
                 <a:solidFill>
-                  <a:schemeClr val="accent6"/>
+                  <a:srgbClr val="A9BCD0"/>
                 </a:solidFill>
               </a:rPr>
               <a:t>IN SUMMARY</a:t>
@@ -14087,7 +14269,7 @@
             <a:r>
               <a:rPr lang="en-US" sz="5400" b="1" dirty="0">
                 <a:solidFill>
-                  <a:schemeClr val="accent6"/>
+                  <a:srgbClr val="56B4E9"/>
                 </a:solidFill>
               </a:rPr>
               <a:t>1</a:t>
@@ -14195,7 +14377,7 @@
             <a:r>
               <a:rPr lang="en-US" sz="1200" b="1" dirty="0">
                 <a:solidFill>
-                  <a:schemeClr val="accent6"/>
+                  <a:srgbClr val="A9BCD0"/>
                 </a:solidFill>
                 <a:latin typeface="Consolas" pitchFamily="34" charset="0"/>
                 <a:ea typeface="Consolas" pitchFamily="34" charset="-122"/>
@@ -14234,7 +14416,7 @@
             <a:r>
               <a:rPr lang="en-US" sz="5400" b="1" dirty="0">
                 <a:solidFill>
-                  <a:schemeClr val="accent6"/>
+                  <a:srgbClr val="56B4E9"/>
                 </a:solidFill>
               </a:rPr>
               <a:t>2</a:t>
@@ -14342,7 +14524,7 @@
             <a:r>
               <a:rPr lang="en-US" sz="1200" b="1" dirty="0">
                 <a:solidFill>
-                  <a:schemeClr val="accent6"/>
+                  <a:srgbClr val="A9BCD0"/>
                 </a:solidFill>
                 <a:latin typeface="Consolas" pitchFamily="34" charset="0"/>
                 <a:ea typeface="Consolas" pitchFamily="34" charset="-122"/>
@@ -14381,7 +14563,7 @@
             <a:r>
               <a:rPr lang="en-US" sz="5400" b="1" dirty="0">
                 <a:solidFill>
-                  <a:schemeClr val="accent6"/>
+                  <a:srgbClr val="56B4E9"/>
                 </a:solidFill>
               </a:rPr>
               <a:t>3</a:t>
@@ -14489,7 +14671,7 @@
             <a:r>
               <a:rPr lang="en-US" sz="1200" b="1" dirty="0">
                 <a:solidFill>
-                  <a:schemeClr val="accent6"/>
+                  <a:srgbClr val="A9BCD0"/>
                 </a:solidFill>
                 <a:latin typeface="Consolas" pitchFamily="34" charset="0"/>
                 <a:ea typeface="Consolas" pitchFamily="34" charset="-122"/>
@@ -14528,7 +14710,7 @@
             <a:r>
               <a:rPr lang="en-US" sz="1100" dirty="0">
                 <a:solidFill>
-                  <a:schemeClr val="accent6"/>
+                  <a:srgbClr val="A9BCD0"/>
                 </a:solidFill>
               </a:rPr>
               <a:t>Full method, code and assumptions: nepal_risk_assessment.ipynb</a:t>
@@ -14591,7 +14773,7 @@
             <a:r>
               <a:rPr lang="en-US" sz="1200" b="1" spc="200" kern="0" dirty="0">
                 <a:solidFill>
-                  <a:schemeClr val="accent4"/>
+                  <a:schemeClr val="accent2"/>
                 </a:solidFill>
               </a:rPr>
               <a:t>APPENDIX</a:t>
@@ -15271,7 +15453,7 @@
             <a:r>
               <a:rPr lang="en-US" sz="1200" b="1" spc="200" kern="0" dirty="0">
                 <a:solidFill>
-                  <a:schemeClr val="accent4"/>
+                  <a:schemeClr val="accent2"/>
                 </a:solidFill>
               </a:rPr>
               <a:t>THE EVENT</a:t>
@@ -15320,7 +15502,7 @@
       </p:sp>
       <p:sp>
         <p:nvSpPr>
-          <p:cNvPr id="4" name="Trigger circle"/>
+          <p:cNvPr id="4" name="Trigger tile"/>
           <p:cNvSpPr/>
           <p:nvPr/>
         </p:nvSpPr>
@@ -15329,11 +15511,13 @@
             <a:off x="548640" y="1783080"/>
             <a:ext cx="731520" cy="731520"/>
           </a:xfrm>
-          <a:prstGeom prst="ellipse">
-            <a:avLst/>
+          <a:prstGeom prst="roundRect">
+            <a:avLst>
+              <a:gd name="adj" fmla="val 22000"/>
+            </a:avLst>
           </a:prstGeom>
           <a:solidFill>
-            <a:schemeClr val="accent1"/>
+            <a:srgbClr val="E6F1F8"/>
           </a:solidFill>
           <a:ln/>
         </p:spPr>
@@ -15354,8 +15538,8 @@
         </p:blipFill>
         <p:spPr>
           <a:xfrm>
-            <a:off x="746150" y="1980590"/>
-            <a:ext cx="336499" cy="336499"/>
+            <a:off x="731520" y="1965960"/>
+            <a:ext cx="365760" cy="365760"/>
           </a:xfrm>
           <a:prstGeom prst="rect">
             <a:avLst/>
@@ -15436,7 +15620,7 @@
       </p:sp>
       <p:sp>
         <p:nvSpPr>
-          <p:cNvPr id="8" name="Path circle"/>
+          <p:cNvPr id="8" name="Path tile"/>
           <p:cNvSpPr/>
           <p:nvPr/>
         </p:nvSpPr>
@@ -15445,11 +15629,13 @@
             <a:off x="548640" y="2880360"/>
             <a:ext cx="731520" cy="731520"/>
           </a:xfrm>
-          <a:prstGeom prst="ellipse">
-            <a:avLst/>
+          <a:prstGeom prst="roundRect">
+            <a:avLst>
+              <a:gd name="adj" fmla="val 22000"/>
+            </a:avLst>
           </a:prstGeom>
           <a:solidFill>
-            <a:schemeClr val="accent1"/>
+            <a:srgbClr val="E6F1F8"/>
           </a:solidFill>
           <a:ln/>
         </p:spPr>
@@ -15470,8 +15656,8 @@
         </p:blipFill>
         <p:spPr>
           <a:xfrm>
-            <a:off x="746150" y="3077870"/>
-            <a:ext cx="336499" cy="336499"/>
+            <a:off x="731520" y="3063240"/>
+            <a:ext cx="365760" cy="365760"/>
           </a:xfrm>
           <a:prstGeom prst="rect">
             <a:avLst/>
@@ -15552,7 +15738,7 @@
       </p:sp>
       <p:sp>
         <p:nvSpPr>
-          <p:cNvPr id="12" name="Human cost circle"/>
+          <p:cNvPr id="12" name="Human cost tile"/>
           <p:cNvSpPr/>
           <p:nvPr/>
         </p:nvSpPr>
@@ -15561,11 +15747,13 @@
             <a:off x="548640" y="3977640"/>
             <a:ext cx="731520" cy="731520"/>
           </a:xfrm>
-          <a:prstGeom prst="ellipse">
-            <a:avLst/>
+          <a:prstGeom prst="roundRect">
+            <a:avLst>
+              <a:gd name="adj" fmla="val 22000"/>
+            </a:avLst>
           </a:prstGeom>
           <a:solidFill>
-            <a:schemeClr val="accent1"/>
+            <a:srgbClr val="E6F1F8"/>
           </a:solidFill>
           <a:ln/>
         </p:spPr>
@@ -15586,8 +15774,8 @@
         </p:blipFill>
         <p:spPr>
           <a:xfrm>
-            <a:off x="746150" y="4175150"/>
-            <a:ext cx="336499" cy="336499"/>
+            <a:off x="731520" y="4160520"/>
+            <a:ext cx="365760" cy="365760"/>
           </a:xfrm>
           <a:prstGeom prst="rect">
             <a:avLst/>
@@ -15668,7 +15856,7 @@
       </p:sp>
       <p:sp>
         <p:nvSpPr>
-          <p:cNvPr id="16" name="Assets circle"/>
+          <p:cNvPr id="16" name="Assets tile"/>
           <p:cNvSpPr/>
           <p:nvPr/>
         </p:nvSpPr>
@@ -15677,11 +15865,13 @@
             <a:off x="548640" y="5074920"/>
             <a:ext cx="731520" cy="731520"/>
           </a:xfrm>
-          <a:prstGeom prst="ellipse">
-            <a:avLst/>
+          <a:prstGeom prst="roundRect">
+            <a:avLst>
+              <a:gd name="adj" fmla="val 22000"/>
+            </a:avLst>
           </a:prstGeom>
           <a:solidFill>
-            <a:schemeClr val="accent1"/>
+            <a:srgbClr val="E6F1F8"/>
           </a:solidFill>
           <a:ln/>
         </p:spPr>
@@ -15702,8 +15892,8 @@
         </p:blipFill>
         <p:spPr>
           <a:xfrm>
-            <a:off x="746150" y="5272430"/>
-            <a:ext cx="336499" cy="336499"/>
+            <a:off x="731520" y="5257800"/>
+            <a:ext cx="365760" cy="365760"/>
           </a:xfrm>
           <a:prstGeom prst="rect">
             <a:avLst/>
@@ -15795,7 +15985,7 @@
           </a:xfrm>
           <a:prstGeom prst="roundRect">
             <a:avLst>
-              <a:gd name="adj" fmla="val 1053"/>
+              <a:gd name="adj" fmla="val 2526"/>
             </a:avLst>
           </a:prstGeom>
           <a:solidFill>
@@ -15831,7 +16021,7 @@
             <a:r>
               <a:rPr lang="en-US" sz="1200" b="1" spc="200" kern="0" dirty="0">
                 <a:solidFill>
-                  <a:schemeClr val="accent6"/>
+                  <a:srgbClr val="A9BCD0"/>
                 </a:solidFill>
               </a:rPr>
               <a:t>THE CENTRAL QUESTION</a:t>
@@ -15975,7 +16165,7 @@
             <a:r>
               <a:rPr lang="en-US" sz="1200" b="1" spc="200" kern="0" dirty="0">
                 <a:solidFill>
-                  <a:schemeClr val="accent4"/>
+                  <a:schemeClr val="accent2"/>
                 </a:solidFill>
               </a:rPr>
               <a:t>OUR APPROACH</a:t>
@@ -16024,7 +16214,7 @@
       </p:sp>
       <p:sp>
         <p:nvSpPr>
-          <p:cNvPr id="4" name="Hazard circle"/>
+          <p:cNvPr id="4" name="Hazard tile"/>
           <p:cNvSpPr/>
           <p:nvPr/>
         </p:nvSpPr>
@@ -16033,11 +16223,13 @@
             <a:off x="1417320" y="1645920"/>
             <a:ext cx="1280160" cy="1280160"/>
           </a:xfrm>
-          <a:prstGeom prst="ellipse">
-            <a:avLst/>
+          <a:prstGeom prst="roundRect">
+            <a:avLst>
+              <a:gd name="adj" fmla="val 22000"/>
+            </a:avLst>
           </a:prstGeom>
           <a:solidFill>
-            <a:schemeClr val="accent3"/>
+            <a:srgbClr val="E6F1F8"/>
           </a:solidFill>
           <a:ln/>
         </p:spPr>
@@ -16058,8 +16250,8 @@
         </p:blipFill>
         <p:spPr>
           <a:xfrm>
-            <a:off x="1762963" y="1991563"/>
-            <a:ext cx="588874" cy="588874"/>
+            <a:off x="1737360" y="1965960"/>
+            <a:ext cx="640080" cy="640080"/>
           </a:xfrm>
           <a:prstGeom prst="rect">
             <a:avLst/>
@@ -16176,7 +16368,7 @@
       </p:sp>
       <p:sp>
         <p:nvSpPr>
-          <p:cNvPr id="9" name="Exposure circle"/>
+          <p:cNvPr id="9" name="Exposure tile"/>
           <p:cNvSpPr/>
           <p:nvPr/>
         </p:nvSpPr>
@@ -16185,11 +16377,13 @@
             <a:off x="5367528" y="1645920"/>
             <a:ext cx="1280160" cy="1280160"/>
           </a:xfrm>
-          <a:prstGeom prst="ellipse">
-            <a:avLst/>
+          <a:prstGeom prst="roundRect">
+            <a:avLst>
+              <a:gd name="adj" fmla="val 22000"/>
+            </a:avLst>
           </a:prstGeom>
           <a:solidFill>
-            <a:schemeClr val="accent2"/>
+            <a:srgbClr val="E6F1F8"/>
           </a:solidFill>
           <a:ln/>
         </p:spPr>
@@ -16210,8 +16404,8 @@
         </p:blipFill>
         <p:spPr>
           <a:xfrm>
-            <a:off x="5713171" y="1991563"/>
-            <a:ext cx="588874" cy="588874"/>
+            <a:off x="5687568" y="1965960"/>
+            <a:ext cx="640080" cy="640080"/>
           </a:xfrm>
           <a:prstGeom prst="rect">
             <a:avLst/>
@@ -16328,7 +16522,7 @@
       </p:sp>
       <p:sp>
         <p:nvSpPr>
-          <p:cNvPr id="14" name="Vulnerability circle"/>
+          <p:cNvPr id="14" name="Vulnerability tile"/>
           <p:cNvSpPr/>
           <p:nvPr/>
         </p:nvSpPr>
@@ -16337,11 +16531,13 @@
             <a:off x="9317736" y="1645920"/>
             <a:ext cx="1280160" cy="1280160"/>
           </a:xfrm>
-          <a:prstGeom prst="ellipse">
-            <a:avLst/>
+          <a:prstGeom prst="roundRect">
+            <a:avLst>
+              <a:gd name="adj" fmla="val 22000"/>
+            </a:avLst>
           </a:prstGeom>
           <a:solidFill>
-            <a:schemeClr val="accent1"/>
+            <a:srgbClr val="E6F1F8"/>
           </a:solidFill>
           <a:ln/>
         </p:spPr>
@@ -16362,8 +16558,8 @@
         </p:blipFill>
         <p:spPr>
           <a:xfrm>
-            <a:off x="9663379" y="1991563"/>
-            <a:ext cx="588874" cy="588874"/>
+            <a:off x="9637776" y="1965960"/>
+            <a:ext cx="640080" cy="640080"/>
           </a:xfrm>
           <a:prstGeom prst="rect">
             <a:avLst/>
@@ -16455,15 +16651,15 @@
           </a:xfrm>
           <a:prstGeom prst="roundRect">
             <a:avLst>
-              <a:gd name="adj" fmla="val 3030"/>
+              <a:gd name="adj" fmla="val 7273"/>
             </a:avLst>
           </a:prstGeom>
           <a:solidFill>
-            <a:schemeClr val="bg2"/>
+            <a:schemeClr val="bg1"/>
           </a:solidFill>
           <a:ln w="9525">
             <a:solidFill>
-              <a:srgbClr val="DDE2E7"/>
+              <a:srgbClr val="E2E8F0"/>
             </a:solidFill>
             <a:prstDash val="solid"/>
           </a:ln>
@@ -16554,15 +16750,15 @@
           </a:xfrm>
           <a:prstGeom prst="roundRect">
             <a:avLst>
-              <a:gd name="adj" fmla="val 3030"/>
+              <a:gd name="adj" fmla="val 7273"/>
             </a:avLst>
           </a:prstGeom>
           <a:solidFill>
-            <a:schemeClr val="bg2"/>
+            <a:schemeClr val="bg1"/>
           </a:solidFill>
           <a:ln w="9525">
             <a:solidFill>
-              <a:srgbClr val="DDE2E7"/>
+              <a:srgbClr val="E2E8F0"/>
             </a:solidFill>
             <a:prstDash val="solid"/>
           </a:ln>
@@ -16653,15 +16849,15 @@
           </a:xfrm>
           <a:prstGeom prst="roundRect">
             <a:avLst>
-              <a:gd name="adj" fmla="val 3030"/>
+              <a:gd name="adj" fmla="val 7273"/>
             </a:avLst>
           </a:prstGeom>
           <a:solidFill>
-            <a:schemeClr val="bg2"/>
+            <a:schemeClr val="bg1"/>
           </a:solidFill>
           <a:ln w="9525">
             <a:solidFill>
-              <a:srgbClr val="DDE2E7"/>
+              <a:srgbClr val="E2E8F0"/>
             </a:solidFill>
             <a:prstDash val="solid"/>
           </a:ln>
@@ -16838,7 +17034,7 @@
             <a:r>
               <a:rPr lang="en-US" sz="1200" b="1" spc="200" kern="0" dirty="0">
                 <a:solidFill>
-                  <a:schemeClr val="accent4"/>
+                  <a:schemeClr val="accent2"/>
                 </a:solidFill>
               </a:rPr>
               <a:t>THE DATA</a:t>
@@ -16923,7 +17119,7 @@
       </p:sp>
       <p:sp>
         <p:nvSpPr>
-          <p:cNvPr id="5" name="Climate: NASA POWER circle"/>
+          <p:cNvPr id="5" name="Climate: NASA POWER tile"/>
           <p:cNvSpPr/>
           <p:nvPr/>
         </p:nvSpPr>
@@ -16932,11 +17128,13 @@
             <a:off x="548640" y="2194560"/>
             <a:ext cx="640080" cy="640080"/>
           </a:xfrm>
-          <a:prstGeom prst="ellipse">
-            <a:avLst/>
+          <a:prstGeom prst="roundRect">
+            <a:avLst>
+              <a:gd name="adj" fmla="val 22000"/>
+            </a:avLst>
           </a:prstGeom>
           <a:solidFill>
-            <a:schemeClr val="accent1"/>
+            <a:srgbClr val="E6F1F8"/>
           </a:solidFill>
           <a:ln/>
         </p:spPr>
@@ -16957,8 +17155,8 @@
         </p:blipFill>
         <p:spPr>
           <a:xfrm>
-            <a:off x="721462" y="2367382"/>
-            <a:ext cx="294437" cy="294437"/>
+            <a:off x="708660" y="2354580"/>
+            <a:ext cx="320040" cy="320040"/>
           </a:xfrm>
           <a:prstGeom prst="rect">
             <a:avLst/>
@@ -17028,7 +17226,7 @@
             <a:r>
               <a:rPr lang="en-US" sz="1300" dirty="0">
                 <a:solidFill>
-                  <a:srgbClr val="76838F"/>
+                  <a:srgbClr val="526579"/>
                 </a:solidFill>
               </a:rPr>
               <a:t>Daily rainfall and temperature, 1990-2026</a:t>
@@ -17039,7 +17237,7 @@
       </p:sp>
       <p:sp>
         <p:nvSpPr>
-          <p:cNvPr id="9" name="Terrain and rivers: HydroSHEDS circle"/>
+          <p:cNvPr id="9" name="Terrain and rivers: HydroSHEDS tile"/>
           <p:cNvSpPr/>
           <p:nvPr/>
         </p:nvSpPr>
@@ -17048,11 +17246,13 @@
             <a:off x="548640" y="3218688"/>
             <a:ext cx="640080" cy="640080"/>
           </a:xfrm>
-          <a:prstGeom prst="ellipse">
-            <a:avLst/>
+          <a:prstGeom prst="roundRect">
+            <a:avLst>
+              <a:gd name="adj" fmla="val 22000"/>
+            </a:avLst>
           </a:prstGeom>
           <a:solidFill>
-            <a:schemeClr val="accent1"/>
+            <a:srgbClr val="E6F1F8"/>
           </a:solidFill>
           <a:ln/>
         </p:spPr>
@@ -17073,8 +17273,8 @@
         </p:blipFill>
         <p:spPr>
           <a:xfrm>
-            <a:off x="721462" y="3391510"/>
-            <a:ext cx="294437" cy="294437"/>
+            <a:off x="708660" y="3378708"/>
+            <a:ext cx="320040" cy="320040"/>
           </a:xfrm>
           <a:prstGeom prst="rect">
             <a:avLst/>
@@ -17144,7 +17344,7 @@
             <a:r>
               <a:rPr lang="en-US" sz="1300" dirty="0">
                 <a:solidFill>
-                  <a:srgbClr val="76838F"/>
+                  <a:srgbClr val="526579"/>
                 </a:solidFill>
               </a:rPr>
               <a:t>Elevation, river size, distance to rivers</a:t>
@@ -17155,7 +17355,7 @@
       </p:sp>
       <p:sp>
         <p:nvSpPr>
-          <p:cNvPr id="13" name="Exposure: Census 2021, OpenStreetMap circle"/>
+          <p:cNvPr id="13" name="Exposure: Census 2021, OpenStreetMap tile"/>
           <p:cNvSpPr/>
           <p:nvPr/>
         </p:nvSpPr>
@@ -17164,11 +17364,13 @@
             <a:off x="548640" y="4242816"/>
             <a:ext cx="640080" cy="640080"/>
           </a:xfrm>
-          <a:prstGeom prst="ellipse">
-            <a:avLst/>
+          <a:prstGeom prst="roundRect">
+            <a:avLst>
+              <a:gd name="adj" fmla="val 22000"/>
+            </a:avLst>
           </a:prstGeom>
           <a:solidFill>
-            <a:schemeClr val="accent1"/>
+            <a:srgbClr val="E6F1F8"/>
           </a:solidFill>
           <a:ln/>
         </p:spPr>
@@ -17189,8 +17391,8 @@
         </p:blipFill>
         <p:spPr>
           <a:xfrm>
-            <a:off x="721462" y="4415638"/>
-            <a:ext cx="294437" cy="294437"/>
+            <a:off x="708660" y="4402836"/>
+            <a:ext cx="320040" cy="320040"/>
           </a:xfrm>
           <a:prstGeom prst="rect">
             <a:avLst/>
@@ -17260,7 +17462,7 @@
             <a:r>
               <a:rPr lang="en-US" sz="1300" dirty="0">
                 <a:solidFill>
-                  <a:srgbClr val="76838F"/>
+                  <a:srgbClr val="526579"/>
                 </a:solidFill>
               </a:rPr>
               <a:t>Population, hospitals, schools, roads, hydropower</a:t>
@@ -17271,7 +17473,7 @@
       </p:sp>
       <p:sp>
         <p:nvSpPr>
-          <p:cNvPr id="17" name="Disasters: BIPAD Portal circle"/>
+          <p:cNvPr id="17" name="Disasters: BIPAD Portal tile"/>
           <p:cNvSpPr/>
           <p:nvPr/>
         </p:nvSpPr>
@@ -17280,11 +17482,13 @@
             <a:off x="548640" y="5266944"/>
             <a:ext cx="640080" cy="640080"/>
           </a:xfrm>
-          <a:prstGeom prst="ellipse">
-            <a:avLst/>
+          <a:prstGeom prst="roundRect">
+            <a:avLst>
+              <a:gd name="adj" fmla="val 22000"/>
+            </a:avLst>
           </a:prstGeom>
           <a:solidFill>
-            <a:schemeClr val="accent1"/>
+            <a:srgbClr val="E6F1F8"/>
           </a:solidFill>
           <a:ln/>
         </p:spPr>
@@ -17305,8 +17509,8 @@
         </p:blipFill>
         <p:spPr>
           <a:xfrm>
-            <a:off x="721462" y="5439766"/>
-            <a:ext cx="294437" cy="294437"/>
+            <a:off x="708660" y="5426964"/>
+            <a:ext cx="320040" cy="320040"/>
           </a:xfrm>
           <a:prstGeom prst="rect">
             <a:avLst/>
@@ -17376,7 +17580,7 @@
             <a:r>
               <a:rPr lang="en-US" sz="1300" dirty="0">
                 <a:solidFill>
-                  <a:srgbClr val="76838F"/>
+                  <a:srgbClr val="526579"/>
                 </a:solidFill>
               </a:rPr>
               <a:t>12,341 floods, landslides and rain events after removing duplicates</a:t>
@@ -17434,15 +17638,15 @@
           </a:xfrm>
           <a:prstGeom prst="roundRect">
             <a:avLst>
-              <a:gd name="adj" fmla="val 2500"/>
+              <a:gd name="adj" fmla="val 6000"/>
             </a:avLst>
           </a:prstGeom>
           <a:solidFill>
-            <a:schemeClr val="bg2"/>
+            <a:schemeClr val="bg1"/>
           </a:solidFill>
           <a:ln w="9525">
             <a:solidFill>
-              <a:srgbClr val="DDE2E7"/>
+              <a:srgbClr val="E2E8F0"/>
             </a:solidFill>
             <a:prstDash val="solid"/>
           </a:ln>
@@ -17533,15 +17737,15 @@
           </a:xfrm>
           <a:prstGeom prst="roundRect">
             <a:avLst>
-              <a:gd name="adj" fmla="val 2500"/>
+              <a:gd name="adj" fmla="val 6000"/>
             </a:avLst>
           </a:prstGeom>
           <a:solidFill>
-            <a:schemeClr val="bg2"/>
+            <a:schemeClr val="bg1"/>
           </a:solidFill>
           <a:ln w="9525">
             <a:solidFill>
-              <a:srgbClr val="DDE2E7"/>
+              <a:srgbClr val="E2E8F0"/>
             </a:solidFill>
             <a:prstDash val="solid"/>
           </a:ln>
@@ -17632,15 +17836,15 @@
           </a:xfrm>
           <a:prstGeom prst="roundRect">
             <a:avLst>
-              <a:gd name="adj" fmla="val 2500"/>
+              <a:gd name="adj" fmla="val 6000"/>
             </a:avLst>
           </a:prstGeom>
           <a:solidFill>
-            <a:schemeClr val="bg2"/>
+            <a:schemeClr val="bg1"/>
           </a:solidFill>
           <a:ln w="9525">
             <a:solidFill>
-              <a:srgbClr val="DDE2E7"/>
+              <a:srgbClr val="E2E8F0"/>
             </a:solidFill>
             <a:prstDash val="solid"/>
           </a:ln>
@@ -17731,15 +17935,15 @@
           </a:xfrm>
           <a:prstGeom prst="roundRect">
             <a:avLst>
-              <a:gd name="adj" fmla="val 2500"/>
+              <a:gd name="adj" fmla="val 6000"/>
             </a:avLst>
           </a:prstGeom>
           <a:solidFill>
-            <a:schemeClr val="bg2"/>
+            <a:schemeClr val="bg1"/>
           </a:solidFill>
           <a:ln w="9525">
             <a:solidFill>
-              <a:srgbClr val="DDE2E7"/>
+              <a:srgbClr val="E2E8F0"/>
             </a:solidFill>
             <a:prstDash val="solid"/>
           </a:ln>
@@ -17916,7 +18120,7 @@
             <a:r>
               <a:rPr lang="en-US" sz="1200" b="1" spc="200" kern="0" dirty="0">
                 <a:solidFill>
-                  <a:schemeClr val="accent4"/>
+                  <a:schemeClr val="accent2"/>
                 </a:solidFill>
               </a:rPr>
               <a:t>CLIMATE  |  2004-2025</a:t>
@@ -17984,7 +18188,7 @@
           </a:solidFill>
           <a:ln w="9525">
             <a:solidFill>
-              <a:srgbClr val="C7D1DE"/>
+              <a:srgbClr val="9DBAD6"/>
             </a:solidFill>
             <a:prstDash val="solid"/>
           </a:ln>
@@ -18029,9 +18233,36 @@
           </a:p>
         </p:txBody>
       </p:sp>
+      <p:sp>
+        <p:nvSpPr>
+          <p:cNvPr id="6" name="chart panel"/>
+          <p:cNvSpPr/>
+          <p:nvPr/>
+        </p:nvSpPr>
+        <p:spPr>
+          <a:xfrm>
+            <a:off x="438912" y="1536192"/>
+            <a:ext cx="7443216" cy="4745736"/>
+          </a:xfrm>
+          <a:prstGeom prst="roundRect">
+            <a:avLst>
+              <a:gd name="adj" fmla="val 2312"/>
+            </a:avLst>
+          </a:prstGeom>
+          <a:solidFill>
+            <a:schemeClr val="bg1"/>
+          </a:solidFill>
+          <a:ln w="9525">
+            <a:solidFill>
+              <a:srgbClr val="E2E8F0"/>
+            </a:solidFill>
+            <a:prstDash val="solid"/>
+          </a:ln>
+        </p:spPr>
+      </p:sp>
       <p:graphicFrame>
         <p:nvGraphicFramePr>
-          <p:cNvPr id="6" name="Chart 0" descr=""/>
+          <p:cNvPr id="7" name="Chart 0" descr=""/>
           <p:cNvGraphicFramePr/>
           <p:nvPr/>
         </p:nvGraphicFramePr>
@@ -18047,7 +18278,7 @@
       </p:graphicFrame>
       <p:sp>
         <p:nvSpPr>
-          <p:cNvPr id="7" name="Text 4"/>
+          <p:cNvPr id="8" name="Text 5"/>
           <p:cNvSpPr txBox="1"/>
           <p:nvPr/>
         </p:nvSpPr>
@@ -18086,7 +18317,7 @@
       </p:sp>
       <p:sp>
         <p:nvSpPr>
-          <p:cNvPr id="8" name="Text 5"/>
+          <p:cNvPr id="9" name="Text 6"/>
           <p:cNvSpPr txBox="1"/>
           <p:nvPr/>
         </p:nvSpPr>
@@ -18122,7 +18353,7 @@
       </p:sp>
       <p:sp>
         <p:nvSpPr>
-          <p:cNvPr id="9" name="Text 6"/>
+          <p:cNvPr id="10" name="Text 7"/>
           <p:cNvSpPr txBox="1"/>
           <p:nvPr/>
         </p:nvSpPr>
@@ -18161,7 +18392,7 @@
       </p:sp>
       <p:sp>
         <p:nvSpPr>
-          <p:cNvPr id="10" name="Text 7"/>
+          <p:cNvPr id="11" name="Text 8"/>
           <p:cNvSpPr txBox="1"/>
           <p:nvPr/>
         </p:nvSpPr>
@@ -18197,7 +18428,7 @@
       </p:sp>
       <p:sp>
         <p:nvSpPr>
-          <p:cNvPr id="11" name="Text 8"/>
+          <p:cNvPr id="12" name="Text 9"/>
           <p:cNvSpPr txBox="1"/>
           <p:nvPr/>
         </p:nvSpPr>
@@ -18236,7 +18467,7 @@
       </p:sp>
       <p:sp>
         <p:nvSpPr>
-          <p:cNvPr id="12" name="Text 9"/>
+          <p:cNvPr id="13" name="Text 10"/>
           <p:cNvSpPr txBox="1"/>
           <p:nvPr/>
         </p:nvSpPr>
@@ -18369,7 +18600,7 @@
             <a:r>
               <a:rPr lang="en-US" sz="1200" b="1" spc="200" kern="0" dirty="0">
                 <a:solidFill>
-                  <a:schemeClr val="accent4"/>
+                  <a:schemeClr val="accent2"/>
                 </a:solidFill>
               </a:rPr>
               <a:t>CLIMATE  |  EXTREMES</a:t>
@@ -18437,7 +18668,7 @@
           </a:solidFill>
           <a:ln w="9525">
             <a:solidFill>
-              <a:srgbClr val="C7D1DE"/>
+              <a:srgbClr val="9DBAD6"/>
             </a:solidFill>
             <a:prstDash val="solid"/>
           </a:ln>
@@ -18503,7 +18734,7 @@
           </a:solidFill>
           <a:ln w="9525">
             <a:solidFill>
-              <a:srgbClr val="C7D1DE"/>
+              <a:srgbClr val="9DBAD6"/>
             </a:solidFill>
             <a:prstDash val="solid"/>
           </a:ln>
@@ -18548,9 +18779,36 @@
           </a:p>
         </p:txBody>
       </p:sp>
+      <p:sp>
+        <p:nvSpPr>
+          <p:cNvPr id="8" name="chart panel"/>
+          <p:cNvSpPr/>
+          <p:nvPr/>
+        </p:nvSpPr>
+        <p:spPr>
+          <a:xfrm>
+            <a:off x="438912" y="1536192"/>
+            <a:ext cx="7168896" cy="4745736"/>
+          </a:xfrm>
+          <a:prstGeom prst="roundRect">
+            <a:avLst>
+              <a:gd name="adj" fmla="val 2312"/>
+            </a:avLst>
+          </a:prstGeom>
+          <a:solidFill>
+            <a:schemeClr val="bg1"/>
+          </a:solidFill>
+          <a:ln w="9525">
+            <a:solidFill>
+              <a:srgbClr val="E2E8F0"/>
+            </a:solidFill>
+            <a:prstDash val="solid"/>
+          </a:ln>
+        </p:spPr>
+      </p:sp>
       <p:graphicFrame>
         <p:nvGraphicFramePr>
-          <p:cNvPr id="8" name="Chart 0" descr=""/>
+          <p:cNvPr id="9" name="Chart 0" descr=""/>
           <p:cNvGraphicFramePr/>
           <p:nvPr/>
         </p:nvGraphicFramePr>
@@ -18566,7 +18824,7 @@
       </p:graphicFrame>
       <p:sp>
         <p:nvSpPr>
-          <p:cNvPr id="9" name="Text 6"/>
+          <p:cNvPr id="10" name="Text 7"/>
           <p:cNvSpPr txBox="1"/>
           <p:nvPr/>
         </p:nvSpPr>
@@ -18605,7 +18863,7 @@
       </p:sp>
       <p:sp>
         <p:nvSpPr>
-          <p:cNvPr id="10" name="Text 7"/>
+          <p:cNvPr id="11" name="Text 8"/>
           <p:cNvSpPr txBox="1"/>
           <p:nvPr/>
         </p:nvSpPr>
@@ -18641,7 +18899,7 @@
       </p:sp>
       <p:sp>
         <p:nvSpPr>
-          <p:cNvPr id="11" name="event card"/>
+          <p:cNvPr id="12" name="event card"/>
           <p:cNvSpPr/>
           <p:nvPr/>
         </p:nvSpPr>
@@ -18652,7 +18910,7 @@
           </a:xfrm>
           <a:prstGeom prst="roundRect">
             <a:avLst>
-              <a:gd name="adj" fmla="val 1613"/>
+              <a:gd name="adj" fmla="val 3871"/>
             </a:avLst>
           </a:prstGeom>
           <a:solidFill>
@@ -18663,7 +18921,7 @@
       </p:sp>
       <p:sp>
         <p:nvSpPr>
-          <p:cNvPr id="12" name="Text 9"/>
+          <p:cNvPr id="13" name="Text 10"/>
           <p:cNvSpPr txBox="1"/>
           <p:nvPr/>
         </p:nvSpPr>
@@ -18699,7 +18957,7 @@
       </p:sp>
       <p:sp>
         <p:nvSpPr>
-          <p:cNvPr id="13" name="Text 10"/>
+          <p:cNvPr id="14" name="Text 11"/>
           <p:cNvSpPr txBox="1"/>
           <p:nvPr/>
         </p:nvSpPr>
@@ -18832,7 +19090,7 @@
             <a:r>
               <a:rPr lang="en-US" sz="1200" b="1" spc="200" kern="0" dirty="0">
                 <a:solidFill>
-                  <a:schemeClr val="accent4"/>
+                  <a:schemeClr val="accent2"/>
                 </a:solidFill>
               </a:rPr>
               <a:t>TERRAIN AND RIVERS</a:t>
@@ -18900,7 +19158,7 @@
           </a:solidFill>
           <a:ln w="9525">
             <a:solidFill>
-              <a:srgbClr val="C7D1DE"/>
+              <a:srgbClr val="9DBAD6"/>
             </a:solidFill>
             <a:prstDash val="solid"/>
           </a:ln>
@@ -18945,9 +19203,36 @@
           </a:p>
         </p:txBody>
       </p:sp>
+      <p:sp>
+        <p:nvSpPr>
+          <p:cNvPr id="6" name="chart panel"/>
+          <p:cNvSpPr/>
+          <p:nvPr/>
+        </p:nvSpPr>
+        <p:spPr>
+          <a:xfrm>
+            <a:off x="438912" y="1536192"/>
+            <a:ext cx="6986016" cy="4745736"/>
+          </a:xfrm>
+          <a:prstGeom prst="roundRect">
+            <a:avLst>
+              <a:gd name="adj" fmla="val 2312"/>
+            </a:avLst>
+          </a:prstGeom>
+          <a:solidFill>
+            <a:schemeClr val="bg1"/>
+          </a:solidFill>
+          <a:ln w="9525">
+            <a:solidFill>
+              <a:srgbClr val="E2E8F0"/>
+            </a:solidFill>
+            <a:prstDash val="solid"/>
+          </a:ln>
+        </p:spPr>
+      </p:sp>
       <p:graphicFrame>
         <p:nvGraphicFramePr>
-          <p:cNvPr id="6" name="Chart 0" descr=""/>
+          <p:cNvPr id="7" name="Chart 0" descr=""/>
           <p:cNvGraphicFramePr/>
           <p:nvPr/>
         </p:nvGraphicFramePr>
@@ -18963,7 +19248,7 @@
       </p:graphicFrame>
       <p:sp>
         <p:nvSpPr>
-          <p:cNvPr id="7" name="Text 4"/>
+          <p:cNvPr id="8" name="Text 5"/>
           <p:cNvSpPr txBox="1"/>
           <p:nvPr/>
         </p:nvSpPr>
@@ -18999,7 +19284,7 @@
       </p:sp>
       <p:sp>
         <p:nvSpPr>
-          <p:cNvPr id="8" name="chip Gorkha"/>
+          <p:cNvPr id="9" name="chip Gorkha"/>
           <p:cNvSpPr/>
           <p:nvPr/>
         </p:nvSpPr>
@@ -19010,15 +19295,15 @@
           </a:xfrm>
           <a:prstGeom prst="roundRect">
             <a:avLst>
-              <a:gd name="adj" fmla="val 10870"/>
+              <a:gd name="adj" fmla="val 26087"/>
             </a:avLst>
           </a:prstGeom>
           <a:solidFill>
-            <a:schemeClr val="bg2"/>
+            <a:schemeClr val="bg1"/>
           </a:solidFill>
           <a:ln w="9525">
             <a:solidFill>
-              <a:srgbClr val="DDE2E7"/>
+              <a:srgbClr val="E2E8F0"/>
             </a:solidFill>
             <a:prstDash val="solid"/>
           </a:ln>
@@ -19026,7 +19311,7 @@
       </p:sp>
       <p:sp>
         <p:nvSpPr>
-          <p:cNvPr id="9" name="Text 6"/>
+          <p:cNvPr id="10" name="Text 7"/>
           <p:cNvSpPr txBox="1"/>
           <p:nvPr/>
         </p:nvSpPr>
@@ -19062,7 +19347,7 @@
       </p:sp>
       <p:sp>
         <p:nvSpPr>
-          <p:cNvPr id="10" name="chip Sankhuwasabha"/>
+          <p:cNvPr id="11" name="chip Sankhuwasabha"/>
           <p:cNvSpPr/>
           <p:nvPr/>
         </p:nvSpPr>
@@ -19073,15 +19358,15 @@
           </a:xfrm>
           <a:prstGeom prst="roundRect">
             <a:avLst>
-              <a:gd name="adj" fmla="val 10870"/>
+              <a:gd name="adj" fmla="val 26087"/>
             </a:avLst>
           </a:prstGeom>
           <a:solidFill>
-            <a:schemeClr val="bg2"/>
+            <a:schemeClr val="bg1"/>
           </a:solidFill>
           <a:ln w="9525">
             <a:solidFill>
-              <a:srgbClr val="DDE2E7"/>
+              <a:srgbClr val="E2E8F0"/>
             </a:solidFill>
             <a:prstDash val="solid"/>
           </a:ln>
@@ -19089,7 +19374,7 @@
       </p:sp>
       <p:sp>
         <p:nvSpPr>
-          <p:cNvPr id="11" name="Text 8"/>
+          <p:cNvPr id="12" name="Text 9"/>
           <p:cNvSpPr txBox="1"/>
           <p:nvPr/>
         </p:nvSpPr>
@@ -19125,7 +19410,7 @@
       </p:sp>
       <p:sp>
         <p:nvSpPr>
-          <p:cNvPr id="12" name="chip Ramechhap"/>
+          <p:cNvPr id="13" name="chip Ramechhap"/>
           <p:cNvSpPr/>
           <p:nvPr/>
         </p:nvSpPr>
@@ -19136,15 +19421,15 @@
           </a:xfrm>
           <a:prstGeom prst="roundRect">
             <a:avLst>
-              <a:gd name="adj" fmla="val 10870"/>
+              <a:gd name="adj" fmla="val 26087"/>
             </a:avLst>
           </a:prstGeom>
           <a:solidFill>
-            <a:schemeClr val="bg2"/>
+            <a:schemeClr val="bg1"/>
           </a:solidFill>
           <a:ln w="9525">
             <a:solidFill>
-              <a:srgbClr val="DDE2E7"/>
+              <a:srgbClr val="E2E8F0"/>
             </a:solidFill>
             <a:prstDash val="solid"/>
           </a:ln>
@@ -19152,7 +19437,7 @@
       </p:sp>
       <p:sp>
         <p:nvSpPr>
-          <p:cNvPr id="13" name="Text 10"/>
+          <p:cNvPr id="14" name="Text 11"/>
           <p:cNvSpPr txBox="1"/>
           <p:nvPr/>
         </p:nvSpPr>
@@ -19188,7 +19473,7 @@
       </p:sp>
       <p:sp>
         <p:nvSpPr>
-          <p:cNvPr id="14" name="chip Dhading"/>
+          <p:cNvPr id="15" name="chip Dhading"/>
           <p:cNvSpPr/>
           <p:nvPr/>
         </p:nvSpPr>
@@ -19199,15 +19484,15 @@
           </a:xfrm>
           <a:prstGeom prst="roundRect">
             <a:avLst>
-              <a:gd name="adj" fmla="val 10870"/>
+              <a:gd name="adj" fmla="val 26087"/>
             </a:avLst>
           </a:prstGeom>
           <a:solidFill>
-            <a:schemeClr val="bg2"/>
+            <a:schemeClr val="bg1"/>
           </a:solidFill>
           <a:ln w="9525">
             <a:solidFill>
-              <a:srgbClr val="DDE2E7"/>
+              <a:srgbClr val="E2E8F0"/>
             </a:solidFill>
             <a:prstDash val="solid"/>
           </a:ln>
@@ -19215,7 +19500,7 @@
       </p:sp>
       <p:sp>
         <p:nvSpPr>
-          <p:cNvPr id="15" name="Text 12"/>
+          <p:cNvPr id="16" name="Text 13"/>
           <p:cNvSpPr txBox="1"/>
           <p:nvPr/>
         </p:nvSpPr>
@@ -19251,7 +19536,7 @@
       </p:sp>
       <p:sp>
         <p:nvSpPr>
-          <p:cNvPr id="16" name="chip Mugu"/>
+          <p:cNvPr id="17" name="chip Mugu"/>
           <p:cNvSpPr/>
           <p:nvPr/>
         </p:nvSpPr>
@@ -19262,15 +19547,15 @@
           </a:xfrm>
           <a:prstGeom prst="roundRect">
             <a:avLst>
-              <a:gd name="adj" fmla="val 10870"/>
+              <a:gd name="adj" fmla="val 26087"/>
             </a:avLst>
           </a:prstGeom>
           <a:solidFill>
-            <a:schemeClr val="bg2"/>
+            <a:schemeClr val="bg1"/>
           </a:solidFill>
           <a:ln w="9525">
             <a:solidFill>
-              <a:srgbClr val="DDE2E7"/>
+              <a:srgbClr val="E2E8F0"/>
             </a:solidFill>
             <a:prstDash val="solid"/>
           </a:ln>
@@ -19278,7 +19563,7 @@
       </p:sp>
       <p:sp>
         <p:nvSpPr>
-          <p:cNvPr id="17" name="Text 14"/>
+          <p:cNvPr id="18" name="Text 15"/>
           <p:cNvSpPr txBox="1"/>
           <p:nvPr/>
         </p:nvSpPr>
@@ -19314,7 +19599,7 @@
       </p:sp>
       <p:sp>
         <p:nvSpPr>
-          <p:cNvPr id="18" name="chip Humla"/>
+          <p:cNvPr id="19" name="chip Humla"/>
           <p:cNvSpPr/>
           <p:nvPr/>
         </p:nvSpPr>
@@ -19325,15 +19610,15 @@
           </a:xfrm>
           <a:prstGeom prst="roundRect">
             <a:avLst>
-              <a:gd name="adj" fmla="val 10870"/>
+              <a:gd name="adj" fmla="val 26087"/>
             </a:avLst>
           </a:prstGeom>
           <a:solidFill>
-            <a:schemeClr val="bg2"/>
+            <a:schemeClr val="bg1"/>
           </a:solidFill>
           <a:ln w="9525">
             <a:solidFill>
-              <a:srgbClr val="DDE2E7"/>
+              <a:srgbClr val="E2E8F0"/>
             </a:solidFill>
             <a:prstDash val="solid"/>
           </a:ln>
@@ -19341,7 +19626,7 @@
       </p:sp>
       <p:sp>
         <p:nvSpPr>
-          <p:cNvPr id="19" name="Text 16"/>
+          <p:cNvPr id="20" name="Text 17"/>
           <p:cNvSpPr txBox="1"/>
           <p:nvPr/>
         </p:nvSpPr>
@@ -19377,7 +19662,7 @@
       </p:sp>
       <p:sp>
         <p:nvSpPr>
-          <p:cNvPr id="20" name="chip Rukum West"/>
+          <p:cNvPr id="21" name="chip Rukum West"/>
           <p:cNvSpPr/>
           <p:nvPr/>
         </p:nvSpPr>
@@ -19388,15 +19673,15 @@
           </a:xfrm>
           <a:prstGeom prst="roundRect">
             <a:avLst>
-              <a:gd name="adj" fmla="val 10870"/>
+              <a:gd name="adj" fmla="val 26087"/>
             </a:avLst>
           </a:prstGeom>
           <a:solidFill>
-            <a:schemeClr val="bg2"/>
+            <a:schemeClr val="bg1"/>
           </a:solidFill>
           <a:ln w="9525">
             <a:solidFill>
-              <a:srgbClr val="DDE2E7"/>
+              <a:srgbClr val="E2E8F0"/>
             </a:solidFill>
             <a:prstDash val="solid"/>
           </a:ln>
@@ -19404,7 +19689,7 @@
       </p:sp>
       <p:sp>
         <p:nvSpPr>
-          <p:cNvPr id="21" name="Text 18"/>
+          <p:cNvPr id="22" name="Text 19"/>
           <p:cNvSpPr txBox="1"/>
           <p:nvPr/>
         </p:nvSpPr>
@@ -19440,7 +19725,7 @@
       </p:sp>
       <p:sp>
         <p:nvSpPr>
-          <p:cNvPr id="22" name="chip Kalikot"/>
+          <p:cNvPr id="23" name="chip Kalikot"/>
           <p:cNvSpPr/>
           <p:nvPr/>
         </p:nvSpPr>
@@ -19451,15 +19736,15 @@
           </a:xfrm>
           <a:prstGeom prst="roundRect">
             <a:avLst>
-              <a:gd name="adj" fmla="val 10870"/>
+              <a:gd name="adj" fmla="val 26087"/>
             </a:avLst>
           </a:prstGeom>
           <a:solidFill>
-            <a:schemeClr val="bg2"/>
+            <a:schemeClr val="bg1"/>
           </a:solidFill>
           <a:ln w="9525">
             <a:solidFill>
-              <a:srgbClr val="DDE2E7"/>
+              <a:srgbClr val="E2E8F0"/>
             </a:solidFill>
             <a:prstDash val="solid"/>
           </a:ln>
@@ -19467,7 +19752,7 @@
       </p:sp>
       <p:sp>
         <p:nvSpPr>
-          <p:cNvPr id="23" name="Text 20"/>
+          <p:cNvPr id="24" name="Text 21"/>
           <p:cNvSpPr txBox="1"/>
           <p:nvPr/>
         </p:nvSpPr>
@@ -19503,7 +19788,7 @@
       </p:sp>
       <p:sp>
         <p:nvSpPr>
-          <p:cNvPr id="24" name="Text 21"/>
+          <p:cNvPr id="25" name="Text 22"/>
           <p:cNvSpPr txBox="1"/>
           <p:nvPr/>
         </p:nvSpPr>
@@ -19550,7 +19835,7 @@
       </p:sp>
       <p:sp>
         <p:nvSpPr>
-          <p:cNvPr id="25" name="Text 22"/>
+          <p:cNvPr id="26" name="Text 23"/>
           <p:cNvSpPr txBox="1"/>
           <p:nvPr/>
         </p:nvSpPr>
@@ -19575,7 +19860,7 @@
             <a:r>
               <a:rPr lang="en-US" sz="1100" i="1" dirty="0">
                 <a:solidFill>
-                  <a:srgbClr val="76838F"/>
+                  <a:srgbClr val="526579"/>
                 </a:solidFill>
               </a:rPr>
               <a:t>Ruggedness = spread of elevation within the district (supplied slope data is corrupted).</a:t>
@@ -19683,7 +19968,7 @@
             <a:r>
               <a:rPr lang="en-US" sz="1200" b="1" spc="200" kern="0" dirty="0">
                 <a:solidFill>
-                  <a:schemeClr val="accent4"/>
+                  <a:schemeClr val="accent2"/>
                 </a:solidFill>
               </a:rPr>
               <a:t>EXPOSURE AND VULNERABILITY</a:t>
@@ -19751,7 +20036,7 @@
           </a:solidFill>
           <a:ln w="9525">
             <a:solidFill>
-              <a:srgbClr val="C7D1DE"/>
+              <a:srgbClr val="9DBAD6"/>
             </a:solidFill>
             <a:prstDash val="solid"/>
           </a:ln>
@@ -19817,7 +20102,7 @@
           </a:solidFill>
           <a:ln w="9525">
             <a:solidFill>
-              <a:srgbClr val="C7D1DE"/>
+              <a:srgbClr val="9DBAD6"/>
             </a:solidFill>
             <a:prstDash val="solid"/>
           </a:ln>
@@ -19862,9 +20147,36 @@
           </a:p>
         </p:txBody>
       </p:sp>
+      <p:sp>
+        <p:nvSpPr>
+          <p:cNvPr id="8" name="chart panel"/>
+          <p:cNvSpPr/>
+          <p:nvPr/>
+        </p:nvSpPr>
+        <p:spPr>
+          <a:xfrm>
+            <a:off x="438912" y="1536192"/>
+            <a:ext cx="5568696" cy="4151376"/>
+          </a:xfrm>
+          <a:prstGeom prst="roundRect">
+            <a:avLst>
+              <a:gd name="adj" fmla="val 2643"/>
+            </a:avLst>
+          </a:prstGeom>
+          <a:solidFill>
+            <a:schemeClr val="bg1"/>
+          </a:solidFill>
+          <a:ln w="9525">
+            <a:solidFill>
+              <a:srgbClr val="E2E8F0"/>
+            </a:solidFill>
+            <a:prstDash val="solid"/>
+          </a:ln>
+        </p:spPr>
+      </p:sp>
       <p:graphicFrame>
         <p:nvGraphicFramePr>
-          <p:cNvPr id="8" name="Chart 0" descr=""/>
+          <p:cNvPr id="9" name="Chart 0" descr=""/>
           <p:cNvGraphicFramePr/>
           <p:nvPr/>
         </p:nvGraphicFramePr>
@@ -19878,9 +20190,36 @@
           </a:graphicData>
         </a:graphic>
       </p:graphicFrame>
+      <p:sp>
+        <p:nvSpPr>
+          <p:cNvPr id="10" name="chart panel"/>
+          <p:cNvSpPr/>
+          <p:nvPr/>
+        </p:nvSpPr>
+        <p:spPr>
+          <a:xfrm>
+            <a:off x="6181344" y="1536192"/>
+            <a:ext cx="5568696" cy="4151376"/>
+          </a:xfrm>
+          <a:prstGeom prst="roundRect">
+            <a:avLst>
+              <a:gd name="adj" fmla="val 2643"/>
+            </a:avLst>
+          </a:prstGeom>
+          <a:solidFill>
+            <a:schemeClr val="bg1"/>
+          </a:solidFill>
+          <a:ln w="9525">
+            <a:solidFill>
+              <a:srgbClr val="E2E8F0"/>
+            </a:solidFill>
+            <a:prstDash val="solid"/>
+          </a:ln>
+        </p:spPr>
+      </p:sp>
       <p:graphicFrame>
         <p:nvGraphicFramePr>
-          <p:cNvPr id="9" name="Chart 1" descr=""/>
+          <p:cNvPr id="11" name="Chart 1" descr=""/>
           <p:cNvGraphicFramePr/>
           <p:nvPr/>
         </p:nvGraphicFramePr>
@@ -19896,7 +20235,7 @@
       </p:graphicFrame>
       <p:sp>
         <p:nvSpPr>
-          <p:cNvPr id="10" name="Text 6"/>
+          <p:cNvPr id="12" name="Text 8"/>
           <p:cNvSpPr txBox="1"/>
           <p:nvPr/>
         </p:nvSpPr>
@@ -19932,7 +20271,7 @@
       </p:sp>
       <p:sp>
         <p:nvSpPr>
-          <p:cNvPr id="11" name="Text 7"/>
+          <p:cNvPr id="13" name="Text 9"/>
           <p:cNvSpPr txBox="1"/>
           <p:nvPr/>
         </p:nvSpPr>
@@ -20065,7 +20404,7 @@
             <a:r>
               <a:rPr lang="en-US" sz="1200" b="1" spc="200" kern="0" dirty="0">
                 <a:solidFill>
-                  <a:schemeClr val="accent4"/>
+                  <a:schemeClr val="accent2"/>
                 </a:solidFill>
               </a:rPr>
               <a:t>THE RISK INDEX</a:t>
@@ -20125,13 +20464,18 @@
           </a:xfrm>
           <a:prstGeom prst="roundRect">
             <a:avLst>
-              <a:gd name="adj" fmla="val 2381"/>
+              <a:gd name="adj" fmla="val 5714"/>
             </a:avLst>
           </a:prstGeom>
           <a:solidFill>
-            <a:schemeClr val="accent3"/>
+            <a:schemeClr val="bg1"/>
           </a:solidFill>
-          <a:ln/>
+          <a:ln w="9525">
+            <a:solidFill>
+              <a:srgbClr val="E2E8F0"/>
+            </a:solidFill>
+            <a:prstDash val="solid"/>
+          </a:ln>
         </p:spPr>
       </p:sp>
       <p:sp>
@@ -20161,7 +20505,7 @@
             <a:r>
               <a:rPr lang="en-US" sz="1600" b="1" spc="100" kern="0" dirty="0">
                 <a:solidFill>
-                  <a:schemeClr val="bg1"/>
+                  <a:srgbClr val="B84A00"/>
                 </a:solidFill>
               </a:rPr>
               <a:t>HAZARD</a:t>
@@ -20197,7 +20541,7 @@
             <a:r>
               <a:rPr lang="en-US" sz="1400" dirty="0">
                 <a:solidFill>
-                  <a:schemeClr val="bg1"/>
+                  <a:schemeClr val="tx1"/>
                 </a:solidFill>
               </a:rPr>
               <a:t>Flood: rain + rivers</a:t>
@@ -20211,7 +20555,7 @@
             <a:r>
               <a:rPr lang="en-US" sz="1400" dirty="0">
                 <a:solidFill>
-                  <a:schemeClr val="bg1"/>
+                  <a:schemeClr val="tx1"/>
                 </a:solidFill>
               </a:rPr>
               <a:t>Landslide: rain + terrain</a:t>
@@ -20269,13 +20613,18 @@
           </a:xfrm>
           <a:prstGeom prst="roundRect">
             <a:avLst>
-              <a:gd name="adj" fmla="val 2381"/>
+              <a:gd name="adj" fmla="val 5714"/>
             </a:avLst>
           </a:prstGeom>
           <a:solidFill>
-            <a:schemeClr val="accent2"/>
+            <a:schemeClr val="bg1"/>
           </a:solidFill>
-          <a:ln/>
+          <a:ln w="9525">
+            <a:solidFill>
+              <a:srgbClr val="E2E8F0"/>
+            </a:solidFill>
+            <a:prstDash val="solid"/>
+          </a:ln>
         </p:spPr>
       </p:sp>
       <p:sp>
@@ -20305,7 +20654,7 @@
             <a:r>
               <a:rPr lang="en-US" sz="1600" b="1" spc="100" kern="0" dirty="0">
                 <a:solidFill>
-                  <a:schemeClr val="bg1"/>
+                  <a:schemeClr val="accent2"/>
                 </a:solidFill>
               </a:rPr>
               <a:t>EXPOSURE</a:t>
@@ -20341,7 +20690,7 @@
             <a:r>
               <a:rPr lang="en-US" sz="1400" dirty="0">
                 <a:solidFill>
-                  <a:schemeClr val="bg1"/>
+                  <a:schemeClr val="tx1"/>
                 </a:solidFill>
               </a:rPr>
               <a:t>People, density, hydropower, hospitals, schools</a:t>
@@ -20399,13 +20748,18 @@
           </a:xfrm>
           <a:prstGeom prst="roundRect">
             <a:avLst>
-              <a:gd name="adj" fmla="val 2381"/>
+              <a:gd name="adj" fmla="val 5714"/>
             </a:avLst>
           </a:prstGeom>
           <a:solidFill>
-            <a:schemeClr val="accent4"/>
+            <a:schemeClr val="bg1"/>
           </a:solidFill>
-          <a:ln/>
+          <a:ln w="9525">
+            <a:solidFill>
+              <a:srgbClr val="E2E8F0"/>
+            </a:solidFill>
+            <a:prstDash val="solid"/>
+          </a:ln>
         </p:spPr>
       </p:sp>
       <p:sp>
@@ -20435,7 +20789,7 @@
             <a:r>
               <a:rPr lang="en-US" sz="1600" b="1" spc="100" kern="0" dirty="0">
                 <a:solidFill>
-                  <a:schemeClr val="bg1"/>
+                  <a:schemeClr val="accent1"/>
                 </a:solidFill>
               </a:rPr>
               <a:t>VULNERABILITY</a:t>
@@ -20471,7 +20825,7 @@
             <a:r>
               <a:rPr lang="en-US" sz="1400" dirty="0">
                 <a:solidFill>
-                  <a:schemeClr val="bg1"/>
+                  <a:schemeClr val="tx1"/>
                 </a:solidFill>
               </a:rPr>
               <a:t>Road access and people per hospital</a:t>
@@ -20529,7 +20883,7 @@
           </a:xfrm>
           <a:prstGeom prst="roundRect">
             <a:avLst>
-              <a:gd name="adj" fmla="val 2381"/>
+              <a:gd name="adj" fmla="val 5714"/>
             </a:avLst>
           </a:prstGeom>
           <a:solidFill>
@@ -20565,7 +20919,7 @@
             <a:r>
               <a:rPr lang="en-US" sz="1600" b="1" spc="100" kern="0" dirty="0">
                 <a:solidFill>
-                  <a:schemeClr val="accent6"/>
+                  <a:srgbClr val="A9BCD0"/>
                 </a:solidFill>
               </a:rPr>
               <a:t>RISK</a:t>
@@ -20623,15 +20977,15 @@
           </a:xfrm>
           <a:prstGeom prst="roundRect">
             <a:avLst>
-              <a:gd name="adj" fmla="val 2128"/>
+              <a:gd name="adj" fmla="val 5106"/>
             </a:avLst>
           </a:prstGeom>
           <a:solidFill>
-            <a:schemeClr val="bg2"/>
+            <a:schemeClr val="bg1"/>
           </a:solidFill>
           <a:ln w="9525">
             <a:solidFill>
-              <a:srgbClr val="DDE2E7"/>
+              <a:srgbClr val="E2E8F0"/>
             </a:solidFill>
             <a:prstDash val="solid"/>
           </a:ln>
@@ -20639,7 +20993,7 @@
       </p:sp>
       <p:sp>
         <p:nvSpPr>
-          <p:cNvPr id="20" name="Log scaling circle"/>
+          <p:cNvPr id="20" name="Log scaling tile"/>
           <p:cNvSpPr/>
           <p:nvPr/>
         </p:nvSpPr>
@@ -20648,11 +21002,13 @@
             <a:off x="777240" y="4206240"/>
             <a:ext cx="548640" cy="548640"/>
           </a:xfrm>
-          <a:prstGeom prst="ellipse">
-            <a:avLst/>
+          <a:prstGeom prst="roundRect">
+            <a:avLst>
+              <a:gd name="adj" fmla="val 22000"/>
+            </a:avLst>
           </a:prstGeom>
           <a:solidFill>
-            <a:schemeClr val="accent4"/>
+            <a:srgbClr val="E6F1F8"/>
           </a:solidFill>
           <a:ln/>
         </p:spPr>
@@ -20673,8 +21029,8 @@
         </p:blipFill>
         <p:spPr>
           <a:xfrm>
-            <a:off x="925373" y="4354373"/>
-            <a:ext cx="252374" cy="252374"/>
+            <a:off x="914400" y="4343400"/>
+            <a:ext cx="274320" cy="274320"/>
           </a:xfrm>
           <a:prstGeom prst="rect">
             <a:avLst/>
@@ -20766,15 +21122,15 @@
           </a:xfrm>
           <a:prstGeom prst="roundRect">
             <a:avLst>
-              <a:gd name="adj" fmla="val 2128"/>
+              <a:gd name="adj" fmla="val 5106"/>
             </a:avLst>
           </a:prstGeom>
           <a:solidFill>
-            <a:schemeClr val="bg2"/>
+            <a:schemeClr val="bg1"/>
           </a:solidFill>
           <a:ln w="9525">
             <a:solidFill>
-              <a:srgbClr val="DDE2E7"/>
+              <a:srgbClr val="E2E8F0"/>
             </a:solidFill>
             <a:prstDash val="solid"/>
           </a:ln>
@@ -20782,7 +21138,7 @@
       </p:sp>
       <p:sp>
         <p:nvSpPr>
-          <p:cNvPr id="25" name="Weights tested circle"/>
+          <p:cNvPr id="25" name="Weights tested tile"/>
           <p:cNvSpPr/>
           <p:nvPr/>
         </p:nvSpPr>
@@ -20791,11 +21147,13 @@
             <a:off x="4590288" y="4206240"/>
             <a:ext cx="548640" cy="548640"/>
           </a:xfrm>
-          <a:prstGeom prst="ellipse">
-            <a:avLst/>
+          <a:prstGeom prst="roundRect">
+            <a:avLst>
+              <a:gd name="adj" fmla="val 22000"/>
+            </a:avLst>
           </a:prstGeom>
           <a:solidFill>
-            <a:schemeClr val="accent4"/>
+            <a:srgbClr val="E6F1F8"/>
           </a:solidFill>
           <a:ln/>
         </p:spPr>
@@ -20816,8 +21174,8 @@
         </p:blipFill>
         <p:spPr>
           <a:xfrm>
-            <a:off x="4738421" y="4354373"/>
-            <a:ext cx="252374" cy="252374"/>
+            <a:off x="4727448" y="4343400"/>
+            <a:ext cx="274320" cy="274320"/>
           </a:xfrm>
           <a:prstGeom prst="rect">
             <a:avLst/>
@@ -20909,15 +21267,15 @@
           </a:xfrm>
           <a:prstGeom prst="roundRect">
             <a:avLst>
-              <a:gd name="adj" fmla="val 2128"/>
+              <a:gd name="adj" fmla="val 5106"/>
             </a:avLst>
           </a:prstGeom>
           <a:solidFill>
-            <a:schemeClr val="bg2"/>
+            <a:schemeClr val="bg1"/>
           </a:solidFill>
           <a:ln w="9525">
             <a:solidFill>
-              <a:srgbClr val="DDE2E7"/>
+              <a:srgbClr val="E2E8F0"/>
             </a:solidFill>
             <a:prstDash val="solid"/>
           </a:ln>
@@ -20925,7 +21283,7 @@
       </p:sp>
       <p:sp>
         <p:nvSpPr>
-          <p:cNvPr id="30" name="Multiply, don't add circle"/>
+          <p:cNvPr id="30" name="Multiply, don't add tile"/>
           <p:cNvSpPr/>
           <p:nvPr/>
         </p:nvSpPr>
@@ -20934,11 +21292,13 @@
             <a:off x="8403336" y="4206240"/>
             <a:ext cx="548640" cy="548640"/>
           </a:xfrm>
-          <a:prstGeom prst="ellipse">
-            <a:avLst/>
+          <a:prstGeom prst="roundRect">
+            <a:avLst>
+              <a:gd name="adj" fmla="val 22000"/>
+            </a:avLst>
           </a:prstGeom>
           <a:solidFill>
-            <a:schemeClr val="accent4"/>
+            <a:srgbClr val="E6F1F8"/>
           </a:solidFill>
           <a:ln/>
         </p:spPr>
@@ -20959,8 +21319,8 @@
         </p:blipFill>
         <p:spPr>
           <a:xfrm>
-            <a:off x="8551469" y="4354373"/>
-            <a:ext cx="252374" cy="252374"/>
+            <a:off x="8540496" y="4343400"/>
+            <a:ext cx="274320" cy="274320"/>
           </a:xfrm>
           <a:prstGeom prst="rect">
             <a:avLst/>
@@ -21093,47 +21453,47 @@
 </file>
 
 <file path=ppt/theme/theme1.xml><?xml version="1.0" encoding="utf-8"?>
-<a:theme xmlns:a="http://schemas.openxmlformats.org/drawingml/2006/main" name="Himalaya Risk">
+<a:theme xmlns:a="http://schemas.openxmlformats.org/drawingml/2006/main" name="Nepal Climate Risk Intelligence">
   <a:themeElements>
-    <a:clrScheme name="Himalaya Risk">
+    <a:clrScheme name="Nepal Climate Risk Intelligence">
       <a:dk1>
-        <a:srgbClr val="14202B"/>
+        <a:srgbClr val="334155"/>
       </a:dk1>
       <a:lt1>
         <a:srgbClr val="FFFFFF"/>
       </a:lt1>
       <a:dk2>
-        <a:srgbClr val="1F3A5F"/>
+        <a:srgbClr val="112B49"/>
       </a:dk2>
       <a:lt2>
-        <a:srgbClr val="F5F7F9"/>
+        <a:srgbClr val="F4F7FB"/>
       </a:lt2>
       <a:accent1>
-        <a:srgbClr val="1F3A5F"/>
+        <a:srgbClr val="195B96"/>
       </a:accent1>
       <a:accent2>
-        <a:srgbClr val="3B5BA9"/>
+        <a:srgbClr val="0072B2"/>
       </a:accent2>
       <a:accent3>
-        <a:srgbClr val="B8243B"/>
+        <a:srgbClr val="D55E00"/>
       </a:accent3>
       <a:accent4>
-        <a:srgbClr val="76838F"/>
+        <a:srgbClr val="526579"/>
       </a:accent4>
       <a:accent5>
-        <a:srgbClr val="2462A3"/>
+        <a:srgbClr val="009E73"/>
       </a:accent5>
       <a:accent6>
-        <a:srgbClr val="C9D1D9"/>
+        <a:srgbClr val="76879A"/>
       </a:accent6>
       <a:hlink>
-        <a:srgbClr val="2F4FA0"/>
+        <a:srgbClr val="0072B2"/>
       </a:hlink>
       <a:folHlink>
-        <a:srgbClr val="76838F"/>
+        <a:srgbClr val="526579"/>
       </a:folHlink>
     </a:clrScheme>
-    <a:fontScheme name="Himalaya Risk">
+    <a:fontScheme name="Nepal Climate Risk Intelligence">
       <a:majorFont>
         <a:latin typeface="Calibri"/>
         <a:ea typeface=""/>

</xml_diff>

<commit_message>
Add presenter name and live app link to the deck
</commit_message>
<xml_diff>
--- a/Nepal_Climate_Risk_Deck.pptx
+++ b/Nepal_Climate_Risk_Deck.pptx
@@ -124,7 +124,7 @@
   <p:extLst>
     <p:ext uri="{521415D9-36F7-43E2-AB2F-B90AF26B5E84}">
       <p14:sectionLst xmlns:p14="http://schemas.microsoft.com/office/powerpoint/2010/main">
-        <p14:section name="Introduction" id="{d6230e0d-702e-eafe-8eb6-9a2287367ee6}">
+        <p14:section name="Introduction" id="{f593a506-30d7-31a9-1fdd-c47bb65cf984}">
           <p14:sldIdLst>
             <p14:sldId id="256"/>
             <p14:sldId id="257"/>
@@ -132,25 +132,25 @@
             <p14:sldId id="259"/>
           </p14:sldIdLst>
         </p14:section>
-        <p14:section name="Climate" id="{04d85eee-8ca6-6c30-de3f-dc9846ffd03b}">
+        <p14:section name="Climate" id="{7e5aa4fd-f2be-187b-bdd4-973379a41d9c}">
           <p14:sldIdLst>
             <p14:sldId id="260"/>
             <p14:sldId id="261"/>
           </p14:sldIdLst>
         </p14:section>
-        <p14:section name="Terrain and exposure" id="{94fa56bb-631b-7615-3fd4-36469c266cac}">
+        <p14:section name="Terrain and exposure" id="{14b742f9-241e-ca18-a82c-afd1c1412a4a}">
           <p14:sldIdLst>
             <p14:sldId id="262"/>
             <p14:sldId id="263"/>
           </p14:sldIdLst>
         </p14:section>
-        <p14:section name="Risk index" id="{81500c9f-35aa-149b-98bc-a4db1ee677f5}">
+        <p14:section name="Risk index" id="{2dc5b69b-b6b9-1b06-29b6-d053c1145674}">
           <p14:sldIdLst>
             <p14:sldId id="264"/>
             <p14:sldId id="265"/>
           </p14:sldIdLst>
         </p14:section>
-        <p14:section name="Validation" id="{7d27a51a-8c20-919c-14e2-5524b33577cb}">
+        <p14:section name="Validation" id="{3dd7a71b-9fd6-1ac3-18f2-c7bb44935b53}">
           <p14:sldIdLst>
             <p14:sldId id="266"/>
             <p14:sldId id="267"/>
@@ -158,14 +158,14 @@
             <p14:sldId id="269"/>
           </p14:sldIdLst>
         </p14:section>
-        <p14:section name="Recommendation" id="{1208bc22-975b-863b-f7f4-21a2d6b3fbcf}">
+        <p14:section name="Recommendation" id="{ce7126bc-31e7-c51c-4b27-708426ead4a3}">
           <p14:sldIdLst>
             <p14:sldId id="270"/>
             <p14:sldId id="271"/>
             <p14:sldId id="272"/>
           </p14:sldIdLst>
         </p14:section>
-        <p14:section name="Appendix" id="{5709a503-7b9f-424e-0c90-39755ce716ad}">
+        <p14:section name="Appendix" id="{af1268aa-1ee9-bdcb-94f6-ae0c9a7f7944}">
           <p14:sldIdLst>
             <p14:sldId id="273"/>
           </p14:sldIdLst>
@@ -5084,7 +5084,7 @@
           <a:p>
             <a:r>
               <a:rPr lang="en-US" dirty="0"/>
-              <a:t>Good morning. This assessment answers one practical question: if a donor has 100 million dollars to make Nepal more resilient to climate disasters, where should it go and why? We look at all 77 districts, we test our answer against 15 years of real disaster records, and we end with a recommendation where every dollar is tied to evidence.</a:t>
+              <a:t>Good morning. My name is Kingsley Chigozie, and I carried out this analysis. This assessment answers one practical question: if a donor has 100 million dollars to make Nepal more resilient to climate disasters, where should it go and why? We look at all 77 districts, we test our answer against 15 years of real disaster records, and we end with a recommendation where every dollar is tied to evidence.</a:t>
             </a:r>
             <a:endParaRPr lang="en-US" dirty="0"/>
           </a:p>
@@ -6726,7 +6726,7 @@
         <p:spPr>
           <a:xfrm>
             <a:off x="548640" y="1828800"/>
-            <a:ext cx="7680960" cy="1143000"/>
+            <a:ext cx="10058400" cy="1143000"/>
           </a:xfrm>
           <a:prstGeom prst="rect">
             <a:avLst/>
@@ -6933,7 +6933,7 @@
                   <a:schemeClr val="accent4"/>
                 </a:solidFill>
               </a:rPr>
-              <a:t>Nepal Climate Risk and Resilience Assessment</a:t>
+              <a:t>Nepal Climate Risk and Resilience Assessment  ·  Kingsley Chigozie</a:t>
             </a:r>
             <a:endParaRPr lang="en-US" sz="1000" dirty="0"/>
           </a:p>
@@ -7493,7 +7493,7 @@
         <p:spPr>
           <a:xfrm>
             <a:off x="548640" y="1828800"/>
-            <a:ext cx="7680960" cy="1143000"/>
+            <a:ext cx="10058400" cy="1143000"/>
           </a:xfrm>
           <a:prstGeom prst="rect">
             <a:avLst/>
@@ -7661,6 +7661,132 @@
               <a:t>NEPAL CLIMATE RISK  ·  INTELLIGENCE PLATFORM</a:t>
             </a:r>
             <a:endParaRPr lang="en-US" sz="1200" dirty="0"/>
+          </a:p>
+        </p:txBody>
+      </p:sp>
+      <p:sp>
+        <p:nvSpPr>
+          <p:cNvPr id="9" name="Text 5"/>
+          <p:cNvSpPr txBox="1"/>
+          <p:nvPr/>
+        </p:nvSpPr>
+        <p:spPr>
+          <a:xfrm>
+            <a:off x="548640" y="4572000"/>
+            <a:ext cx="5029200" cy="274320"/>
+          </a:xfrm>
+          <a:prstGeom prst="rect">
+            <a:avLst/>
+          </a:prstGeom>
+          <a:noFill/>
+          <a:ln/>
+        </p:spPr>
+        <p:txBody>
+          <a:bodyPr wrap="square" lIns="0" tIns="0" rIns="0" bIns="0" rtlCol="0" anchor="t"/>
+          <a:lstStyle/>
+          <a:p>
+            <a:pPr indent="0" marL="0">
+              <a:buNone/>
+            </a:pPr>
+            <a:r>
+              <a:rPr lang="en-US" sz="1100" b="1" spc="200" kern="0" dirty="0">
+                <a:solidFill>
+                  <a:srgbClr val="A9BCD0"/>
+                </a:solidFill>
+              </a:rPr>
+              <a:t>PRESENTER / ANALYST</a:t>
+            </a:r>
+            <a:endParaRPr lang="en-US" sz="1100" dirty="0"/>
+          </a:p>
+        </p:txBody>
+      </p:sp>
+      <p:sp>
+        <p:nvSpPr>
+          <p:cNvPr id="10" name="Text 6"/>
+          <p:cNvSpPr txBox="1"/>
+          <p:nvPr/>
+        </p:nvSpPr>
+        <p:spPr>
+          <a:xfrm>
+            <a:off x="548640" y="4846320"/>
+            <a:ext cx="5029200" cy="457200"/>
+          </a:xfrm>
+          <a:prstGeom prst="rect">
+            <a:avLst/>
+          </a:prstGeom>
+          <a:noFill/>
+          <a:ln/>
+        </p:spPr>
+        <p:txBody>
+          <a:bodyPr wrap="square" lIns="0" tIns="0" rIns="0" bIns="0" rtlCol="0" anchor="t"/>
+          <a:lstStyle/>
+          <a:p>
+            <a:pPr indent="0" marL="0">
+              <a:buNone/>
+            </a:pPr>
+            <a:r>
+              <a:rPr lang="en-US" sz="2200" b="1" dirty="0">
+                <a:solidFill>
+                  <a:schemeClr val="bg1"/>
+                </a:solidFill>
+              </a:rPr>
+              <a:t>Kingsley Chigozie</a:t>
+            </a:r>
+            <a:endParaRPr lang="en-US" sz="2200" dirty="0"/>
+          </a:p>
+        </p:txBody>
+      </p:sp>
+      <p:sp>
+        <p:nvSpPr>
+          <p:cNvPr id="11" name="Text 7"/>
+          <p:cNvSpPr txBox="1"/>
+          <p:nvPr/>
+        </p:nvSpPr>
+        <p:spPr>
+          <a:xfrm>
+            <a:off x="548640" y="5440680"/>
+            <a:ext cx="5029200" cy="365760"/>
+          </a:xfrm>
+          <a:prstGeom prst="rect">
+            <a:avLst/>
+          </a:prstGeom>
+          <a:noFill/>
+          <a:ln/>
+        </p:spPr>
+        <p:txBody>
+          <a:bodyPr wrap="square" lIns="0" tIns="0" rIns="0" bIns="0" rtlCol="0" anchor="t"/>
+          <a:lstStyle/>
+          <a:p>
+            <a:pPr indent="0" marL="0">
+              <a:buNone/>
+            </a:pPr>
+            <a:r>
+              <a:rPr lang="en-US" sz="1500" dirty="0">
+                <a:solidFill>
+                  <a:srgbClr val="A9BCD0"/>
+                </a:solidFill>
+              </a:rPr>
+              <a:t>Live app:  </a:t>
+            </a:r>
+            <a:pPr indent="0" marL="0">
+              <a:buNone/>
+            </a:pPr>
+            <a:r>
+              <a:rPr lang="en-US" sz="1500" b="1" u="sng" dirty="0">
+                <a:solidFill>
+                  <a:srgbClr val="56B4E9"/>
+                </a:solidFill>
+                <a:hlinkClick r:id="rId3" invalidUrl="" action="" tgtFrame="" tooltip="Open the live Nepal Climate Risk app" history="1" highlightClick="0" endSnd="0">
+                  <a:extLst>
+                    <a:ext uri="{A12FA001-AC4F-418D-AE19-62706E023703}">
+                      <ahyp:hlinkClr xmlns:ahyp="http://schemas.microsoft.com/office/drawing/2018/hyperlinkcolor" val="tx"/>
+                    </a:ext>
+                  </a:extLst>
+                </a:hlinkClick>
+              </a:rPr>
+              <a:t>nepal-climate-risk.streamlit.app</a:t>
+            </a:r>
+            <a:endParaRPr lang="en-US" sz="1500" dirty="0"/>
           </a:p>
         </p:txBody>
       </p:sp>
@@ -14691,8 +14817,8 @@
         </p:nvSpPr>
         <p:spPr>
           <a:xfrm>
-            <a:off x="548640" y="6217920"/>
-            <a:ext cx="11094415" cy="274320"/>
+            <a:off x="548640" y="6126480"/>
+            <a:ext cx="11094415" cy="365760"/>
           </a:xfrm>
           <a:prstGeom prst="rect">
             <a:avLst/>
@@ -14708,14 +14834,43 @@
               <a:buNone/>
             </a:pPr>
             <a:r>
-              <a:rPr lang="en-US" sz="1100" dirty="0">
+              <a:rPr lang="en-US" sz="1300" dirty="0">
                 <a:solidFill>
                   <a:srgbClr val="A9BCD0"/>
                 </a:solidFill>
               </a:rPr>
-              <a:t>Full method, code and assumptions: nepal_risk_assessment.ipynb</a:t>
-            </a:r>
-            <a:endParaRPr lang="en-US" sz="1100" dirty="0"/>
+              <a:t>Explore the live app:  </a:t>
+            </a:r>
+            <a:pPr indent="0" marL="0">
+              <a:buNone/>
+            </a:pPr>
+            <a:r>
+              <a:rPr lang="en-US" sz="1300" b="1" u="sng" dirty="0">
+                <a:solidFill>
+                  <a:srgbClr val="56B4E9"/>
+                </a:solidFill>
+                <a:hlinkClick r:id="rId1" invalidUrl="" action="" tgtFrame="" tooltip="Open the live Nepal Climate Risk app" history="1" highlightClick="0" endSnd="0">
+                  <a:extLst>
+                    <a:ext uri="{A12FA001-AC4F-418D-AE19-62706E023703}">
+                      <ahyp:hlinkClr xmlns:ahyp="http://schemas.microsoft.com/office/drawing/2018/hyperlinkcolor" val="tx"/>
+                    </a:ext>
+                  </a:extLst>
+                </a:hlinkClick>
+              </a:rPr>
+              <a:t>nepal-climate-risk.streamlit.app</a:t>
+            </a:r>
+            <a:pPr indent="0" marL="0">
+              <a:buNone/>
+            </a:pPr>
+            <a:r>
+              <a:rPr lang="en-US" sz="1300" dirty="0">
+                <a:solidFill>
+                  <a:srgbClr val="A9BCD0"/>
+                </a:solidFill>
+              </a:rPr>
+              <a:t>     ·     Kingsley Chigozie, Analyst     ·     Full method and code: nepal_risk_assessment.ipynb</a:t>
+            </a:r>
+            <a:endParaRPr lang="en-US" sz="1300" dirty="0"/>
           </a:p>
         </p:txBody>
       </p:sp>
@@ -21487,10 +21642,10 @@
         <a:srgbClr val="76879A"/>
       </a:accent6>
       <a:hlink>
-        <a:srgbClr val="0072B2"/>
+        <a:srgbClr val="56B4E9"/>
       </a:hlink>
       <a:folHlink>
-        <a:srgbClr val="526579"/>
+        <a:srgbClr val="A9BCD0"/>
       </a:folHlink>
     </a:clrScheme>
     <a:fontScheme name="Nepal Climate Risk Intelligence">

</xml_diff>